<commit_message>
Slides polish based on review feedback
- Fonts: Cambria/Calibri -> Helvetica Neue everywhere for clarity.
- Title slide byline now "Jerry Zeng · Yuxin Liu" (teammate added).
- Top-right header tag shows just the section name ("Goals",
  "System", "Results", "Live Demo", "Future Work",
  "Justification") instead of "Rubric: N pts (…)".
- Removed "VoiceGuard · N / 13" footer from every slide.
- Q&A slide: removed the anticipated-questions hint line;
  just "Q&A" + "Thanks for listening." now.
- Demo slide renamed "Live Demo — Attack → Shield" and its
  top-right tag reads "Live Demo" for easier audience wayfinding.

Co-Authored-By: Claude Opus 4.7 (1M context) <noreply@anthropic.com>
</commit_message>
<xml_diff>
--- a/slides/VoiceGuard - Final Presentation.pptx
+++ b/slides/VoiceGuard - Final Presentation.pptx
@@ -1997,9 +1997,9 @@
                 <a:solidFill>
                   <a:srgbClr val="CADCFC"/>
                 </a:solidFill>
-                <a:latin typeface="Calibri" pitchFamily="34" charset="0"/>
-                <a:ea typeface="Calibri" pitchFamily="34" charset="-122"/>
-                <a:cs typeface="Calibri" pitchFamily="34" charset="-120"/>
+                <a:latin typeface="Helvetica Neue" pitchFamily="34" charset="0"/>
+                <a:ea typeface="Helvetica Neue" pitchFamily="34" charset="-122"/>
+                <a:cs typeface="Helvetica Neue" pitchFamily="34" charset="-120"/>
               </a:rPr>
               <a:t>14-795  ·  FINAL PRESENTATION  ·  APR 2026</a:t>
             </a:r>
@@ -2036,9 +2036,9 @@
                 <a:solidFill>
                   <a:srgbClr val="FFFFFF"/>
                 </a:solidFill>
-                <a:latin typeface="Cambria" pitchFamily="34" charset="0"/>
-                <a:ea typeface="Cambria" pitchFamily="34" charset="-122"/>
-                <a:cs typeface="Cambria" pitchFamily="34" charset="-120"/>
+                <a:latin typeface="Helvetica Neue" pitchFamily="34" charset="0"/>
+                <a:ea typeface="Helvetica Neue" pitchFamily="34" charset="-122"/>
+                <a:cs typeface="Helvetica Neue" pitchFamily="34" charset="-120"/>
               </a:rPr>
               <a:t>VoiceGuard</a:t>
             </a:r>
@@ -2075,9 +2075,9 @@
                 <a:solidFill>
                   <a:srgbClr val="CADCFC"/>
                 </a:solidFill>
-                <a:latin typeface="Cambria" pitchFamily="34" charset="0"/>
-                <a:ea typeface="Cambria" pitchFamily="34" charset="-122"/>
-                <a:cs typeface="Cambria" pitchFamily="34" charset="-120"/>
+                <a:latin typeface="Helvetica Neue" pitchFamily="34" charset="0"/>
+                <a:ea typeface="Helvetica Neue" pitchFamily="34" charset="-122"/>
+                <a:cs typeface="Helvetica Neue" pitchFamily="34" charset="-120"/>
               </a:rPr>
               <a:t>Voice-Cloning Attack &amp; Detection</a:t>
             </a:r>
@@ -2114,9 +2114,9 @@
                 <a:solidFill>
                   <a:srgbClr val="FFFFFF"/>
                 </a:solidFill>
-                <a:latin typeface="Calibri" pitchFamily="34" charset="0"/>
-                <a:ea typeface="Calibri" pitchFamily="34" charset="-122"/>
-                <a:cs typeface="Calibri" pitchFamily="34" charset="-120"/>
+                <a:latin typeface="Helvetica Neue" pitchFamily="34" charset="0"/>
+                <a:ea typeface="Helvetica Neue" pitchFamily="34" charset="-122"/>
+                <a:cs typeface="Helvetica Neue" pitchFamily="34" charset="-120"/>
               </a:rPr>
               <a:t>Jerry Zeng</a:t>
             </a:r>
@@ -2128,11 +2128,25 @@
                 <a:solidFill>
                   <a:srgbClr val="CADCFC"/>
                 </a:solidFill>
-                <a:latin typeface="Calibri" pitchFamily="34" charset="0"/>
-                <a:ea typeface="Calibri" pitchFamily="34" charset="-122"/>
-                <a:cs typeface="Calibri" pitchFamily="34" charset="-120"/>
-              </a:rPr>
-              <a:t>  +  teammate</a:t>
+                <a:latin typeface="Helvetica Neue" pitchFamily="34" charset="0"/>
+                <a:ea typeface="Helvetica Neue" pitchFamily="34" charset="-122"/>
+                <a:cs typeface="Helvetica Neue" pitchFamily="34" charset="-120"/>
+              </a:rPr>
+              <a:t>   ·   </a:t>
+            </a:r>
+            <a:pPr indent="0" marL="0">
+              <a:buNone/>
+            </a:pPr>
+            <a:r>
+              <a:rPr lang="en-US" sz="1800" b="1" dirty="0">
+                <a:solidFill>
+                  <a:srgbClr val="FFFFFF"/>
+                </a:solidFill>
+                <a:latin typeface="Helvetica Neue" pitchFamily="34" charset="0"/>
+                <a:ea typeface="Helvetica Neue" pitchFamily="34" charset="-122"/>
+                <a:cs typeface="Helvetica Neue" pitchFamily="34" charset="-120"/>
+              </a:rPr>
+              <a:t>Yuxin Liu</a:t>
             </a:r>
             <a:endParaRPr lang="en-US" sz="1800" dirty="0"/>
           </a:p>
@@ -2167,9 +2181,9 @@
                 <a:solidFill>
                   <a:srgbClr val="CADCFC"/>
                 </a:solidFill>
-                <a:latin typeface="Calibri" pitchFamily="34" charset="0"/>
-                <a:ea typeface="Calibri" pitchFamily="34" charset="-122"/>
-                <a:cs typeface="Calibri" pitchFamily="34" charset="-120"/>
+                <a:latin typeface="Helvetica Neue" pitchFamily="34" charset="0"/>
+                <a:ea typeface="Helvetica Neue" pitchFamily="34" charset="-122"/>
+                <a:cs typeface="Helvetica Neue" pitchFamily="34" charset="-120"/>
               </a:rPr>
               <a:t>A Gradio app that both clones voices and catches them.</a:t>
             </a:r>
@@ -2263,9 +2277,9 @@
                 <a:solidFill>
                   <a:srgbClr val="1E2761"/>
                 </a:solidFill>
-                <a:latin typeface="Cambria" pitchFamily="34" charset="0"/>
-                <a:ea typeface="Cambria" pitchFamily="34" charset="-122"/>
-                <a:cs typeface="Cambria" pitchFamily="34" charset="-120"/>
+                <a:latin typeface="Helvetica Neue" pitchFamily="34" charset="0"/>
+                <a:ea typeface="Helvetica Neue" pitchFamily="34" charset="-122"/>
+                <a:cs typeface="Helvetica Neue" pitchFamily="34" charset="-120"/>
               </a:rPr>
               <a:t>Future Work  —  one step</a:t>
             </a:r>
@@ -2302,11 +2316,11 @@
                 <a:solidFill>
                   <a:srgbClr val="64748B"/>
                 </a:solidFill>
-                <a:latin typeface="Calibri" pitchFamily="34" charset="0"/>
-                <a:ea typeface="Calibri" pitchFamily="34" charset="-122"/>
-                <a:cs typeface="Calibri" pitchFamily="34" charset="-120"/>
-              </a:rPr>
-              <a:t>Rubric: 5 pts</a:t>
+                <a:latin typeface="Helvetica Neue" pitchFamily="34" charset="0"/>
+                <a:ea typeface="Helvetica Neue" pitchFamily="34" charset="-122"/>
+                <a:cs typeface="Helvetica Neue" pitchFamily="34" charset="-120"/>
+              </a:rPr>
+              <a:t>Future Work</a:t>
             </a:r>
             <a:endParaRPr lang="en-US" sz="1100" dirty="0"/>
           </a:p>
@@ -2389,9 +2403,9 @@
                 <a:solidFill>
                   <a:srgbClr val="FFFFFF"/>
                 </a:solidFill>
-                <a:latin typeface="Cambria" pitchFamily="34" charset="0"/>
-                <a:ea typeface="Cambria" pitchFamily="34" charset="-122"/>
-                <a:cs typeface="Cambria" pitchFamily="34" charset="-120"/>
+                <a:latin typeface="Helvetica Neue" pitchFamily="34" charset="0"/>
+                <a:ea typeface="Helvetica Neue" pitchFamily="34" charset="-122"/>
+                <a:cs typeface="Helvetica Neue" pitchFamily="34" charset="-120"/>
               </a:rPr>
               <a:t>Domain-adaptive fine-tuning  on diverse real-world speech</a:t>
             </a:r>
@@ -2478,9 +2492,9 @@
                 <a:solidFill>
                   <a:srgbClr val="1E2761"/>
                 </a:solidFill>
-                <a:latin typeface="Cambria" pitchFamily="34" charset="0"/>
-                <a:ea typeface="Cambria" pitchFamily="34" charset="-122"/>
-                <a:cs typeface="Cambria" pitchFamily="34" charset="-120"/>
+                <a:latin typeface="Helvetica Neue" pitchFamily="34" charset="0"/>
+                <a:ea typeface="Helvetica Neue" pitchFamily="34" charset="-122"/>
+                <a:cs typeface="Helvetica Neue" pitchFamily="34" charset="-120"/>
               </a:rPr>
               <a:t>Data  —  collect ≥ 1,000 hrs real human audio</a:t>
             </a:r>
@@ -2521,9 +2535,9 @@
                 <a:solidFill>
                   <a:srgbClr val="0F172A"/>
                 </a:solidFill>
-                <a:latin typeface="Calibri" pitchFamily="34" charset="0"/>
-                <a:ea typeface="Calibri" pitchFamily="34" charset="-122"/>
-                <a:cs typeface="Calibri" pitchFamily="34" charset="-120"/>
+                <a:latin typeface="Helvetica Neue" pitchFamily="34" charset="0"/>
+                <a:ea typeface="Helvetica Neue" pitchFamily="34" charset="-122"/>
+                <a:cs typeface="Helvetica Neue" pitchFamily="34" charset="-120"/>
               </a:rPr>
               <a:t>Phone codecs  (µ-law, Opus, GSM)</a:t>
             </a:r>
@@ -2542,9 +2556,9 @@
                 <a:solidFill>
                   <a:srgbClr val="0F172A"/>
                 </a:solidFill>
-                <a:latin typeface="Calibri" pitchFamily="34" charset="0"/>
-                <a:ea typeface="Calibri" pitchFamily="34" charset="-122"/>
-                <a:cs typeface="Calibri" pitchFamily="34" charset="-120"/>
+                <a:latin typeface="Helvetica Neue" pitchFamily="34" charset="0"/>
+                <a:ea typeface="Helvetica Neue" pitchFamily="34" charset="-122"/>
+                <a:cs typeface="Helvetica Neue" pitchFamily="34" charset="-120"/>
               </a:rPr>
               <a:t>Consumer mics  (laptop, earbuds, headset)</a:t>
             </a:r>
@@ -2563,9 +2577,9 @@
                 <a:solidFill>
                   <a:srgbClr val="0F172A"/>
                 </a:solidFill>
-                <a:latin typeface="Calibri" pitchFamily="34" charset="0"/>
-                <a:ea typeface="Calibri" pitchFamily="34" charset="-122"/>
-                <a:cs typeface="Calibri" pitchFamily="34" charset="-120"/>
+                <a:latin typeface="Helvetica Neue" pitchFamily="34" charset="0"/>
+                <a:ea typeface="Helvetica Neue" pitchFamily="34" charset="-122"/>
+                <a:cs typeface="Helvetica Neue" pitchFamily="34" charset="-120"/>
               </a:rPr>
               <a:t>Noisy conditions  (café, car, wind)</a:t>
             </a:r>
@@ -2584,9 +2598,9 @@
                 <a:solidFill>
                   <a:srgbClr val="0F172A"/>
                 </a:solidFill>
-                <a:latin typeface="Calibri" pitchFamily="34" charset="0"/>
-                <a:ea typeface="Calibri" pitchFamily="34" charset="-122"/>
-                <a:cs typeface="Calibri" pitchFamily="34" charset="-120"/>
+                <a:latin typeface="Helvetica Neue" pitchFamily="34" charset="0"/>
+                <a:ea typeface="Helvetica Neue" pitchFamily="34" charset="-122"/>
+                <a:cs typeface="Helvetica Neue" pitchFamily="34" charset="-120"/>
               </a:rPr>
               <a:t>50+ demographically diverse speakers</a:t>
             </a:r>
@@ -2602,9 +2616,9 @@
                 <a:solidFill>
                   <a:srgbClr val="0F172A"/>
                 </a:solidFill>
-                <a:latin typeface="Calibri" pitchFamily="34" charset="0"/>
-                <a:ea typeface="Calibri" pitchFamily="34" charset="-122"/>
-                <a:cs typeface="Calibri" pitchFamily="34" charset="-120"/>
+                <a:latin typeface="Helvetica Neue" pitchFamily="34" charset="0"/>
+                <a:ea typeface="Helvetica Neue" pitchFamily="34" charset="-122"/>
+                <a:cs typeface="Helvetica Neue" pitchFamily="34" charset="-120"/>
               </a:rPr>
               <a:t>Pool with ASVspoof, fine-tune end-to-end</a:t>
             </a:r>
@@ -2691,9 +2705,9 @@
                 <a:solidFill>
                   <a:srgbClr val="1E2761"/>
                 </a:solidFill>
-                <a:latin typeface="Cambria" pitchFamily="34" charset="0"/>
-                <a:ea typeface="Cambria" pitchFamily="34" charset="-122"/>
-                <a:cs typeface="Cambria" pitchFamily="34" charset="-120"/>
+                <a:latin typeface="Helvetica Neue" pitchFamily="34" charset="0"/>
+                <a:ea typeface="Helvetica Neue" pitchFamily="34" charset="-122"/>
+                <a:cs typeface="Helvetica Neue" pitchFamily="34" charset="-120"/>
               </a:rPr>
               <a:t>Resources — think big</a:t>
             </a:r>
@@ -2734,9 +2748,9 @@
                 <a:solidFill>
                   <a:srgbClr val="0F172A"/>
                 </a:solidFill>
-                <a:latin typeface="Calibri" pitchFamily="34" charset="0"/>
-                <a:ea typeface="Calibri" pitchFamily="34" charset="-122"/>
-                <a:cs typeface="Calibri" pitchFamily="34" charset="-120"/>
+                <a:latin typeface="Helvetica Neue" pitchFamily="34" charset="0"/>
+                <a:ea typeface="Helvetica Neue" pitchFamily="34" charset="-122"/>
+                <a:cs typeface="Helvetica Neue" pitchFamily="34" charset="-120"/>
               </a:rPr>
               <a:t>1 × A100-week  GPU for fine-tuning</a:t>
             </a:r>
@@ -2755,9 +2769,9 @@
                 <a:solidFill>
                   <a:srgbClr val="0F172A"/>
                 </a:solidFill>
-                <a:latin typeface="Calibri" pitchFamily="34" charset="0"/>
-                <a:ea typeface="Calibri" pitchFamily="34" charset="-122"/>
-                <a:cs typeface="Calibri" pitchFamily="34" charset="-120"/>
+                <a:latin typeface="Helvetica Neue" pitchFamily="34" charset="0"/>
+                <a:ea typeface="Helvetica Neue" pitchFamily="34" charset="-122"/>
+                <a:cs typeface="Helvetica Neue" pitchFamily="34" charset="-120"/>
               </a:rPr>
               <a:t>~ 2 FTE-months  for data collection + labelling</a:t>
             </a:r>
@@ -2776,9 +2790,9 @@
                 <a:solidFill>
                   <a:srgbClr val="0F172A"/>
                 </a:solidFill>
-                <a:latin typeface="Calibri" pitchFamily="34" charset="0"/>
-                <a:ea typeface="Calibri" pitchFamily="34" charset="-122"/>
-                <a:cs typeface="Calibri" pitchFamily="34" charset="-120"/>
+                <a:latin typeface="Helvetica Neue" pitchFamily="34" charset="0"/>
+                <a:ea typeface="Helvetica Neue" pitchFamily="34" charset="-122"/>
+                <a:cs typeface="Helvetica Neue" pitchFamily="34" charset="-120"/>
               </a:rPr>
               <a:t>$5–10 k  microphones + speaker honoraria</a:t>
             </a:r>
@@ -2794,52 +2808,13 @@
                 <a:solidFill>
                   <a:srgbClr val="0F172A"/>
                 </a:solidFill>
-                <a:latin typeface="Calibri" pitchFamily="34" charset="0"/>
-                <a:ea typeface="Calibri" pitchFamily="34" charset="-122"/>
-                <a:cs typeface="Calibri" pitchFamily="34" charset="-120"/>
+                <a:latin typeface="Helvetica Neue" pitchFamily="34" charset="0"/>
+                <a:ea typeface="Helvetica Neue" pitchFamily="34" charset="-122"/>
+                <a:cs typeface="Helvetica Neue" pitchFamily="34" charset="-120"/>
               </a:rPr>
               <a:t>Re-evaluate on both benchmark and new in-the-wild set</a:t>
             </a:r>
             <a:endParaRPr lang="en-US" sz="1350" dirty="0"/>
-          </a:p>
-        </p:txBody>
-      </p:sp>
-      <p:sp>
-        <p:nvSpPr>
-          <p:cNvPr id="16" name="Text 14"/>
-          <p:cNvSpPr/>
-          <p:nvPr/>
-        </p:nvSpPr>
-        <p:spPr>
-          <a:xfrm>
-            <a:off x="411480" y="6537960"/>
-            <a:ext cx="11338560" cy="228600"/>
-          </a:xfrm>
-          <a:prstGeom prst="rect">
-            <a:avLst/>
-          </a:prstGeom>
-          <a:noFill/>
-          <a:ln/>
-        </p:spPr>
-        <p:txBody>
-          <a:bodyPr wrap="square" lIns="0" tIns="0" rIns="0" bIns="0" rtlCol="0" anchor="ctr"/>
-          <a:lstStyle/>
-          <a:p>
-            <a:pPr algn="r" indent="0" marL="0">
-              <a:buNone/>
-            </a:pPr>
-            <a:r>
-              <a:rPr lang="en-US" sz="900" dirty="0">
-                <a:solidFill>
-                  <a:srgbClr val="64748B"/>
-                </a:solidFill>
-                <a:latin typeface="Calibri" pitchFamily="34" charset="0"/>
-                <a:ea typeface="Calibri" pitchFamily="34" charset="-122"/>
-                <a:cs typeface="Calibri" pitchFamily="34" charset="-120"/>
-              </a:rPr>
-              <a:t>VoiceGuard · 10 / 13</a:t>
-            </a:r>
-            <a:endParaRPr lang="en-US" sz="900" dirty="0"/>
           </a:p>
         </p:txBody>
       </p:sp>
@@ -2929,9 +2904,9 @@
                 <a:solidFill>
                   <a:srgbClr val="1E2761"/>
                 </a:solidFill>
-                <a:latin typeface="Cambria" pitchFamily="34" charset="0"/>
-                <a:ea typeface="Cambria" pitchFamily="34" charset="-122"/>
-                <a:cs typeface="Cambria" pitchFamily="34" charset="-120"/>
+                <a:latin typeface="Helvetica Neue" pitchFamily="34" charset="0"/>
+                <a:ea typeface="Helvetica Neue" pitchFamily="34" charset="-122"/>
+                <a:cs typeface="Helvetica Neue" pitchFamily="34" charset="-120"/>
               </a:rPr>
               <a:t>Justification  —  evidence from our eval</a:t>
             </a:r>
@@ -2968,11 +2943,11 @@
                 <a:solidFill>
                   <a:srgbClr val="64748B"/>
                 </a:solidFill>
-                <a:latin typeface="Calibri" pitchFamily="34" charset="0"/>
-                <a:ea typeface="Calibri" pitchFamily="34" charset="-122"/>
-                <a:cs typeface="Calibri" pitchFamily="34" charset="-120"/>
-              </a:rPr>
-              <a:t>Rubric: 5 pts</a:t>
+                <a:latin typeface="Helvetica Neue" pitchFamily="34" charset="0"/>
+                <a:ea typeface="Helvetica Neue" pitchFamily="34" charset="-122"/>
+                <a:cs typeface="Helvetica Neue" pitchFamily="34" charset="-120"/>
+              </a:rPr>
+              <a:t>Justification</a:t>
             </a:r>
             <a:endParaRPr lang="en-US" sz="1100" dirty="0"/>
           </a:p>
@@ -3080,9 +3055,9 @@
                 <a:solidFill>
                   <a:srgbClr val="FFFFFF"/>
                 </a:solidFill>
-                <a:latin typeface="Cambria" pitchFamily="34" charset="0"/>
-                <a:ea typeface="Cambria" pitchFamily="34" charset="-122"/>
-                <a:cs typeface="Cambria" pitchFamily="34" charset="-120"/>
+                <a:latin typeface="Helvetica Neue" pitchFamily="34" charset="0"/>
+                <a:ea typeface="Helvetica Neue" pitchFamily="34" charset="-122"/>
+                <a:cs typeface="Helvetica Neue" pitchFamily="34" charset="-120"/>
               </a:rPr>
               <a:t>1</a:t>
             </a:r>
@@ -3119,9 +3094,9 @@
                 <a:solidFill>
                   <a:srgbClr val="1E2761"/>
                 </a:solidFill>
-                <a:latin typeface="Cambria" pitchFamily="34" charset="0"/>
-                <a:ea typeface="Cambria" pitchFamily="34" charset="-122"/>
-                <a:cs typeface="Cambria" pitchFamily="34" charset="-120"/>
+                <a:latin typeface="Helvetica Neue" pitchFamily="34" charset="0"/>
+                <a:ea typeface="Helvetica Neue" pitchFamily="34" charset="-122"/>
+                <a:cs typeface="Helvetica Neue" pitchFamily="34" charset="-120"/>
               </a:rPr>
               <a:t>Benchmark FPR is already near-zero</a:t>
             </a:r>
@@ -3158,9 +3133,9 @@
                 <a:solidFill>
                   <a:srgbClr val="0F172A"/>
                 </a:solidFill>
-                <a:latin typeface="Calibri" pitchFamily="34" charset="0"/>
-                <a:ea typeface="Calibri" pitchFamily="34" charset="-122"/>
-                <a:cs typeface="Calibri" pitchFamily="34" charset="-120"/>
+                <a:latin typeface="Helvetica Neue" pitchFamily="34" charset="0"/>
+                <a:ea typeface="Helvetica Neue" pitchFamily="34" charset="-122"/>
+                <a:cs typeface="Helvetica Neue" pitchFamily="34" charset="-120"/>
               </a:rPr>
               <a:t>0.109 %  (8 / 7,355 real).  A bigger / deeper model</a:t>
             </a:r>
@@ -3175,9 +3150,9 @@
                 <a:solidFill>
                   <a:srgbClr val="0F172A"/>
                 </a:solidFill>
-                <a:latin typeface="Calibri" pitchFamily="34" charset="0"/>
-                <a:ea typeface="Calibri" pitchFamily="34" charset="-122"/>
-                <a:cs typeface="Calibri" pitchFamily="34" charset="-120"/>
+                <a:latin typeface="Helvetica Neue" pitchFamily="34" charset="0"/>
+                <a:ea typeface="Helvetica Neue" pitchFamily="34" charset="-122"/>
+                <a:cs typeface="Helvetica Neue" pitchFamily="34" charset="-120"/>
               </a:rPr>
               <a:t>won't help when you're already at the floor.</a:t>
             </a:r>
@@ -3264,9 +3239,9 @@
                 <a:solidFill>
                   <a:srgbClr val="FFFFFF"/>
                 </a:solidFill>
-                <a:latin typeface="Cambria" pitchFamily="34" charset="0"/>
-                <a:ea typeface="Cambria" pitchFamily="34" charset="-122"/>
-                <a:cs typeface="Cambria" pitchFamily="34" charset="-120"/>
+                <a:latin typeface="Helvetica Neue" pitchFamily="34" charset="0"/>
+                <a:ea typeface="Helvetica Neue" pitchFamily="34" charset="-122"/>
+                <a:cs typeface="Helvetica Neue" pitchFamily="34" charset="-120"/>
               </a:rPr>
               <a:t>2</a:t>
             </a:r>
@@ -3303,9 +3278,9 @@
                 <a:solidFill>
                   <a:srgbClr val="1E2761"/>
                 </a:solidFill>
-                <a:latin typeface="Cambria" pitchFamily="34" charset="0"/>
-                <a:ea typeface="Cambria" pitchFamily="34" charset="-122"/>
-                <a:cs typeface="Cambria" pitchFamily="34" charset="-120"/>
+                <a:latin typeface="Helvetica Neue" pitchFamily="34" charset="0"/>
+                <a:ea typeface="Helvetica Neue" pitchFamily="34" charset="-122"/>
+                <a:cs typeface="Helvetica Neue" pitchFamily="34" charset="-120"/>
               </a:rPr>
               <a:t>In-the-wild FPR is catastrophic</a:t>
             </a:r>
@@ -3342,9 +3317,9 @@
                 <a:solidFill>
                   <a:srgbClr val="0F172A"/>
                 </a:solidFill>
-                <a:latin typeface="Calibri" pitchFamily="34" charset="0"/>
-                <a:ea typeface="Calibri" pitchFamily="34" charset="-122"/>
-                <a:cs typeface="Calibri" pitchFamily="34" charset="-120"/>
+                <a:latin typeface="Helvetica Neue" pitchFamily="34" charset="0"/>
+                <a:ea typeface="Helvetica Neue" pitchFamily="34" charset="-122"/>
+                <a:cs typeface="Helvetica Neue" pitchFamily="34" charset="-120"/>
               </a:rPr>
               <a:t>80 %  (4 / 5 real humans).  A ~730× degradation that</a:t>
             </a:r>
@@ -3359,9 +3334,9 @@
                 <a:solidFill>
                   <a:srgbClr val="0F172A"/>
                 </a:solidFill>
-                <a:latin typeface="Calibri" pitchFamily="34" charset="0"/>
-                <a:ea typeface="Calibri" pitchFamily="34" charset="-122"/>
-                <a:cs typeface="Calibri" pitchFamily="34" charset="-120"/>
+                <a:latin typeface="Helvetica Neue" pitchFamily="34" charset="0"/>
+                <a:ea typeface="Helvetica Neue" pitchFamily="34" charset="-122"/>
+                <a:cs typeface="Helvetica Neue" pitchFamily="34" charset="-120"/>
               </a:rPr>
               <a:t>scales with distribution mismatch, not model size.</a:t>
             </a:r>
@@ -3448,9 +3423,9 @@
                 <a:solidFill>
                   <a:srgbClr val="FFFFFF"/>
                 </a:solidFill>
-                <a:latin typeface="Cambria" pitchFamily="34" charset="0"/>
-                <a:ea typeface="Cambria" pitchFamily="34" charset="-122"/>
-                <a:cs typeface="Cambria" pitchFamily="34" charset="-120"/>
+                <a:latin typeface="Helvetica Neue" pitchFamily="34" charset="0"/>
+                <a:ea typeface="Helvetica Neue" pitchFamily="34" charset="-122"/>
+                <a:cs typeface="Helvetica Neue" pitchFamily="34" charset="-120"/>
               </a:rPr>
               <a:t>3</a:t>
             </a:r>
@@ -3487,9 +3462,9 @@
                 <a:solidFill>
                   <a:srgbClr val="1E2761"/>
                 </a:solidFill>
-                <a:latin typeface="Cambria" pitchFamily="34" charset="0"/>
-                <a:ea typeface="Cambria" pitchFamily="34" charset="-122"/>
-                <a:cs typeface="Cambria" pitchFamily="34" charset="-120"/>
+                <a:latin typeface="Helvetica Neue" pitchFamily="34" charset="0"/>
+                <a:ea typeface="Helvetica Neue" pitchFamily="34" charset="-122"/>
+                <a:cs typeface="Helvetica Neue" pitchFamily="34" charset="-120"/>
               </a:rPr>
               <a:t>The architecture is fine — data isn't</a:t>
             </a:r>
@@ -3526,9 +3501,9 @@
                 <a:solidFill>
                   <a:srgbClr val="0F172A"/>
                 </a:solidFill>
-                <a:latin typeface="Calibri" pitchFamily="34" charset="0"/>
-                <a:ea typeface="Calibri" pitchFamily="34" charset="-122"/>
-                <a:cs typeface="Calibri" pitchFamily="34" charset="-120"/>
+                <a:latin typeface="Helvetica Neue" pitchFamily="34" charset="0"/>
+                <a:ea typeface="Helvetica Neue" pitchFamily="34" charset="-122"/>
+                <a:cs typeface="Helvetica Neue" pitchFamily="34" charset="-120"/>
               </a:rPr>
               <a:t>W2V-AASIST paper: EER ~0.7 % when train ≈ test.</a:t>
             </a:r>
@@ -3543,9 +3518,9 @@
                 <a:solidFill>
                   <a:srgbClr val="0F172A"/>
                 </a:solidFill>
-                <a:latin typeface="Calibri" pitchFamily="34" charset="0"/>
-                <a:ea typeface="Calibri" pitchFamily="34" charset="-122"/>
-                <a:cs typeface="Calibri" pitchFamily="34" charset="-120"/>
+                <a:latin typeface="Helvetica Neue" pitchFamily="34" charset="0"/>
+                <a:ea typeface="Helvetica Neue" pitchFamily="34" charset="-122"/>
+                <a:cs typeface="Helvetica Neue" pitchFamily="34" charset="-120"/>
               </a:rPr>
               <a:t>Our reproduction:  EER 0.146 %  — within range.</a:t>
             </a:r>
@@ -3632,9 +3607,9 @@
                 <a:solidFill>
                   <a:srgbClr val="FFFFFF"/>
                 </a:solidFill>
-                <a:latin typeface="Cambria" pitchFamily="34" charset="0"/>
-                <a:ea typeface="Cambria" pitchFamily="34" charset="-122"/>
-                <a:cs typeface="Cambria" pitchFamily="34" charset="-120"/>
+                <a:latin typeface="Helvetica Neue" pitchFamily="34" charset="0"/>
+                <a:ea typeface="Helvetica Neue" pitchFamily="34" charset="-122"/>
+                <a:cs typeface="Helvetica Neue" pitchFamily="34" charset="-120"/>
               </a:rPr>
               <a:t>4</a:t>
             </a:r>
@@ -3671,9 +3646,9 @@
                 <a:solidFill>
                   <a:srgbClr val="1E2761"/>
                 </a:solidFill>
-                <a:latin typeface="Cambria" pitchFamily="34" charset="0"/>
-                <a:ea typeface="Cambria" pitchFamily="34" charset="-122"/>
-                <a:cs typeface="Cambria" pitchFamily="34" charset="-120"/>
+                <a:latin typeface="Helvetica Neue" pitchFamily="34" charset="0"/>
+                <a:ea typeface="Helvetica Neue" pitchFamily="34" charset="-122"/>
+                <a:cs typeface="Helvetica Neue" pitchFamily="34" charset="-120"/>
               </a:rPr>
               <a:t>Features already separate real / fake</a:t>
             </a:r>
@@ -3710,9 +3685,9 @@
                 <a:solidFill>
                   <a:srgbClr val="0F172A"/>
                 </a:solidFill>
-                <a:latin typeface="Calibri" pitchFamily="34" charset="0"/>
-                <a:ea typeface="Calibri" pitchFamily="34" charset="-122"/>
-                <a:cs typeface="Calibri" pitchFamily="34" charset="-120"/>
+                <a:latin typeface="Helvetica Neue" pitchFamily="34" charset="0"/>
+                <a:ea typeface="Helvetica Neue" pitchFamily="34" charset="-122"/>
+                <a:cs typeface="Helvetica Neue" pitchFamily="34" charset="-120"/>
               </a:rPr>
               <a:t>At 71 k scale, shimmer / F0-CV / energy-CV</a:t>
             </a:r>
@@ -3727,9 +3702,9 @@
                 <a:solidFill>
                   <a:srgbClr val="0F172A"/>
                 </a:solidFill>
-                <a:latin typeface="Calibri" pitchFamily="34" charset="0"/>
-                <a:ea typeface="Calibri" pitchFamily="34" charset="-122"/>
-                <a:cs typeface="Calibri" pitchFamily="34" charset="-120"/>
+                <a:latin typeface="Helvetica Neue" pitchFamily="34" charset="0"/>
+                <a:ea typeface="Helvetica Neue" pitchFamily="34" charset="-122"/>
+                <a:cs typeface="Helvetica Neue" pitchFamily="34" charset="-120"/>
               </a:rPr>
               <a:t>distributions split cleanly → signal exists, domain doesn't.</a:t>
             </a:r>
@@ -3766,52 +3741,13 @@
                 <a:solidFill>
                   <a:srgbClr val="DD6B20"/>
                 </a:solidFill>
-                <a:latin typeface="Calibri" pitchFamily="34" charset="0"/>
-                <a:ea typeface="Calibri" pitchFamily="34" charset="-122"/>
-                <a:cs typeface="Calibri" pitchFamily="34" charset="-120"/>
+                <a:latin typeface="Helvetica Neue" pitchFamily="34" charset="0"/>
+                <a:ea typeface="Helvetica Neue" pitchFamily="34" charset="-122"/>
+                <a:cs typeface="Helvetica Neue" pitchFamily="34" charset="-120"/>
               </a:rPr>
               <a:t>→  Fine-tuning on diverse real speech is a higher-leverage investment than architectural changes or a bigger model.</a:t>
             </a:r>
             <a:endParaRPr lang="en-US" sz="1350" dirty="0"/>
-          </a:p>
-        </p:txBody>
-      </p:sp>
-      <p:sp>
-        <p:nvSpPr>
-          <p:cNvPr id="27" name="Text 25"/>
-          <p:cNvSpPr/>
-          <p:nvPr/>
-        </p:nvSpPr>
-        <p:spPr>
-          <a:xfrm>
-            <a:off x="411480" y="6537960"/>
-            <a:ext cx="11338560" cy="228600"/>
-          </a:xfrm>
-          <a:prstGeom prst="rect">
-            <a:avLst/>
-          </a:prstGeom>
-          <a:noFill/>
-          <a:ln/>
-        </p:spPr>
-        <p:txBody>
-          <a:bodyPr wrap="square" lIns="0" tIns="0" rIns="0" bIns="0" rtlCol="0" anchor="ctr"/>
-          <a:lstStyle/>
-          <a:p>
-            <a:pPr algn="r" indent="0" marL="0">
-              <a:buNone/>
-            </a:pPr>
-            <a:r>
-              <a:rPr lang="en-US" sz="900" dirty="0">
-                <a:solidFill>
-                  <a:srgbClr val="64748B"/>
-                </a:solidFill>
-                <a:latin typeface="Calibri" pitchFamily="34" charset="0"/>
-                <a:ea typeface="Calibri" pitchFamily="34" charset="-122"/>
-                <a:cs typeface="Calibri" pitchFamily="34" charset="-120"/>
-              </a:rPr>
-              <a:t>VoiceGuard · 11 / 13</a:t>
-            </a:r>
-            <a:endParaRPr lang="en-US" sz="900" dirty="0"/>
           </a:p>
         </p:txBody>
       </p:sp>
@@ -3901,9 +3837,9 @@
                 <a:solidFill>
                   <a:srgbClr val="1E2761"/>
                 </a:solidFill>
-                <a:latin typeface="Cambria" pitchFamily="34" charset="0"/>
-                <a:ea typeface="Cambria" pitchFamily="34" charset="-122"/>
-                <a:cs typeface="Cambria" pitchFamily="34" charset="-120"/>
+                <a:latin typeface="Helvetica Neue" pitchFamily="34" charset="0"/>
+                <a:ea typeface="Helvetica Neue" pitchFamily="34" charset="-122"/>
+                <a:cs typeface="Helvetica Neue" pitchFamily="34" charset="-120"/>
               </a:rPr>
               <a:t>Summary</a:t>
             </a:r>
@@ -3988,9 +3924,9 @@
                 <a:solidFill>
                   <a:srgbClr val="FFFFFF"/>
                 </a:solidFill>
-                <a:latin typeface="Cambria" pitchFamily="34" charset="0"/>
-                <a:ea typeface="Cambria" pitchFamily="34" charset="-122"/>
-                <a:cs typeface="Cambria" pitchFamily="34" charset="-120"/>
+                <a:latin typeface="Helvetica Neue" pitchFamily="34" charset="0"/>
+                <a:ea typeface="Helvetica Neue" pitchFamily="34" charset="-122"/>
+                <a:cs typeface="Helvetica Neue" pitchFamily="34" charset="-120"/>
               </a:rPr>
               <a:t>1</a:t>
             </a:r>
@@ -4027,9 +3963,9 @@
                 <a:solidFill>
                   <a:srgbClr val="1E2761"/>
                 </a:solidFill>
-                <a:latin typeface="Cambria" pitchFamily="34" charset="0"/>
-                <a:ea typeface="Cambria" pitchFamily="34" charset="-122"/>
-                <a:cs typeface="Cambria" pitchFamily="34" charset="-120"/>
+                <a:latin typeface="Helvetica Neue" pitchFamily="34" charset="0"/>
+                <a:ea typeface="Helvetica Neue" pitchFamily="34" charset="-122"/>
+                <a:cs typeface="Helvetica Neue" pitchFamily="34" charset="-120"/>
               </a:rPr>
               <a:t>Built</a:t>
             </a:r>
@@ -4066,9 +4002,9 @@
                 <a:solidFill>
                   <a:srgbClr val="0F172A"/>
                 </a:solidFill>
-                <a:latin typeface="Calibri" pitchFamily="34" charset="0"/>
-                <a:ea typeface="Calibri" pitchFamily="34" charset="-122"/>
-                <a:cs typeface="Calibri" pitchFamily="34" charset="-120"/>
+                <a:latin typeface="Helvetica Neue" pitchFamily="34" charset="0"/>
+                <a:ea typeface="Helvetica Neue" pitchFamily="34" charset="-122"/>
+                <a:cs typeface="Helvetica Neue" pitchFamily="34" charset="-120"/>
               </a:rPr>
               <a:t>an integrated clone + detect tool  —  attack → shield in  &lt; 30 s</a:t>
             </a:r>
@@ -4130,9 +4066,9 @@
                 <a:solidFill>
                   <a:srgbClr val="FFFFFF"/>
                 </a:solidFill>
-                <a:latin typeface="Cambria" pitchFamily="34" charset="0"/>
-                <a:ea typeface="Cambria" pitchFamily="34" charset="-122"/>
-                <a:cs typeface="Cambria" pitchFamily="34" charset="-120"/>
+                <a:latin typeface="Helvetica Neue" pitchFamily="34" charset="0"/>
+                <a:ea typeface="Helvetica Neue" pitchFamily="34" charset="-122"/>
+                <a:cs typeface="Helvetica Neue" pitchFamily="34" charset="-120"/>
               </a:rPr>
               <a:t>2</a:t>
             </a:r>
@@ -4169,9 +4105,9 @@
                 <a:solidFill>
                   <a:srgbClr val="2E8B8B"/>
                 </a:solidFill>
-                <a:latin typeface="Cambria" pitchFamily="34" charset="0"/>
-                <a:ea typeface="Cambria" pitchFamily="34" charset="-122"/>
-                <a:cs typeface="Cambria" pitchFamily="34" charset="-120"/>
+                <a:latin typeface="Helvetica Neue" pitchFamily="34" charset="0"/>
+                <a:ea typeface="Helvetica Neue" pitchFamily="34" charset="-122"/>
+                <a:cs typeface="Helvetica Neue" pitchFamily="34" charset="-120"/>
               </a:rPr>
               <a:t>Benchmarked</a:t>
             </a:r>
@@ -4208,9 +4144,9 @@
                 <a:solidFill>
                   <a:srgbClr val="0F172A"/>
                 </a:solidFill>
-                <a:latin typeface="Calibri" pitchFamily="34" charset="0"/>
-                <a:ea typeface="Calibri" pitchFamily="34" charset="-122"/>
-                <a:cs typeface="Calibri" pitchFamily="34" charset="-120"/>
+                <a:latin typeface="Helvetica Neue" pitchFamily="34" charset="0"/>
+                <a:ea typeface="Helvetica Neue" pitchFamily="34" charset="-122"/>
+                <a:cs typeface="Helvetica Neue" pitchFamily="34" charset="-120"/>
               </a:rPr>
               <a:t>at full scale:  99.77 % accuracy,  0.109 % FPR,  EER  0.146 %   (N = 71,237)</a:t>
             </a:r>
@@ -4272,9 +4208,9 @@
                 <a:solidFill>
                   <a:srgbClr val="FFFFFF"/>
                 </a:solidFill>
-                <a:latin typeface="Cambria" pitchFamily="34" charset="0"/>
-                <a:ea typeface="Cambria" pitchFamily="34" charset="-122"/>
-                <a:cs typeface="Cambria" pitchFamily="34" charset="-120"/>
+                <a:latin typeface="Helvetica Neue" pitchFamily="34" charset="0"/>
+                <a:ea typeface="Helvetica Neue" pitchFamily="34" charset="-122"/>
+                <a:cs typeface="Helvetica Neue" pitchFamily="34" charset="-120"/>
               </a:rPr>
               <a:t>3</a:t>
             </a:r>
@@ -4311,9 +4247,9 @@
                 <a:solidFill>
                   <a:srgbClr val="E53E3E"/>
                 </a:solidFill>
-                <a:latin typeface="Cambria" pitchFamily="34" charset="0"/>
-                <a:ea typeface="Cambria" pitchFamily="34" charset="-122"/>
-                <a:cs typeface="Cambria" pitchFamily="34" charset="-120"/>
+                <a:latin typeface="Helvetica Neue" pitchFamily="34" charset="0"/>
+                <a:ea typeface="Helvetica Neue" pitchFamily="34" charset="-122"/>
+                <a:cs typeface="Helvetica Neue" pitchFamily="34" charset="-120"/>
               </a:rPr>
               <a:t>Found</a:t>
             </a:r>
@@ -4350,9 +4286,9 @@
                 <a:solidFill>
                   <a:srgbClr val="0F172A"/>
                 </a:solidFill>
-                <a:latin typeface="Calibri" pitchFamily="34" charset="0"/>
-                <a:ea typeface="Calibri" pitchFamily="34" charset="-122"/>
-                <a:cs typeface="Calibri" pitchFamily="34" charset="-120"/>
+                <a:latin typeface="Helvetica Neue" pitchFamily="34" charset="0"/>
+                <a:ea typeface="Helvetica Neue" pitchFamily="34" charset="-122"/>
+                <a:cs typeface="Helvetica Neue" pitchFamily="34" charset="-120"/>
               </a:rPr>
               <a:t>80 % FPR on in-the-wild real humans  —  ~730× benchmark FPR</a:t>
             </a:r>
@@ -4414,9 +4350,9 @@
                 <a:solidFill>
                   <a:srgbClr val="FFFFFF"/>
                 </a:solidFill>
-                <a:latin typeface="Cambria" pitchFamily="34" charset="0"/>
-                <a:ea typeface="Cambria" pitchFamily="34" charset="-122"/>
-                <a:cs typeface="Cambria" pitchFamily="34" charset="-120"/>
+                <a:latin typeface="Helvetica Neue" pitchFamily="34" charset="0"/>
+                <a:ea typeface="Helvetica Neue" pitchFamily="34" charset="-122"/>
+                <a:cs typeface="Helvetica Neue" pitchFamily="34" charset="-120"/>
               </a:rPr>
               <a:t>4</a:t>
             </a:r>
@@ -4453,9 +4389,9 @@
                 <a:solidFill>
                   <a:srgbClr val="DD6B20"/>
                 </a:solidFill>
-                <a:latin typeface="Cambria" pitchFamily="34" charset="0"/>
-                <a:ea typeface="Cambria" pitchFamily="34" charset="-122"/>
-                <a:cs typeface="Cambria" pitchFamily="34" charset="-120"/>
+                <a:latin typeface="Helvetica Neue" pitchFamily="34" charset="0"/>
+                <a:ea typeface="Helvetica Neue" pitchFamily="34" charset="-122"/>
+                <a:cs typeface="Helvetica Neue" pitchFamily="34" charset="-120"/>
               </a:rPr>
               <a:t>Recommend</a:t>
             </a:r>
@@ -4492,52 +4428,13 @@
                 <a:solidFill>
                   <a:srgbClr val="0F172A"/>
                 </a:solidFill>
-                <a:latin typeface="Calibri" pitchFamily="34" charset="0"/>
-                <a:ea typeface="Calibri" pitchFamily="34" charset="-122"/>
-                <a:cs typeface="Calibri" pitchFamily="34" charset="-120"/>
+                <a:latin typeface="Helvetica Neue" pitchFamily="34" charset="0"/>
+                <a:ea typeface="Helvetica Neue" pitchFamily="34" charset="-122"/>
+                <a:cs typeface="Helvetica Neue" pitchFamily="34" charset="-120"/>
               </a:rPr>
               <a:t>collect diverse real-world speech  +  domain-adapt fine-tune</a:t>
             </a:r>
             <a:endParaRPr lang="en-US" sz="1500" dirty="0"/>
-          </a:p>
-        </p:txBody>
-      </p:sp>
-      <p:sp>
-        <p:nvSpPr>
-          <p:cNvPr id="21" name="Text 19"/>
-          <p:cNvSpPr/>
-          <p:nvPr/>
-        </p:nvSpPr>
-        <p:spPr>
-          <a:xfrm>
-            <a:off x="411480" y="6537960"/>
-            <a:ext cx="11338560" cy="228600"/>
-          </a:xfrm>
-          <a:prstGeom prst="rect">
-            <a:avLst/>
-          </a:prstGeom>
-          <a:noFill/>
-          <a:ln/>
-        </p:spPr>
-        <p:txBody>
-          <a:bodyPr wrap="square" lIns="0" tIns="0" rIns="0" bIns="0" rtlCol="0" anchor="ctr"/>
-          <a:lstStyle/>
-          <a:p>
-            <a:pPr algn="r" indent="0" marL="0">
-              <a:buNone/>
-            </a:pPr>
-            <a:r>
-              <a:rPr lang="en-US" sz="900" dirty="0">
-                <a:solidFill>
-                  <a:srgbClr val="64748B"/>
-                </a:solidFill>
-                <a:latin typeface="Calibri" pitchFamily="34" charset="0"/>
-                <a:ea typeface="Calibri" pitchFamily="34" charset="-122"/>
-                <a:cs typeface="Calibri" pitchFamily="34" charset="-120"/>
-              </a:rPr>
-              <a:t>VoiceGuard · 12 / 13</a:t>
-            </a:r>
-            <a:endParaRPr lang="en-US" sz="900" dirty="0"/>
           </a:p>
         </p:txBody>
       </p:sp>
@@ -4606,7 +4503,7 @@
         </p:nvSpPr>
         <p:spPr>
           <a:xfrm>
-            <a:off x="914400" y="2194560"/>
+            <a:off x="914400" y="2377440"/>
             <a:ext cx="10332720" cy="1645920"/>
           </a:xfrm>
           <a:prstGeom prst="rect">
@@ -4623,17 +4520,17 @@
               <a:buNone/>
             </a:pPr>
             <a:r>
-              <a:rPr lang="en-US" sz="12000" b="1" dirty="0">
+              <a:rPr lang="en-US" sz="14000" b="1" dirty="0">
                 <a:solidFill>
                   <a:srgbClr val="FFFFFF"/>
                 </a:solidFill>
-                <a:latin typeface="Cambria" pitchFamily="34" charset="0"/>
-                <a:ea typeface="Cambria" pitchFamily="34" charset="-122"/>
-                <a:cs typeface="Cambria" pitchFamily="34" charset="-120"/>
+                <a:latin typeface="Helvetica Neue" pitchFamily="34" charset="0"/>
+                <a:ea typeface="Helvetica Neue" pitchFamily="34" charset="-122"/>
+                <a:cs typeface="Helvetica Neue" pitchFamily="34" charset="-120"/>
               </a:rPr>
               <a:t>Q&amp;A</a:t>
             </a:r>
-            <a:endParaRPr lang="en-US" sz="12000" dirty="0"/>
+            <a:endParaRPr lang="en-US" sz="14000" dirty="0"/>
           </a:p>
         </p:txBody>
       </p:sp>
@@ -4645,7 +4542,7 @@
         </p:nvSpPr>
         <p:spPr>
           <a:xfrm>
-            <a:off x="914400" y="3931920"/>
+            <a:off x="914400" y="4297680"/>
             <a:ext cx="10332720" cy="640080"/>
           </a:xfrm>
           <a:prstGeom prst="rect">
@@ -4662,70 +4559,17 @@
               <a:buNone/>
             </a:pPr>
             <a:r>
-              <a:rPr lang="en-US" sz="2600" i="1" dirty="0">
+              <a:rPr lang="en-US" sz="2800" i="1" dirty="0">
                 <a:solidFill>
                   <a:srgbClr val="CADCFC"/>
                 </a:solidFill>
-                <a:latin typeface="Cambria" pitchFamily="34" charset="0"/>
-                <a:ea typeface="Cambria" pitchFamily="34" charset="-122"/>
-                <a:cs typeface="Cambria" pitchFamily="34" charset="-120"/>
+                <a:latin typeface="Helvetica Neue" pitchFamily="34" charset="0"/>
+                <a:ea typeface="Helvetica Neue" pitchFamily="34" charset="-122"/>
+                <a:cs typeface="Helvetica Neue" pitchFamily="34" charset="-120"/>
               </a:rPr>
               <a:t>Thanks for listening.</a:t>
             </a:r>
-            <a:endParaRPr lang="en-US" sz="2600" dirty="0"/>
-          </a:p>
-        </p:txBody>
-      </p:sp>
-      <p:sp>
-        <p:nvSpPr>
-          <p:cNvPr id="5" name="Text 3"/>
-          <p:cNvSpPr/>
-          <p:nvPr/>
-        </p:nvSpPr>
-        <p:spPr>
-          <a:xfrm>
-            <a:off x="914400" y="5852160"/>
-            <a:ext cx="10332720" cy="457200"/>
-          </a:xfrm>
-          <a:prstGeom prst="rect">
-            <a:avLst/>
-          </a:prstGeom>
-          <a:noFill/>
-          <a:ln/>
-        </p:spPr>
-        <p:txBody>
-          <a:bodyPr wrap="square" lIns="0" tIns="0" rIns="0" bIns="0" rtlCol="0" anchor="ctr"/>
-          <a:lstStyle/>
-          <a:p>
-            <a:pPr indent="0" marL="0">
-              <a:buNone/>
-            </a:pPr>
-            <a:r>
-              <a:rPr lang="en-US" sz="1200" i="1" dirty="0">
-                <a:solidFill>
-                  <a:srgbClr val="CADCFC"/>
-                </a:solidFill>
-                <a:latin typeface="Calibri" pitchFamily="34" charset="0"/>
-                <a:ea typeface="Calibri" pitchFamily="34" charset="-122"/>
-                <a:cs typeface="Calibri" pitchFamily="34" charset="-120"/>
-              </a:rPr>
-              <a:t>Anticipated:  </a:t>
-            </a:r>
-            <a:pPr indent="0" marL="0">
-              <a:buNone/>
-            </a:pPr>
-            <a:r>
-              <a:rPr lang="en-US" sz="1200" dirty="0">
-                <a:solidFill>
-                  <a:srgbClr val="FFFFFF"/>
-                </a:solidFill>
-                <a:latin typeface="Calibri" pitchFamily="34" charset="0"/>
-                <a:ea typeface="Calibri" pitchFamily="34" charset="-122"/>
-                <a:cs typeface="Calibri" pitchFamily="34" charset="-120"/>
-              </a:rPr>
-              <a:t>why 2019 LA? · 5 in-the-wild samples? · fine-tune in-house? · heatmap as explanation?</a:t>
-            </a:r>
-            <a:endParaRPr lang="en-US" sz="1200" dirty="0"/>
+            <a:endParaRPr lang="en-US" sz="2800" dirty="0"/>
           </a:p>
         </p:txBody>
       </p:sp>
@@ -4815,9 +4659,9 @@
                 <a:solidFill>
                   <a:srgbClr val="1E2761"/>
                 </a:solidFill>
-                <a:latin typeface="Cambria" pitchFamily="34" charset="0"/>
-                <a:ea typeface="Cambria" pitchFamily="34" charset="-122"/>
-                <a:cs typeface="Cambria" pitchFamily="34" charset="-120"/>
+                <a:latin typeface="Helvetica Neue" pitchFamily="34" charset="0"/>
+                <a:ea typeface="Helvetica Neue" pitchFamily="34" charset="-122"/>
+                <a:cs typeface="Helvetica Neue" pitchFamily="34" charset="-120"/>
               </a:rPr>
               <a:t>Goals</a:t>
             </a:r>
@@ -4854,11 +4698,11 @@
                 <a:solidFill>
                   <a:srgbClr val="64748B"/>
                 </a:solidFill>
-                <a:latin typeface="Calibri" pitchFamily="34" charset="0"/>
-                <a:ea typeface="Calibri" pitchFamily="34" charset="-122"/>
-                <a:cs typeface="Calibri" pitchFamily="34" charset="-120"/>
-              </a:rPr>
-              <a:t>Rubric: 5 pts</a:t>
+                <a:latin typeface="Helvetica Neue" pitchFamily="34" charset="0"/>
+                <a:ea typeface="Helvetica Neue" pitchFamily="34" charset="-122"/>
+                <a:cs typeface="Helvetica Neue" pitchFamily="34" charset="-120"/>
+              </a:rPr>
+              <a:t>Goals</a:t>
             </a:r>
             <a:endParaRPr lang="en-US" sz="1100" dirty="0"/>
           </a:p>
@@ -4916,9 +4760,9 @@
                 <a:solidFill>
                   <a:srgbClr val="1E2761"/>
                 </a:solidFill>
-                <a:latin typeface="Cambria" pitchFamily="34" charset="0"/>
-                <a:ea typeface="Cambria" pitchFamily="34" charset="-122"/>
-                <a:cs typeface="Cambria" pitchFamily="34" charset="-120"/>
+                <a:latin typeface="Helvetica Neue" pitchFamily="34" charset="0"/>
+                <a:ea typeface="Helvetica Neue" pitchFamily="34" charset="-122"/>
+                <a:cs typeface="Helvetica Neue" pitchFamily="34" charset="-120"/>
               </a:rPr>
               <a:t>What we set out to build</a:t>
             </a:r>
@@ -4958,9 +4802,9 @@
                 <a:solidFill>
                   <a:srgbClr val="0F172A"/>
                 </a:solidFill>
-                <a:latin typeface="Calibri" pitchFamily="34" charset="0"/>
-                <a:ea typeface="Calibri" pitchFamily="34" charset="-122"/>
-                <a:cs typeface="Calibri" pitchFamily="34" charset="-120"/>
+                <a:latin typeface="Helvetica Neue" pitchFamily="34" charset="0"/>
+                <a:ea typeface="Helvetica Neue" pitchFamily="34" charset="-122"/>
+                <a:cs typeface="Helvetica Neue" pitchFamily="34" charset="-120"/>
               </a:rPr>
               <a:t>A single tool where anyone can:</a:t>
             </a:r>
@@ -4979,9 +4823,9 @@
                 <a:solidFill>
                   <a:srgbClr val="0F172A"/>
                 </a:solidFill>
-                <a:latin typeface="Calibri" pitchFamily="34" charset="0"/>
-                <a:ea typeface="Calibri" pitchFamily="34" charset="-122"/>
-                <a:cs typeface="Calibri" pitchFamily="34" charset="-120"/>
+                <a:latin typeface="Helvetica Neue" pitchFamily="34" charset="0"/>
+                <a:ea typeface="Helvetica Neue" pitchFamily="34" charset="-122"/>
+                <a:cs typeface="Helvetica Neue" pitchFamily="34" charset="-120"/>
               </a:rPr>
               <a:t>Attack — clone a voice from 3–30 s of reference audio</a:t>
             </a:r>
@@ -5000,9 +4844,9 @@
                 <a:solidFill>
                   <a:srgbClr val="0F172A"/>
                 </a:solidFill>
-                <a:latin typeface="Calibri" pitchFamily="34" charset="0"/>
-                <a:ea typeface="Calibri" pitchFamily="34" charset="-122"/>
-                <a:cs typeface="Calibri" pitchFamily="34" charset="-120"/>
+                <a:latin typeface="Helvetica Neue" pitchFamily="34" charset="0"/>
+                <a:ea typeface="Helvetica Neue" pitchFamily="34" charset="-122"/>
+                <a:cs typeface="Helvetica Neue" pitchFamily="34" charset="-120"/>
               </a:rPr>
               <a:t>Shield — detect AI-generated speech with verdict + explanation</a:t>
             </a:r>
@@ -5020,9 +4864,9 @@
                 <a:solidFill>
                   <a:srgbClr val="0F172A"/>
                 </a:solidFill>
-                <a:latin typeface="Calibri" pitchFamily="34" charset="0"/>
-                <a:ea typeface="Calibri" pitchFamily="34" charset="-122"/>
-                <a:cs typeface="Calibri" pitchFamily="34" charset="-120"/>
+                <a:latin typeface="Helvetica Neue" pitchFamily="34" charset="0"/>
+                <a:ea typeface="Helvetica Neue" pitchFamily="34" charset="-122"/>
+                <a:cs typeface="Helvetica Neue" pitchFamily="34" charset="-120"/>
               </a:rPr>
               <a:t>Why now:</a:t>
             </a:r>
@@ -5041,9 +4885,9 @@
                 <a:solidFill>
                   <a:srgbClr val="0F172A"/>
                 </a:solidFill>
-                <a:latin typeface="Calibri" pitchFamily="34" charset="0"/>
-                <a:ea typeface="Calibri" pitchFamily="34" charset="-122"/>
-                <a:cs typeface="Calibri" pitchFamily="34" charset="-120"/>
+                <a:latin typeface="Helvetica Neue" pitchFamily="34" charset="0"/>
+                <a:ea typeface="Helvetica Neue" pitchFamily="34" charset="-122"/>
+                <a:cs typeface="Helvetica Neue" pitchFamily="34" charset="-120"/>
               </a:rPr>
               <a:t>Voice-cloning scams projected at $40 B by 2027</a:t>
             </a:r>
@@ -5059,9 +4903,9 @@
                 <a:solidFill>
                   <a:srgbClr val="0F172A"/>
                 </a:solidFill>
-                <a:latin typeface="Calibri" pitchFamily="34" charset="0"/>
-                <a:ea typeface="Calibri" pitchFamily="34" charset="-122"/>
-                <a:cs typeface="Calibri" pitchFamily="34" charset="-120"/>
+                <a:latin typeface="Helvetica Neue" pitchFamily="34" charset="0"/>
+                <a:ea typeface="Helvetica Neue" pitchFamily="34" charset="-122"/>
+                <a:cs typeface="Helvetica Neue" pitchFamily="34" charset="-120"/>
               </a:rPr>
               <a:t>No open tool pairs clone + detect in one interface</a:t>
             </a:r>
@@ -5148,9 +4992,9 @@
                 <a:solidFill>
                   <a:srgbClr val="1E2761"/>
                 </a:solidFill>
-                <a:latin typeface="Cambria" pitchFamily="34" charset="0"/>
-                <a:ea typeface="Cambria" pitchFamily="34" charset="-122"/>
-                <a:cs typeface="Cambria" pitchFamily="34" charset="-120"/>
+                <a:latin typeface="Helvetica Neue" pitchFamily="34" charset="0"/>
+                <a:ea typeface="Helvetica Neue" pitchFamily="34" charset="-122"/>
+                <a:cs typeface="Helvetica Neue" pitchFamily="34" charset="-120"/>
               </a:rPr>
               <a:t>Refined goal after Challenge Analysis</a:t>
             </a:r>
@@ -5190,9 +5034,9 @@
                 <a:solidFill>
                   <a:srgbClr val="64748B"/>
                 </a:solidFill>
-                <a:latin typeface="Calibri" pitchFamily="34" charset="0"/>
-                <a:ea typeface="Calibri" pitchFamily="34" charset="-122"/>
-                <a:cs typeface="Calibri" pitchFamily="34" charset="-120"/>
+                <a:latin typeface="Helvetica Neue" pitchFamily="34" charset="0"/>
+                <a:ea typeface="Helvetica Neue" pitchFamily="34" charset="-122"/>
+                <a:cs typeface="Helvetica Neue" pitchFamily="34" charset="-120"/>
               </a:rPr>
               <a:t>Not just "does it work?"</a:t>
             </a:r>
@@ -5207,9 +5051,9 @@
                 <a:solidFill>
                   <a:srgbClr val="DD6B20"/>
                 </a:solidFill>
-                <a:latin typeface="Calibri" pitchFamily="34" charset="0"/>
-                <a:ea typeface="Calibri" pitchFamily="34" charset="-122"/>
-                <a:cs typeface="Calibri" pitchFamily="34" charset="-120"/>
+                <a:latin typeface="Helvetica Neue" pitchFamily="34" charset="0"/>
+                <a:ea typeface="Helvetica Neue" pitchFamily="34" charset="-122"/>
+                <a:cs typeface="Helvetica Neue" pitchFamily="34" charset="-120"/>
               </a:rPr>
               <a:t>→  "is the detection calibrated and generalizable beyond the benchmark?"</a:t>
             </a:r>
@@ -5246,52 +5090,13 @@
                 <a:solidFill>
                   <a:srgbClr val="64748B"/>
                 </a:solidFill>
-                <a:latin typeface="Calibri" pitchFamily="34" charset="0"/>
-                <a:ea typeface="Calibri" pitchFamily="34" charset="-122"/>
-                <a:cs typeface="Calibri" pitchFamily="34" charset="-120"/>
+                <a:latin typeface="Helvetica Neue" pitchFamily="34" charset="0"/>
+                <a:ea typeface="Helvetica Neue" pitchFamily="34" charset="-122"/>
+                <a:cs typeface="Helvetica Neue" pitchFamily="34" charset="-120"/>
               </a:rPr>
               <a:t>This framing drives every Results slide →</a:t>
             </a:r>
             <a:endParaRPr lang="en-US" sz="1200" dirty="0"/>
-          </a:p>
-        </p:txBody>
-      </p:sp>
-      <p:sp>
-        <p:nvSpPr>
-          <p:cNvPr id="13" name="Text 11"/>
-          <p:cNvSpPr/>
-          <p:nvPr/>
-        </p:nvSpPr>
-        <p:spPr>
-          <a:xfrm>
-            <a:off x="411480" y="6537960"/>
-            <a:ext cx="11338560" cy="228600"/>
-          </a:xfrm>
-          <a:prstGeom prst="rect">
-            <a:avLst/>
-          </a:prstGeom>
-          <a:noFill/>
-          <a:ln/>
-        </p:spPr>
-        <p:txBody>
-          <a:bodyPr wrap="square" lIns="0" tIns="0" rIns="0" bIns="0" rtlCol="0" anchor="ctr"/>
-          <a:lstStyle/>
-          <a:p>
-            <a:pPr algn="r" indent="0" marL="0">
-              <a:buNone/>
-            </a:pPr>
-            <a:r>
-              <a:rPr lang="en-US" sz="900" dirty="0">
-                <a:solidFill>
-                  <a:srgbClr val="64748B"/>
-                </a:solidFill>
-                <a:latin typeface="Calibri" pitchFamily="34" charset="0"/>
-                <a:ea typeface="Calibri" pitchFamily="34" charset="-122"/>
-                <a:cs typeface="Calibri" pitchFamily="34" charset="-120"/>
-              </a:rPr>
-              <a:t>VoiceGuard · 2 / 13</a:t>
-            </a:r>
-            <a:endParaRPr lang="en-US" sz="900" dirty="0"/>
           </a:p>
         </p:txBody>
       </p:sp>
@@ -5381,9 +5186,9 @@
                 <a:solidFill>
                   <a:srgbClr val="1E2761"/>
                 </a:solidFill>
-                <a:latin typeface="Cambria" pitchFamily="34" charset="0"/>
-                <a:ea typeface="Cambria" pitchFamily="34" charset="-122"/>
-                <a:cs typeface="Cambria" pitchFamily="34" charset="-120"/>
+                <a:latin typeface="Helvetica Neue" pitchFamily="34" charset="0"/>
+                <a:ea typeface="Helvetica Neue" pitchFamily="34" charset="-122"/>
+                <a:cs typeface="Helvetica Neue" pitchFamily="34" charset="-120"/>
               </a:rPr>
               <a:t>System — Two-Tab Gradio App</a:t>
             </a:r>
@@ -5420,11 +5225,11 @@
                 <a:solidFill>
                   <a:srgbClr val="64748B"/>
                 </a:solidFill>
-                <a:latin typeface="Calibri" pitchFamily="34" charset="0"/>
-                <a:ea typeface="Calibri" pitchFamily="34" charset="-122"/>
-                <a:cs typeface="Calibri" pitchFamily="34" charset="-120"/>
-              </a:rPr>
-              <a:t>Rubric: 5 pts</a:t>
+                <a:latin typeface="Helvetica Neue" pitchFamily="34" charset="0"/>
+                <a:ea typeface="Helvetica Neue" pitchFamily="34" charset="-122"/>
+                <a:cs typeface="Helvetica Neue" pitchFamily="34" charset="-120"/>
+              </a:rPr>
+              <a:t>System</a:t>
             </a:r>
             <a:endParaRPr lang="en-US" sz="1100" dirty="0"/>
           </a:p>
@@ -5532,9 +5337,9 @@
                 <a:solidFill>
                   <a:srgbClr val="FFFFFF"/>
                 </a:solidFill>
-                <a:latin typeface="Cambria" pitchFamily="34" charset="0"/>
-                <a:ea typeface="Cambria" pitchFamily="34" charset="-122"/>
-                <a:cs typeface="Cambria" pitchFamily="34" charset="-120"/>
+                <a:latin typeface="Helvetica Neue" pitchFamily="34" charset="0"/>
+                <a:ea typeface="Helvetica Neue" pitchFamily="34" charset="-122"/>
+                <a:cs typeface="Helvetica Neue" pitchFamily="34" charset="-120"/>
               </a:rPr>
               <a:t>ATTACK  ·  clone a voice</a:t>
             </a:r>
@@ -5574,9 +5379,9 @@
                 <a:solidFill>
                   <a:srgbClr val="1E2761"/>
                 </a:solidFill>
-                <a:latin typeface="Calibri" pitchFamily="34" charset="0"/>
-                <a:ea typeface="Calibri" pitchFamily="34" charset="-122"/>
-                <a:cs typeface="Calibri" pitchFamily="34" charset="-120"/>
+                <a:latin typeface="Helvetica Neue" pitchFamily="34" charset="0"/>
+                <a:ea typeface="Helvetica Neue" pitchFamily="34" charset="-122"/>
+                <a:cs typeface="Helvetica Neue" pitchFamily="34" charset="-120"/>
               </a:rPr>
               <a:t>OpenVoice v2 (MyShell)</a:t>
             </a:r>
@@ -5595,9 +5400,9 @@
                 <a:solidFill>
                   <a:srgbClr val="0F172A"/>
                 </a:solidFill>
-                <a:latin typeface="Calibri" pitchFamily="34" charset="0"/>
-                <a:ea typeface="Calibri" pitchFamily="34" charset="-122"/>
-                <a:cs typeface="Calibri" pitchFamily="34" charset="-120"/>
+                <a:latin typeface="Helvetica Neue" pitchFamily="34" charset="0"/>
+                <a:ea typeface="Helvetica Neue" pitchFamily="34" charset="-122"/>
+                <a:cs typeface="Helvetica Neue" pitchFamily="34" charset="-120"/>
               </a:rPr>
               <a:t>Speaker embedding</a:t>
             </a:r>
@@ -5616,9 +5421,9 @@
                 <a:solidFill>
                   <a:srgbClr val="0F172A"/>
                 </a:solidFill>
-                <a:latin typeface="Calibri" pitchFamily="34" charset="0"/>
-                <a:ea typeface="Calibri" pitchFamily="34" charset="-122"/>
-                <a:cs typeface="Calibri" pitchFamily="34" charset="-120"/>
+                <a:latin typeface="Helvetica Neue" pitchFamily="34" charset="0"/>
+                <a:ea typeface="Helvetica Neue" pitchFamily="34" charset="-122"/>
+                <a:cs typeface="Helvetica Neue" pitchFamily="34" charset="-120"/>
               </a:rPr>
               <a:t>MeloTTS base waveform</a:t>
             </a:r>
@@ -5637,9 +5442,9 @@
                 <a:solidFill>
                   <a:srgbClr val="0F172A"/>
                 </a:solidFill>
-                <a:latin typeface="Calibri" pitchFamily="34" charset="0"/>
-                <a:ea typeface="Calibri" pitchFamily="34" charset="-122"/>
-                <a:cs typeface="Calibri" pitchFamily="34" charset="-120"/>
+                <a:latin typeface="Helvetica Neue" pitchFamily="34" charset="0"/>
+                <a:ea typeface="Helvetica Neue" pitchFamily="34" charset="-122"/>
+                <a:cs typeface="Helvetica Neue" pitchFamily="34" charset="-120"/>
               </a:rPr>
               <a:t>Tone-color conversion</a:t>
             </a:r>
@@ -5657,9 +5462,9 @@
                 <a:solidFill>
                   <a:srgbClr val="64748B"/>
                 </a:solidFill>
-                <a:latin typeface="Calibri" pitchFamily="34" charset="0"/>
-                <a:ea typeface="Calibri" pitchFamily="34" charset="-122"/>
-                <a:cs typeface="Calibri" pitchFamily="34" charset="-120"/>
+                <a:latin typeface="Helvetica Neue" pitchFamily="34" charset="0"/>
+                <a:ea typeface="Helvetica Neue" pitchFamily="34" charset="-122"/>
+                <a:cs typeface="Helvetica Neue" pitchFamily="34" charset="-120"/>
               </a:rPr>
               <a:t>Inputs:</a:t>
             </a:r>
@@ -5677,9 +5482,9 @@
                 <a:solidFill>
                   <a:srgbClr val="0F172A"/>
                 </a:solidFill>
-                <a:latin typeface="Calibri" pitchFamily="34" charset="0"/>
-                <a:ea typeface="Calibri" pitchFamily="34" charset="-122"/>
-                <a:cs typeface="Calibri" pitchFamily="34" charset="-120"/>
+                <a:latin typeface="Helvetica Neue" pitchFamily="34" charset="0"/>
+                <a:ea typeface="Helvetica Neue" pitchFamily="34" charset="-122"/>
+                <a:cs typeface="Helvetica Neue" pitchFamily="34" charset="-120"/>
               </a:rPr>
               <a:t>3–30 s reference audio + free text</a:t>
             </a:r>
@@ -5697,9 +5502,9 @@
                 <a:solidFill>
                   <a:srgbClr val="64748B"/>
                 </a:solidFill>
-                <a:latin typeface="Calibri" pitchFamily="34" charset="0"/>
-                <a:ea typeface="Calibri" pitchFamily="34" charset="-122"/>
-                <a:cs typeface="Calibri" pitchFamily="34" charset="-120"/>
+                <a:latin typeface="Helvetica Neue" pitchFamily="34" charset="0"/>
+                <a:ea typeface="Helvetica Neue" pitchFamily="34" charset="-122"/>
+                <a:cs typeface="Helvetica Neue" pitchFamily="34" charset="-120"/>
               </a:rPr>
               <a:t>Outputs:</a:t>
             </a:r>
@@ -5714,9 +5519,9 @@
                 <a:solidFill>
                   <a:srgbClr val="0F172A"/>
                 </a:solidFill>
-                <a:latin typeface="Calibri" pitchFamily="34" charset="0"/>
-                <a:ea typeface="Calibri" pitchFamily="34" charset="-122"/>
-                <a:cs typeface="Calibri" pitchFamily="34" charset="-120"/>
+                <a:latin typeface="Helvetica Neue" pitchFamily="34" charset="0"/>
+                <a:ea typeface="Helvetica Neue" pitchFamily="34" charset="-122"/>
+                <a:cs typeface="Helvetica Neue" pitchFamily="34" charset="-120"/>
               </a:rPr>
               <a:t>Cloned .wav  +  similarity score (0–100 %)</a:t>
             </a:r>
@@ -5778,9 +5583,9 @@
                 <a:solidFill>
                   <a:srgbClr val="FFFFFF"/>
                 </a:solidFill>
-                <a:latin typeface="Cambria" pitchFamily="34" charset="0"/>
-                <a:ea typeface="Cambria" pitchFamily="34" charset="-122"/>
-                <a:cs typeface="Cambria" pitchFamily="34" charset="-120"/>
+                <a:latin typeface="Helvetica Neue" pitchFamily="34" charset="0"/>
+                <a:ea typeface="Helvetica Neue" pitchFamily="34" charset="-122"/>
+                <a:cs typeface="Helvetica Neue" pitchFamily="34" charset="-120"/>
               </a:rPr>
               <a:t>→</a:t>
             </a:r>
@@ -5817,9 +5622,9 @@
                 <a:solidFill>
                   <a:srgbClr val="64748B"/>
                 </a:solidFill>
-                <a:latin typeface="Calibri" pitchFamily="34" charset="0"/>
-                <a:ea typeface="Calibri" pitchFamily="34" charset="-122"/>
-                <a:cs typeface="Calibri" pitchFamily="34" charset="-120"/>
+                <a:latin typeface="Helvetica Neue" pitchFamily="34" charset="0"/>
+                <a:ea typeface="Helvetica Neue" pitchFamily="34" charset="-122"/>
+                <a:cs typeface="Helvetica Neue" pitchFamily="34" charset="-120"/>
               </a:rPr>
               <a:t>Send to Shield</a:t>
             </a:r>
@@ -5906,9 +5711,9 @@
                 <a:solidFill>
                   <a:srgbClr val="FFFFFF"/>
                 </a:solidFill>
-                <a:latin typeface="Cambria" pitchFamily="34" charset="0"/>
-                <a:ea typeface="Cambria" pitchFamily="34" charset="-122"/>
-                <a:cs typeface="Cambria" pitchFamily="34" charset="-120"/>
+                <a:latin typeface="Helvetica Neue" pitchFamily="34" charset="0"/>
+                <a:ea typeface="Helvetica Neue" pitchFamily="34" charset="-122"/>
+                <a:cs typeface="Helvetica Neue" pitchFamily="34" charset="-120"/>
               </a:rPr>
               <a:t>SHIELD  ·  detect deepfake</a:t>
             </a:r>
@@ -5948,9 +5753,9 @@
                 <a:solidFill>
                   <a:srgbClr val="1E2761"/>
                 </a:solidFill>
-                <a:latin typeface="Calibri" pitchFamily="34" charset="0"/>
-                <a:ea typeface="Calibri" pitchFamily="34" charset="-122"/>
-                <a:cs typeface="Calibri" pitchFamily="34" charset="-120"/>
+                <a:latin typeface="Helvetica Neue" pitchFamily="34" charset="0"/>
+                <a:ea typeface="Helvetica Neue" pitchFamily="34" charset="-122"/>
+                <a:cs typeface="Helvetica Neue" pitchFamily="34" charset="-120"/>
               </a:rPr>
               <a:t>W2V-AASIST (Tak et al. 2022)</a:t>
             </a:r>
@@ -5969,9 +5774,9 @@
                 <a:solidFill>
                   <a:srgbClr val="0F172A"/>
                 </a:solidFill>
-                <a:latin typeface="Calibri" pitchFamily="34" charset="0"/>
-                <a:ea typeface="Calibri" pitchFamily="34" charset="-122"/>
-                <a:cs typeface="Calibri" pitchFamily="34" charset="-120"/>
+                <a:latin typeface="Helvetica Neue" pitchFamily="34" charset="0"/>
+                <a:ea typeface="Helvetica Neue" pitchFamily="34" charset="-122"/>
+                <a:cs typeface="Helvetica Neue" pitchFamily="34" charset="-120"/>
               </a:rPr>
               <a:t>wav2vec 2.0 XLSR (300 M params)</a:t>
             </a:r>
@@ -5990,9 +5795,9 @@
                 <a:solidFill>
                   <a:srgbClr val="0F172A"/>
                 </a:solidFill>
-                <a:latin typeface="Calibri" pitchFamily="34" charset="0"/>
-                <a:ea typeface="Calibri" pitchFamily="34" charset="-122"/>
-                <a:cs typeface="Calibri" pitchFamily="34" charset="-120"/>
+                <a:latin typeface="Helvetica Neue" pitchFamily="34" charset="0"/>
+                <a:ea typeface="Helvetica Neue" pitchFamily="34" charset="-122"/>
+                <a:cs typeface="Helvetica Neue" pitchFamily="34" charset="-120"/>
               </a:rPr>
               <a:t>AASIST graph-attention backend</a:t>
             </a:r>
@@ -6011,9 +5816,9 @@
                 <a:solidFill>
                   <a:srgbClr val="0F172A"/>
                 </a:solidFill>
-                <a:latin typeface="Calibri" pitchFamily="34" charset="0"/>
-                <a:ea typeface="Calibri" pitchFamily="34" charset="-122"/>
-                <a:cs typeface="Calibri" pitchFamily="34" charset="-120"/>
+                <a:latin typeface="Helvetica Neue" pitchFamily="34" charset="0"/>
+                <a:ea typeface="Helvetica Neue" pitchFamily="34" charset="-122"/>
+                <a:cs typeface="Helvetica Neue" pitchFamily="34" charset="-120"/>
               </a:rPr>
               <a:t>Softmax → spoof_prob</a:t>
             </a:r>
@@ -6031,9 +5836,9 @@
                 <a:solidFill>
                   <a:srgbClr val="64748B"/>
                 </a:solidFill>
-                <a:latin typeface="Calibri" pitchFamily="34" charset="0"/>
-                <a:ea typeface="Calibri" pitchFamily="34" charset="-122"/>
-                <a:cs typeface="Calibri" pitchFamily="34" charset="-120"/>
+                <a:latin typeface="Helvetica Neue" pitchFamily="34" charset="0"/>
+                <a:ea typeface="Helvetica Neue" pitchFamily="34" charset="-122"/>
+                <a:cs typeface="Helvetica Neue" pitchFamily="34" charset="-120"/>
               </a:rPr>
               <a:t>Outputs:</a:t>
             </a:r>
@@ -6051,9 +5856,9 @@
                 <a:solidFill>
                   <a:srgbClr val="0F172A"/>
                 </a:solidFill>
-                <a:latin typeface="Calibri" pitchFamily="34" charset="0"/>
-                <a:ea typeface="Calibri" pitchFamily="34" charset="-122"/>
-                <a:cs typeface="Calibri" pitchFamily="34" charset="-120"/>
+                <a:latin typeface="Helvetica Neue" pitchFamily="34" charset="0"/>
+                <a:ea typeface="Helvetica Neue" pitchFamily="34" charset="-122"/>
+                <a:cs typeface="Helvetica Neue" pitchFamily="34" charset="-120"/>
               </a:rPr>
               <a:t>Verdict: REAL / SUSPICIOUS / FAKE</a:t>
             </a:r>
@@ -6071,9 +5876,9 @@
                 <a:solidFill>
                   <a:srgbClr val="0F172A"/>
                 </a:solidFill>
-                <a:latin typeface="Calibri" pitchFamily="34" charset="0"/>
-                <a:ea typeface="Calibri" pitchFamily="34" charset="-122"/>
-                <a:cs typeface="Calibri" pitchFamily="34" charset="-120"/>
+                <a:latin typeface="Helvetica Neue" pitchFamily="34" charset="0"/>
+                <a:ea typeface="Helvetica Neue" pitchFamily="34" charset="-122"/>
+                <a:cs typeface="Helvetica Neue" pitchFamily="34" charset="-120"/>
               </a:rPr>
               <a:t>Confidence (0 – 100 %)</a:t>
             </a:r>
@@ -6091,9 +5896,9 @@
                 <a:solidFill>
                   <a:srgbClr val="0F172A"/>
                 </a:solidFill>
-                <a:latin typeface="Calibri" pitchFamily="34" charset="0"/>
-                <a:ea typeface="Calibri" pitchFamily="34" charset="-122"/>
-                <a:cs typeface="Calibri" pitchFamily="34" charset="-120"/>
+                <a:latin typeface="Helvetica Neue" pitchFamily="34" charset="0"/>
+                <a:ea typeface="Helvetica Neue" pitchFamily="34" charset="-122"/>
+                <a:cs typeface="Helvetica Neue" pitchFamily="34" charset="-120"/>
               </a:rPr>
               <a:t>8-feature acoustic dashboard</a:t>
             </a:r>
@@ -6108,9 +5913,9 @@
                 <a:solidFill>
                   <a:srgbClr val="0F172A"/>
                 </a:solidFill>
-                <a:latin typeface="Calibri" pitchFamily="34" charset="0"/>
-                <a:ea typeface="Calibri" pitchFamily="34" charset="-122"/>
-                <a:cs typeface="Calibri" pitchFamily="34" charset="-120"/>
+                <a:latin typeface="Helvetica Neue" pitchFamily="34" charset="0"/>
+                <a:ea typeface="Helvetica Neue" pitchFamily="34" charset="-122"/>
+                <a:cs typeface="Helvetica Neue" pitchFamily="34" charset="-120"/>
               </a:rPr>
               <a:t>Attention heatmap + spectrogram</a:t>
             </a:r>
@@ -6147,52 +5952,13 @@
                 <a:solidFill>
                   <a:srgbClr val="DD6B20"/>
                 </a:solidFill>
-                <a:latin typeface="Calibri" pitchFamily="34" charset="0"/>
-                <a:ea typeface="Calibri" pitchFamily="34" charset="-122"/>
-                <a:cs typeface="Calibri" pitchFamily="34" charset="-120"/>
+                <a:latin typeface="Helvetica Neue" pitchFamily="34" charset="0"/>
+                <a:ea typeface="Helvetica Neue" pitchFamily="34" charset="-122"/>
+                <a:cs typeface="Helvetica Neue" pitchFamily="34" charset="-120"/>
               </a:rPr>
               <a:t>Live demo end-to-end in  &lt; 30 s</a:t>
             </a:r>
             <a:endParaRPr lang="en-US" sz="1300" dirty="0"/>
-          </a:p>
-        </p:txBody>
-      </p:sp>
-      <p:sp>
-        <p:nvSpPr>
-          <p:cNvPr id="18" name="Text 16"/>
-          <p:cNvSpPr/>
-          <p:nvPr/>
-        </p:nvSpPr>
-        <p:spPr>
-          <a:xfrm>
-            <a:off x="411480" y="6537960"/>
-            <a:ext cx="11338560" cy="228600"/>
-          </a:xfrm>
-          <a:prstGeom prst="rect">
-            <a:avLst/>
-          </a:prstGeom>
-          <a:noFill/>
-          <a:ln/>
-        </p:spPr>
-        <p:txBody>
-          <a:bodyPr wrap="square" lIns="0" tIns="0" rIns="0" bIns="0" rtlCol="0" anchor="ctr"/>
-          <a:lstStyle/>
-          <a:p>
-            <a:pPr algn="r" indent="0" marL="0">
-              <a:buNone/>
-            </a:pPr>
-            <a:r>
-              <a:rPr lang="en-US" sz="900" dirty="0">
-                <a:solidFill>
-                  <a:srgbClr val="64748B"/>
-                </a:solidFill>
-                <a:latin typeface="Calibri" pitchFamily="34" charset="0"/>
-                <a:ea typeface="Calibri" pitchFamily="34" charset="-122"/>
-                <a:cs typeface="Calibri" pitchFamily="34" charset="-120"/>
-              </a:rPr>
-              <a:t>VoiceGuard · 3 / 13</a:t>
-            </a:r>
-            <a:endParaRPr lang="en-US" sz="900" dirty="0"/>
           </a:p>
         </p:txBody>
       </p:sp>
@@ -6282,9 +6048,9 @@
                 <a:solidFill>
                   <a:srgbClr val="1E2761"/>
                 </a:solidFill>
-                <a:latin typeface="Cambria" pitchFamily="34" charset="0"/>
-                <a:ea typeface="Cambria" pitchFamily="34" charset="-122"/>
-                <a:cs typeface="Cambria" pitchFamily="34" charset="-120"/>
+                <a:latin typeface="Helvetica Neue" pitchFamily="34" charset="0"/>
+                <a:ea typeface="Helvetica Neue" pitchFamily="34" charset="-122"/>
+                <a:cs typeface="Helvetica Neue" pitchFamily="34" charset="-120"/>
               </a:rPr>
               <a:t>Replicated  vs.  Added</a:t>
             </a:r>
@@ -6321,11 +6087,11 @@
                 <a:solidFill>
                   <a:srgbClr val="64748B"/>
                 </a:solidFill>
-                <a:latin typeface="Calibri" pitchFamily="34" charset="0"/>
-                <a:ea typeface="Calibri" pitchFamily="34" charset="-122"/>
-                <a:cs typeface="Calibri" pitchFamily="34" charset="-120"/>
-              </a:rPr>
-              <a:t>Rubric: 5 pts (System)</a:t>
+                <a:latin typeface="Helvetica Neue" pitchFamily="34" charset="0"/>
+                <a:ea typeface="Helvetica Neue" pitchFamily="34" charset="-122"/>
+                <a:cs typeface="Helvetica Neue" pitchFamily="34" charset="-120"/>
+              </a:rPr>
+              <a:t>System</a:t>
             </a:r>
             <a:endParaRPr lang="en-US" sz="1100" dirty="0"/>
           </a:p>
@@ -6395,16 +6161,16 @@
                           <a:solidFill>
                             <a:srgbClr val="FFFFFF"/>
                           </a:solidFill>
-                          <a:latin typeface="Calibri" pitchFamily="34" charset="0"/>
-                          <a:ea typeface="Calibri" pitchFamily="34" charset="-122"/>
-                          <a:cs typeface="Calibri" pitchFamily="34" charset="-120"/>
+                          <a:latin typeface="Helvetica Neue" pitchFamily="34" charset="0"/>
+                          <a:ea typeface="Helvetica Neue" pitchFamily="34" charset="-122"/>
+                          <a:cs typeface="Helvetica Neue" pitchFamily="34" charset="-120"/>
                         </a:rPr>
                         <a:t>Component</a:t>
                       </a:r>
                       <a:endParaRPr lang="en-US" sz="1400" dirty="0">
-                        <a:latin typeface="Calibri" charset="0"/>
-                        <a:ea typeface="Calibri" charset="0"/>
-                        <a:cs typeface="Calibri" charset="0"/>
+                        <a:latin typeface="Helvetica Neue" charset="0"/>
+                        <a:ea typeface="Helvetica Neue" charset="0"/>
+                        <a:cs typeface="Helvetica Neue" charset="0"/>
                       </a:endParaRPr>
                     </a:p>
                   </a:txBody>
@@ -6463,16 +6229,16 @@
                           <a:solidFill>
                             <a:srgbClr val="FFFFFF"/>
                           </a:solidFill>
-                          <a:latin typeface="Calibri" pitchFamily="34" charset="0"/>
-                          <a:ea typeface="Calibri" pitchFamily="34" charset="-122"/>
-                          <a:cs typeface="Calibri" pitchFamily="34" charset="-120"/>
+                          <a:latin typeface="Helvetica Neue" pitchFamily="34" charset="0"/>
+                          <a:ea typeface="Helvetica Neue" pitchFamily="34" charset="-122"/>
+                          <a:cs typeface="Helvetica Neue" pitchFamily="34" charset="-120"/>
                         </a:rPr>
                         <a:t>Source</a:t>
                       </a:r>
                       <a:endParaRPr lang="en-US" sz="1400" dirty="0">
-                        <a:latin typeface="Calibri" charset="0"/>
-                        <a:ea typeface="Calibri" charset="0"/>
-                        <a:cs typeface="Calibri" charset="0"/>
+                        <a:latin typeface="Helvetica Neue" charset="0"/>
+                        <a:ea typeface="Helvetica Neue" charset="0"/>
+                        <a:cs typeface="Helvetica Neue" charset="0"/>
                       </a:endParaRPr>
                     </a:p>
                   </a:txBody>
@@ -6531,16 +6297,16 @@
                           <a:solidFill>
                             <a:srgbClr val="FFFFFF"/>
                           </a:solidFill>
-                          <a:latin typeface="Calibri" pitchFamily="34" charset="0"/>
-                          <a:ea typeface="Calibri" pitchFamily="34" charset="-122"/>
-                          <a:cs typeface="Calibri" pitchFamily="34" charset="-120"/>
+                          <a:latin typeface="Helvetica Neue" pitchFamily="34" charset="0"/>
+                          <a:ea typeface="Helvetica Neue" pitchFamily="34" charset="-122"/>
+                          <a:cs typeface="Helvetica Neue" pitchFamily="34" charset="-120"/>
                         </a:rPr>
                         <a:t>Our change</a:t>
                       </a:r>
                       <a:endParaRPr lang="en-US" sz="1400" dirty="0">
-                        <a:latin typeface="Calibri" charset="0"/>
-                        <a:ea typeface="Calibri" charset="0"/>
-                        <a:cs typeface="Calibri" charset="0"/>
+                        <a:latin typeface="Helvetica Neue" charset="0"/>
+                        <a:ea typeface="Helvetica Neue" charset="0"/>
+                        <a:cs typeface="Helvetica Neue" charset="0"/>
                       </a:endParaRPr>
                     </a:p>
                   </a:txBody>
@@ -6601,16 +6367,16 @@
                           <a:solidFill>
                             <a:srgbClr val="0F172A"/>
                           </a:solidFill>
-                          <a:latin typeface="Calibri" pitchFamily="34" charset="0"/>
-                          <a:ea typeface="Calibri" pitchFamily="34" charset="-122"/>
-                          <a:cs typeface="Calibri" pitchFamily="34" charset="-120"/>
+                          <a:latin typeface="Helvetica Neue" pitchFamily="34" charset="0"/>
+                          <a:ea typeface="Helvetica Neue" pitchFamily="34" charset="-122"/>
+                          <a:cs typeface="Helvetica Neue" pitchFamily="34" charset="-120"/>
                         </a:rPr>
                         <a:t>OpenVoice v2</a:t>
                       </a:r>
                       <a:endParaRPr lang="en-US" sz="1250" dirty="0">
-                        <a:latin typeface="Calibri" charset="0"/>
-                        <a:ea typeface="Calibri" charset="0"/>
-                        <a:cs typeface="Calibri" charset="0"/>
+                        <a:latin typeface="Helvetica Neue" charset="0"/>
+                        <a:ea typeface="Helvetica Neue" charset="0"/>
+                        <a:cs typeface="Helvetica Neue" charset="0"/>
                       </a:endParaRPr>
                     </a:p>
                   </a:txBody>
@@ -6666,16 +6432,16 @@
                           <a:solidFill>
                             <a:srgbClr val="0F172A"/>
                           </a:solidFill>
-                          <a:latin typeface="Calibri" pitchFamily="34" charset="0"/>
-                          <a:ea typeface="Calibri" pitchFamily="34" charset="-122"/>
-                          <a:cs typeface="Calibri" pitchFamily="34" charset="-120"/>
+                          <a:latin typeface="Helvetica Neue" pitchFamily="34" charset="0"/>
+                          <a:ea typeface="Helvetica Neue" pitchFamily="34" charset="-122"/>
+                          <a:cs typeface="Helvetica Neue" pitchFamily="34" charset="-120"/>
                         </a:rPr>
                         <a:t>MyShell (MIT)</a:t>
                       </a:r>
                       <a:endParaRPr lang="en-US" sz="1250" dirty="0">
-                        <a:latin typeface="Calibri" charset="0"/>
-                        <a:ea typeface="Calibri" charset="0"/>
-                        <a:cs typeface="Calibri" charset="0"/>
+                        <a:latin typeface="Helvetica Neue" charset="0"/>
+                        <a:ea typeface="Helvetica Neue" charset="0"/>
+                        <a:cs typeface="Helvetica Neue" charset="0"/>
                       </a:endParaRPr>
                     </a:p>
                   </a:txBody>
@@ -6731,16 +6497,16 @@
                           <a:solidFill>
                             <a:srgbClr val="64748B"/>
                           </a:solidFill>
-                          <a:latin typeface="Calibri" pitchFamily="34" charset="0"/>
-                          <a:ea typeface="Calibri" pitchFamily="34" charset="-122"/>
-                          <a:cs typeface="Calibri" pitchFamily="34" charset="-120"/>
+                          <a:latin typeface="Helvetica Neue" pitchFamily="34" charset="0"/>
+                          <a:ea typeface="Helvetica Neue" pitchFamily="34" charset="-122"/>
+                          <a:cs typeface="Helvetica Neue" pitchFamily="34" charset="-120"/>
                         </a:rPr>
                         <a:t>used as-is</a:t>
                       </a:r>
                       <a:endParaRPr lang="en-US" sz="1250" dirty="0">
-                        <a:latin typeface="Calibri" charset="0"/>
-                        <a:ea typeface="Calibri" charset="0"/>
-                        <a:cs typeface="Calibri" charset="0"/>
+                        <a:latin typeface="Helvetica Neue" charset="0"/>
+                        <a:ea typeface="Helvetica Neue" charset="0"/>
+                        <a:cs typeface="Helvetica Neue" charset="0"/>
                       </a:endParaRPr>
                     </a:p>
                   </a:txBody>
@@ -6798,16 +6564,16 @@
                           <a:solidFill>
                             <a:srgbClr val="0F172A"/>
                           </a:solidFill>
-                          <a:latin typeface="Calibri" pitchFamily="34" charset="0"/>
-                          <a:ea typeface="Calibri" pitchFamily="34" charset="-122"/>
-                          <a:cs typeface="Calibri" pitchFamily="34" charset="-120"/>
+                          <a:latin typeface="Helvetica Neue" pitchFamily="34" charset="0"/>
+                          <a:ea typeface="Helvetica Neue" pitchFamily="34" charset="-122"/>
+                          <a:cs typeface="Helvetica Neue" pitchFamily="34" charset="-120"/>
                         </a:rPr>
                         <a:t>W2V-AASIST  +  best_SSL_model_DF.pth</a:t>
                       </a:r>
                       <a:endParaRPr lang="en-US" sz="1250" dirty="0">
-                        <a:latin typeface="Calibri" charset="0"/>
-                        <a:ea typeface="Calibri" charset="0"/>
-                        <a:cs typeface="Calibri" charset="0"/>
+                        <a:latin typeface="Helvetica Neue" charset="0"/>
+                        <a:ea typeface="Helvetica Neue" charset="0"/>
+                        <a:cs typeface="Helvetica Neue" charset="0"/>
                       </a:endParaRPr>
                     </a:p>
                   </a:txBody>
@@ -6863,16 +6629,16 @@
                           <a:solidFill>
                             <a:srgbClr val="0F172A"/>
                           </a:solidFill>
-                          <a:latin typeface="Calibri" pitchFamily="34" charset="0"/>
-                          <a:ea typeface="Calibri" pitchFamily="34" charset="-122"/>
-                          <a:cs typeface="Calibri" pitchFamily="34" charset="-120"/>
+                          <a:latin typeface="Helvetica Neue" pitchFamily="34" charset="0"/>
+                          <a:ea typeface="Helvetica Neue" pitchFamily="34" charset="-122"/>
+                          <a:cs typeface="Helvetica Neue" pitchFamily="34" charset="-120"/>
                         </a:rPr>
                         <a:t>Tak et al. (MIT)</a:t>
                       </a:r>
                       <a:endParaRPr lang="en-US" sz="1250" dirty="0">
-                        <a:latin typeface="Calibri" charset="0"/>
-                        <a:ea typeface="Calibri" charset="0"/>
-                        <a:cs typeface="Calibri" charset="0"/>
+                        <a:latin typeface="Helvetica Neue" charset="0"/>
+                        <a:ea typeface="Helvetica Neue" charset="0"/>
+                        <a:cs typeface="Helvetica Neue" charset="0"/>
                       </a:endParaRPr>
                     </a:p>
                   </a:txBody>
@@ -6928,16 +6694,16 @@
                           <a:solidFill>
                             <a:srgbClr val="64748B"/>
                           </a:solidFill>
-                          <a:latin typeface="Calibri" pitchFamily="34" charset="0"/>
-                          <a:ea typeface="Calibri" pitchFamily="34" charset="-122"/>
-                          <a:cs typeface="Calibri" pitchFamily="34" charset="-120"/>
+                          <a:latin typeface="Helvetica Neue" pitchFamily="34" charset="0"/>
+                          <a:ea typeface="Helvetica Neue" pitchFamily="34" charset="-122"/>
+                          <a:cs typeface="Helvetica Neue" pitchFamily="34" charset="-120"/>
                         </a:rPr>
                         <a:t>used pretrained weights</a:t>
                       </a:r>
                       <a:endParaRPr lang="en-US" sz="1250" dirty="0">
-                        <a:latin typeface="Calibri" charset="0"/>
-                        <a:ea typeface="Calibri" charset="0"/>
-                        <a:cs typeface="Calibri" charset="0"/>
+                        <a:latin typeface="Helvetica Neue" charset="0"/>
+                        <a:ea typeface="Helvetica Neue" charset="0"/>
+                        <a:cs typeface="Helvetica Neue" charset="0"/>
                       </a:endParaRPr>
                     </a:p>
                   </a:txBody>
@@ -6995,16 +6761,16 @@
                           <a:solidFill>
                             <a:srgbClr val="0F172A"/>
                           </a:solidFill>
-                          <a:latin typeface="Calibri" pitchFamily="34" charset="0"/>
-                          <a:ea typeface="Calibri" pitchFamily="34" charset="-122"/>
-                          <a:cs typeface="Calibri" pitchFamily="34" charset="-120"/>
+                          <a:latin typeface="Helvetica Neue" pitchFamily="34" charset="0"/>
+                          <a:ea typeface="Helvetica Neue" pitchFamily="34" charset="-122"/>
+                          <a:cs typeface="Helvetica Neue" pitchFamily="34" charset="-120"/>
                         </a:rPr>
                         <a:t>Gradio two-tab app</a:t>
                       </a:r>
                       <a:endParaRPr lang="en-US" sz="1250" dirty="0">
-                        <a:latin typeface="Calibri" charset="0"/>
-                        <a:ea typeface="Calibri" charset="0"/>
-                        <a:cs typeface="Calibri" charset="0"/>
+                        <a:latin typeface="Helvetica Neue" charset="0"/>
+                        <a:ea typeface="Helvetica Neue" charset="0"/>
+                        <a:cs typeface="Helvetica Neue" charset="0"/>
                       </a:endParaRPr>
                     </a:p>
                   </a:txBody>
@@ -7060,16 +6826,16 @@
                           <a:solidFill>
                             <a:srgbClr val="64748B"/>
                           </a:solidFill>
-                          <a:latin typeface="Calibri" pitchFamily="34" charset="0"/>
-                          <a:ea typeface="Calibri" pitchFamily="34" charset="-122"/>
-                          <a:cs typeface="Calibri" pitchFamily="34" charset="-120"/>
+                          <a:latin typeface="Helvetica Neue" pitchFamily="34" charset="0"/>
+                          <a:ea typeface="Helvetica Neue" pitchFamily="34" charset="-122"/>
+                          <a:cs typeface="Helvetica Neue" pitchFamily="34" charset="-120"/>
                         </a:rPr>
                         <a:t>—</a:t>
                       </a:r>
                       <a:endParaRPr lang="en-US" sz="1250" dirty="0">
-                        <a:latin typeface="Calibri" charset="0"/>
-                        <a:ea typeface="Calibri" charset="0"/>
-                        <a:cs typeface="Calibri" charset="0"/>
+                        <a:latin typeface="Helvetica Neue" charset="0"/>
+                        <a:ea typeface="Helvetica Neue" charset="0"/>
+                        <a:cs typeface="Helvetica Neue" charset="0"/>
                       </a:endParaRPr>
                     </a:p>
                   </a:txBody>
@@ -7125,16 +6891,16 @@
                           <a:solidFill>
                             <a:srgbClr val="0F172A"/>
                           </a:solidFill>
-                          <a:latin typeface="Calibri" pitchFamily="34" charset="0"/>
-                          <a:ea typeface="Calibri" pitchFamily="34" charset="-122"/>
-                          <a:cs typeface="Calibri" pitchFamily="34" charset="-120"/>
+                          <a:latin typeface="Helvetica Neue" pitchFamily="34" charset="0"/>
+                          <a:ea typeface="Helvetica Neue" pitchFamily="34" charset="-122"/>
+                          <a:cs typeface="Helvetica Neue" pitchFamily="34" charset="-120"/>
                         </a:rPr>
                         <a:t>built from scratch</a:t>
                       </a:r>
                       <a:endParaRPr lang="en-US" sz="1250" dirty="0">
-                        <a:latin typeface="Calibri" charset="0"/>
-                        <a:ea typeface="Calibri" charset="0"/>
-                        <a:cs typeface="Calibri" charset="0"/>
+                        <a:latin typeface="Helvetica Neue" charset="0"/>
+                        <a:ea typeface="Helvetica Neue" charset="0"/>
+                        <a:cs typeface="Helvetica Neue" charset="0"/>
                       </a:endParaRPr>
                     </a:p>
                   </a:txBody>
@@ -7192,16 +6958,16 @@
                           <a:solidFill>
                             <a:srgbClr val="0F172A"/>
                           </a:solidFill>
-                          <a:latin typeface="Calibri" pitchFamily="34" charset="0"/>
-                          <a:ea typeface="Calibri" pitchFamily="34" charset="-122"/>
-                          <a:cs typeface="Calibri" pitchFamily="34" charset="-120"/>
+                          <a:latin typeface="Helvetica Neue" pitchFamily="34" charset="0"/>
+                          <a:ea typeface="Helvetica Neue" pitchFamily="34" charset="-122"/>
+                          <a:cs typeface="Helvetica Neue" pitchFamily="34" charset="-120"/>
                         </a:rPr>
                         <a:t>"Send to Shield" workflow</a:t>
                       </a:r>
                       <a:endParaRPr lang="en-US" sz="1250" dirty="0">
-                        <a:latin typeface="Calibri" charset="0"/>
-                        <a:ea typeface="Calibri" charset="0"/>
-                        <a:cs typeface="Calibri" charset="0"/>
+                        <a:latin typeface="Helvetica Neue" charset="0"/>
+                        <a:ea typeface="Helvetica Neue" charset="0"/>
+                        <a:cs typeface="Helvetica Neue" charset="0"/>
                       </a:endParaRPr>
                     </a:p>
                   </a:txBody>
@@ -7257,16 +7023,16 @@
                           <a:solidFill>
                             <a:srgbClr val="64748B"/>
                           </a:solidFill>
-                          <a:latin typeface="Calibri" pitchFamily="34" charset="0"/>
-                          <a:ea typeface="Calibri" pitchFamily="34" charset="-122"/>
-                          <a:cs typeface="Calibri" pitchFamily="34" charset="-120"/>
+                          <a:latin typeface="Helvetica Neue" pitchFamily="34" charset="0"/>
+                          <a:ea typeface="Helvetica Neue" pitchFamily="34" charset="-122"/>
+                          <a:cs typeface="Helvetica Neue" pitchFamily="34" charset="-120"/>
                         </a:rPr>
                         <a:t>—</a:t>
                       </a:r>
                       <a:endParaRPr lang="en-US" sz="1250" dirty="0">
-                        <a:latin typeface="Calibri" charset="0"/>
-                        <a:ea typeface="Calibri" charset="0"/>
-                        <a:cs typeface="Calibri" charset="0"/>
+                        <a:latin typeface="Helvetica Neue" charset="0"/>
+                        <a:ea typeface="Helvetica Neue" charset="0"/>
+                        <a:cs typeface="Helvetica Neue" charset="0"/>
                       </a:endParaRPr>
                     </a:p>
                   </a:txBody>
@@ -7322,16 +7088,16 @@
                           <a:solidFill>
                             <a:srgbClr val="0F172A"/>
                           </a:solidFill>
-                          <a:latin typeface="Calibri" pitchFamily="34" charset="0"/>
-                          <a:ea typeface="Calibri" pitchFamily="34" charset="-122"/>
-                          <a:cs typeface="Calibri" pitchFamily="34" charset="-120"/>
+                          <a:latin typeface="Helvetica Neue" pitchFamily="34" charset="0"/>
+                          <a:ea typeface="Helvetica Neue" pitchFamily="34" charset="-122"/>
+                          <a:cs typeface="Helvetica Neue" pitchFamily="34" charset="-120"/>
                         </a:rPr>
                         <a:t>built from scratch</a:t>
                       </a:r>
                       <a:endParaRPr lang="en-US" sz="1250" dirty="0">
-                        <a:latin typeface="Calibri" charset="0"/>
-                        <a:ea typeface="Calibri" charset="0"/>
-                        <a:cs typeface="Calibri" charset="0"/>
+                        <a:latin typeface="Helvetica Neue" charset="0"/>
+                        <a:ea typeface="Helvetica Neue" charset="0"/>
+                        <a:cs typeface="Helvetica Neue" charset="0"/>
                       </a:endParaRPr>
                     </a:p>
                   </a:txBody>
@@ -7389,16 +7155,16 @@
                           <a:solidFill>
                             <a:srgbClr val="0F172A"/>
                           </a:solidFill>
-                          <a:latin typeface="Calibri" pitchFamily="34" charset="0"/>
-                          <a:ea typeface="Calibri" pitchFamily="34" charset="-122"/>
-                          <a:cs typeface="Calibri" pitchFamily="34" charset="-120"/>
+                          <a:latin typeface="Helvetica Neue" pitchFamily="34" charset="0"/>
+                          <a:ea typeface="Helvetica Neue" pitchFamily="34" charset="-122"/>
+                          <a:cs typeface="Helvetica Neue" pitchFamily="34" charset="-120"/>
                         </a:rPr>
                         <a:t>AASIST attention heatmap overlay</a:t>
                       </a:r>
                       <a:endParaRPr lang="en-US" sz="1250" dirty="0">
-                        <a:latin typeface="Calibri" charset="0"/>
-                        <a:ea typeface="Calibri" charset="0"/>
-                        <a:cs typeface="Calibri" charset="0"/>
+                        <a:latin typeface="Helvetica Neue" charset="0"/>
+                        <a:ea typeface="Helvetica Neue" charset="0"/>
+                        <a:cs typeface="Helvetica Neue" charset="0"/>
                       </a:endParaRPr>
                     </a:p>
                   </a:txBody>
@@ -7454,16 +7220,16 @@
                           <a:solidFill>
                             <a:srgbClr val="64748B"/>
                           </a:solidFill>
-                          <a:latin typeface="Calibri" pitchFamily="34" charset="0"/>
-                          <a:ea typeface="Calibri" pitchFamily="34" charset="-122"/>
-                          <a:cs typeface="Calibri" pitchFamily="34" charset="-120"/>
+                          <a:latin typeface="Helvetica Neue" pitchFamily="34" charset="0"/>
+                          <a:ea typeface="Helvetica Neue" pitchFamily="34" charset="-122"/>
+                          <a:cs typeface="Helvetica Neue" pitchFamily="34" charset="-120"/>
                         </a:rPr>
                         <a:t>—</a:t>
                       </a:r>
                       <a:endParaRPr lang="en-US" sz="1250" dirty="0">
-                        <a:latin typeface="Calibri" charset="0"/>
-                        <a:ea typeface="Calibri" charset="0"/>
-                        <a:cs typeface="Calibri" charset="0"/>
+                        <a:latin typeface="Helvetica Neue" charset="0"/>
+                        <a:ea typeface="Helvetica Neue" charset="0"/>
+                        <a:cs typeface="Helvetica Neue" charset="0"/>
                       </a:endParaRPr>
                     </a:p>
                   </a:txBody>
@@ -7519,16 +7285,16 @@
                           <a:solidFill>
                             <a:srgbClr val="0F172A"/>
                           </a:solidFill>
-                          <a:latin typeface="Calibri" pitchFamily="34" charset="0"/>
-                          <a:ea typeface="Calibri" pitchFamily="34" charset="-122"/>
-                          <a:cs typeface="Calibri" pitchFamily="34" charset="-120"/>
+                          <a:latin typeface="Helvetica Neue" pitchFamily="34" charset="0"/>
+                          <a:ea typeface="Helvetica Neue" pitchFamily="34" charset="-122"/>
+                          <a:cs typeface="Helvetica Neue" pitchFamily="34" charset="-120"/>
                         </a:rPr>
                         <a:t>attention × mel spectrogram</a:t>
                       </a:r>
                       <a:endParaRPr lang="en-US" sz="1250" dirty="0">
-                        <a:latin typeface="Calibri" charset="0"/>
-                        <a:ea typeface="Calibri" charset="0"/>
-                        <a:cs typeface="Calibri" charset="0"/>
+                        <a:latin typeface="Helvetica Neue" charset="0"/>
+                        <a:ea typeface="Helvetica Neue" charset="0"/>
+                        <a:cs typeface="Helvetica Neue" charset="0"/>
                       </a:endParaRPr>
                     </a:p>
                   </a:txBody>
@@ -7586,16 +7352,16 @@
                           <a:solidFill>
                             <a:srgbClr val="0F172A"/>
                           </a:solidFill>
-                          <a:latin typeface="Calibri" pitchFamily="34" charset="0"/>
-                          <a:ea typeface="Calibri" pitchFamily="34" charset="-122"/>
-                          <a:cs typeface="Calibri" pitchFamily="34" charset="-120"/>
+                          <a:latin typeface="Helvetica Neue" pitchFamily="34" charset="0"/>
+                          <a:ea typeface="Helvetica Neue" pitchFamily="34" charset="-122"/>
+                          <a:cs typeface="Helvetica Neue" pitchFamily="34" charset="-120"/>
                         </a:rPr>
                         <a:t>8-feature acoustic dashboard</a:t>
                       </a:r>
                       <a:endParaRPr lang="en-US" sz="1250" dirty="0">
-                        <a:latin typeface="Calibri" charset="0"/>
-                        <a:ea typeface="Calibri" charset="0"/>
-                        <a:cs typeface="Calibri" charset="0"/>
+                        <a:latin typeface="Helvetica Neue" charset="0"/>
+                        <a:ea typeface="Helvetica Neue" charset="0"/>
+                        <a:cs typeface="Helvetica Neue" charset="0"/>
                       </a:endParaRPr>
                     </a:p>
                   </a:txBody>
@@ -7651,16 +7417,16 @@
                           <a:solidFill>
                             <a:srgbClr val="0F172A"/>
                           </a:solidFill>
-                          <a:latin typeface="Calibri" pitchFamily="34" charset="0"/>
-                          <a:ea typeface="Calibri" pitchFamily="34" charset="-122"/>
-                          <a:cs typeface="Calibri" pitchFamily="34" charset="-120"/>
+                          <a:latin typeface="Helvetica Neue" pitchFamily="34" charset="0"/>
+                          <a:ea typeface="Helvetica Neue" pitchFamily="34" charset="-122"/>
+                          <a:cs typeface="Helvetica Neue" pitchFamily="34" charset="-120"/>
                         </a:rPr>
                         <a:t>librosa</a:t>
                       </a:r>
                       <a:endParaRPr lang="en-US" sz="1250" dirty="0">
-                        <a:latin typeface="Calibri" charset="0"/>
-                        <a:ea typeface="Calibri" charset="0"/>
-                        <a:cs typeface="Calibri" charset="0"/>
+                        <a:latin typeface="Helvetica Neue" charset="0"/>
+                        <a:ea typeface="Helvetica Neue" charset="0"/>
+                        <a:cs typeface="Helvetica Neue" charset="0"/>
                       </a:endParaRPr>
                     </a:p>
                   </a:txBody>
@@ -7716,16 +7482,16 @@
                           <a:solidFill>
                             <a:srgbClr val="0F172A"/>
                           </a:solidFill>
-                          <a:latin typeface="Calibri" pitchFamily="34" charset="0"/>
-                          <a:ea typeface="Calibri" pitchFamily="34" charset="-122"/>
-                          <a:cs typeface="Calibri" pitchFamily="34" charset="-120"/>
+                          <a:latin typeface="Helvetica Neue" pitchFamily="34" charset="0"/>
+                          <a:ea typeface="Helvetica Neue" pitchFamily="34" charset="-122"/>
+                          <a:cs typeface="Helvetica Neue" pitchFamily="34" charset="-120"/>
                         </a:rPr>
                         <a:t>dashboard  +  UI integration</a:t>
                       </a:r>
                       <a:endParaRPr lang="en-US" sz="1250" dirty="0">
-                        <a:latin typeface="Calibri" charset="0"/>
-                        <a:ea typeface="Calibri" charset="0"/>
-                        <a:cs typeface="Calibri" charset="0"/>
+                        <a:latin typeface="Helvetica Neue" charset="0"/>
+                        <a:ea typeface="Helvetica Neue" charset="0"/>
+                        <a:cs typeface="Helvetica Neue" charset="0"/>
                       </a:endParaRPr>
                     </a:p>
                   </a:txBody>
@@ -7783,16 +7549,16 @@
                           <a:solidFill>
                             <a:srgbClr val="0F172A"/>
                           </a:solidFill>
-                          <a:latin typeface="Calibri" pitchFamily="34" charset="0"/>
-                          <a:ea typeface="Calibri" pitchFamily="34" charset="-122"/>
-                          <a:cs typeface="Calibri" pitchFamily="34" charset="-120"/>
+                          <a:latin typeface="Helvetica Neue" pitchFamily="34" charset="0"/>
+                          <a:ea typeface="Helvetica Neue" pitchFamily="34" charset="-122"/>
+                          <a:cs typeface="Helvetica Neue" pitchFamily="34" charset="-120"/>
                         </a:rPr>
                         <a:t>Dataset-wide eval pipeline</a:t>
                       </a:r>
                       <a:endParaRPr lang="en-US" sz="1250" dirty="0">
-                        <a:latin typeface="Calibri" charset="0"/>
-                        <a:ea typeface="Calibri" charset="0"/>
-                        <a:cs typeface="Calibri" charset="0"/>
+                        <a:latin typeface="Helvetica Neue" charset="0"/>
+                        <a:ea typeface="Helvetica Neue" charset="0"/>
+                        <a:cs typeface="Helvetica Neue" charset="0"/>
                       </a:endParaRPr>
                     </a:p>
                   </a:txBody>
@@ -7848,16 +7614,16 @@
                           <a:solidFill>
                             <a:srgbClr val="64748B"/>
                           </a:solidFill>
-                          <a:latin typeface="Calibri" pitchFamily="34" charset="0"/>
-                          <a:ea typeface="Calibri" pitchFamily="34" charset="-122"/>
-                          <a:cs typeface="Calibri" pitchFamily="34" charset="-120"/>
+                          <a:latin typeface="Helvetica Neue" pitchFamily="34" charset="0"/>
+                          <a:ea typeface="Helvetica Neue" pitchFamily="34" charset="-122"/>
+                          <a:cs typeface="Helvetica Neue" pitchFamily="34" charset="-120"/>
                         </a:rPr>
                         <a:t>—</a:t>
                       </a:r>
                       <a:endParaRPr lang="en-US" sz="1250" dirty="0">
-                        <a:latin typeface="Calibri" charset="0"/>
-                        <a:ea typeface="Calibri" charset="0"/>
-                        <a:cs typeface="Calibri" charset="0"/>
+                        <a:latin typeface="Helvetica Neue" charset="0"/>
+                        <a:ea typeface="Helvetica Neue" charset="0"/>
+                        <a:cs typeface="Helvetica Neue" charset="0"/>
                       </a:endParaRPr>
                     </a:p>
                   </a:txBody>
@@ -7913,16 +7679,16 @@
                           <a:solidFill>
                             <a:srgbClr val="0F172A"/>
                           </a:solidFill>
-                          <a:latin typeface="Calibri" pitchFamily="34" charset="0"/>
-                          <a:ea typeface="Calibri" pitchFamily="34" charset="-122"/>
-                          <a:cs typeface="Calibri" pitchFamily="34" charset="-120"/>
+                          <a:latin typeface="Helvetica Neue" pitchFamily="34" charset="0"/>
+                          <a:ea typeface="Helvetica Neue" pitchFamily="34" charset="-122"/>
+                          <a:cs typeface="Helvetica Neue" pitchFamily="34" charset="-120"/>
                         </a:rPr>
                         <a:t>scripts/eval_asvspoof.py (71 k eval)</a:t>
                       </a:r>
                       <a:endParaRPr lang="en-US" sz="1250" dirty="0">
-                        <a:latin typeface="Calibri" charset="0"/>
-                        <a:ea typeface="Calibri" charset="0"/>
-                        <a:cs typeface="Calibri" charset="0"/>
+                        <a:latin typeface="Helvetica Neue" charset="0"/>
+                        <a:ea typeface="Helvetica Neue" charset="0"/>
+                        <a:cs typeface="Helvetica Neue" charset="0"/>
                       </a:endParaRPr>
                     </a:p>
                   </a:txBody>
@@ -7980,16 +7746,16 @@
                           <a:solidFill>
                             <a:srgbClr val="0F172A"/>
                           </a:solidFill>
-                          <a:latin typeface="Calibri" pitchFamily="34" charset="0"/>
-                          <a:ea typeface="Calibri" pitchFamily="34" charset="-122"/>
-                          <a:cs typeface="Calibri" pitchFamily="34" charset="-120"/>
+                          <a:latin typeface="Helvetica Neue" pitchFamily="34" charset="0"/>
+                          <a:ea typeface="Helvetica Neue" pitchFamily="34" charset="-122"/>
+                          <a:cs typeface="Helvetica Neue" pitchFamily="34" charset="-120"/>
                         </a:rPr>
                         <a:t>Feature-distribution calibration</a:t>
                       </a:r>
                       <a:endParaRPr lang="en-US" sz="1250" dirty="0">
-                        <a:latin typeface="Calibri" charset="0"/>
-                        <a:ea typeface="Calibri" charset="0"/>
-                        <a:cs typeface="Calibri" charset="0"/>
+                        <a:latin typeface="Helvetica Neue" charset="0"/>
+                        <a:ea typeface="Helvetica Neue" charset="0"/>
+                        <a:cs typeface="Helvetica Neue" charset="0"/>
                       </a:endParaRPr>
                     </a:p>
                   </a:txBody>
@@ -8045,16 +7811,16 @@
                           <a:solidFill>
                             <a:srgbClr val="64748B"/>
                           </a:solidFill>
-                          <a:latin typeface="Calibri" pitchFamily="34" charset="0"/>
-                          <a:ea typeface="Calibri" pitchFamily="34" charset="-122"/>
-                          <a:cs typeface="Calibri" pitchFamily="34" charset="-120"/>
+                          <a:latin typeface="Helvetica Neue" pitchFamily="34" charset="0"/>
+                          <a:ea typeface="Helvetica Neue" pitchFamily="34" charset="-122"/>
+                          <a:cs typeface="Helvetica Neue" pitchFamily="34" charset="-120"/>
                         </a:rPr>
                         <a:t>—</a:t>
                       </a:r>
                       <a:endParaRPr lang="en-US" sz="1250" dirty="0">
-                        <a:latin typeface="Calibri" charset="0"/>
-                        <a:ea typeface="Calibri" charset="0"/>
-                        <a:cs typeface="Calibri" charset="0"/>
+                        <a:latin typeface="Helvetica Neue" charset="0"/>
+                        <a:ea typeface="Helvetica Neue" charset="0"/>
+                        <a:cs typeface="Helvetica Neue" charset="0"/>
                       </a:endParaRPr>
                     </a:p>
                   </a:txBody>
@@ -8110,16 +7876,16 @@
                           <a:solidFill>
                             <a:srgbClr val="0F172A"/>
                           </a:solidFill>
-                          <a:latin typeface="Calibri" pitchFamily="34" charset="0"/>
-                          <a:ea typeface="Calibri" pitchFamily="34" charset="-122"/>
-                          <a:cs typeface="Calibri" pitchFamily="34" charset="-120"/>
+                          <a:latin typeface="Helvetica Neue" pitchFamily="34" charset="0"/>
+                          <a:ea typeface="Helvetica Neue" pitchFamily="34" charset="-122"/>
+                          <a:cs typeface="Helvetica Neue" pitchFamily="34" charset="-120"/>
                         </a:rPr>
                         <a:t>scripts/analyze_eval.py</a:t>
                       </a:r>
                       <a:endParaRPr lang="en-US" sz="1250" dirty="0">
-                        <a:latin typeface="Calibri" charset="0"/>
-                        <a:ea typeface="Calibri" charset="0"/>
-                        <a:cs typeface="Calibri" charset="0"/>
+                        <a:latin typeface="Helvetica Neue" charset="0"/>
+                        <a:ea typeface="Helvetica Neue" charset="0"/>
+                        <a:cs typeface="Helvetica Neue" charset="0"/>
                       </a:endParaRPr>
                     </a:p>
                   </a:txBody>
@@ -8177,16 +7943,16 @@
                           <a:solidFill>
                             <a:srgbClr val="0F172A"/>
                           </a:solidFill>
-                          <a:latin typeface="Calibri" pitchFamily="34" charset="0"/>
-                          <a:ea typeface="Calibri" pitchFamily="34" charset="-122"/>
-                          <a:cs typeface="Calibri" pitchFamily="34" charset="-120"/>
+                          <a:latin typeface="Helvetica Neue" pitchFamily="34" charset="0"/>
+                          <a:ea typeface="Helvetica Neue" pitchFamily="34" charset="-122"/>
+                          <a:cs typeface="Helvetica Neue" pitchFamily="34" charset="-120"/>
                         </a:rPr>
                         <a:t>In-the-wild domain-gap test</a:t>
                       </a:r>
                       <a:endParaRPr lang="en-US" sz="1250" dirty="0">
-                        <a:latin typeface="Calibri" charset="0"/>
-                        <a:ea typeface="Calibri" charset="0"/>
-                        <a:cs typeface="Calibri" charset="0"/>
+                        <a:latin typeface="Helvetica Neue" charset="0"/>
+                        <a:ea typeface="Helvetica Neue" charset="0"/>
+                        <a:cs typeface="Helvetica Neue" charset="0"/>
                       </a:endParaRPr>
                     </a:p>
                   </a:txBody>
@@ -8242,16 +8008,16 @@
                           <a:solidFill>
                             <a:srgbClr val="64748B"/>
                           </a:solidFill>
-                          <a:latin typeface="Calibri" pitchFamily="34" charset="0"/>
-                          <a:ea typeface="Calibri" pitchFamily="34" charset="-122"/>
-                          <a:cs typeface="Calibri" pitchFamily="34" charset="-120"/>
+                          <a:latin typeface="Helvetica Neue" pitchFamily="34" charset="0"/>
+                          <a:ea typeface="Helvetica Neue" pitchFamily="34" charset="-122"/>
+                          <a:cs typeface="Helvetica Neue" pitchFamily="34" charset="-120"/>
                         </a:rPr>
                         <a:t>—</a:t>
                       </a:r>
                       <a:endParaRPr lang="en-US" sz="1250" dirty="0">
-                        <a:latin typeface="Calibri" charset="0"/>
-                        <a:ea typeface="Calibri" charset="0"/>
-                        <a:cs typeface="Calibri" charset="0"/>
+                        <a:latin typeface="Helvetica Neue" charset="0"/>
+                        <a:ea typeface="Helvetica Neue" charset="0"/>
+                        <a:cs typeface="Helvetica Neue" charset="0"/>
                       </a:endParaRPr>
                     </a:p>
                   </a:txBody>
@@ -8307,16 +8073,16 @@
                           <a:solidFill>
                             <a:srgbClr val="0F172A"/>
                           </a:solidFill>
-                          <a:latin typeface="Calibri" pitchFamily="34" charset="0"/>
-                          <a:ea typeface="Calibri" pitchFamily="34" charset="-122"/>
-                          <a:cs typeface="Calibri" pitchFamily="34" charset="-120"/>
+                          <a:latin typeface="Helvetica Neue" pitchFamily="34" charset="0"/>
+                          <a:ea typeface="Helvetica Neue" pitchFamily="34" charset="-122"/>
+                          <a:cs typeface="Helvetica Neue" pitchFamily="34" charset="-120"/>
                         </a:rPr>
                         <a:t>scripts/in_the_wild_test.py</a:t>
                       </a:r>
                       <a:endParaRPr lang="en-US" sz="1250" dirty="0">
-                        <a:latin typeface="Calibri" charset="0"/>
-                        <a:ea typeface="Calibri" charset="0"/>
-                        <a:cs typeface="Calibri" charset="0"/>
+                        <a:latin typeface="Helvetica Neue" charset="0"/>
+                        <a:ea typeface="Helvetica Neue" charset="0"/>
+                        <a:cs typeface="Helvetica Neue" charset="0"/>
                       </a:endParaRPr>
                     </a:p>
                   </a:txBody>
@@ -8364,45 +8130,6 @@
           </a:graphicData>
         </a:graphic>
       </p:graphicFrame>
-      <p:sp>
-        <p:nvSpPr>
-          <p:cNvPr id="7" name="Text 4"/>
-          <p:cNvSpPr/>
-          <p:nvPr/>
-        </p:nvSpPr>
-        <p:spPr>
-          <a:xfrm>
-            <a:off x="411480" y="6537960"/>
-            <a:ext cx="11338560" cy="228600"/>
-          </a:xfrm>
-          <a:prstGeom prst="rect">
-            <a:avLst/>
-          </a:prstGeom>
-          <a:noFill/>
-          <a:ln/>
-        </p:spPr>
-        <p:txBody>
-          <a:bodyPr wrap="square" lIns="0" tIns="0" rIns="0" bIns="0" rtlCol="0" anchor="ctr"/>
-          <a:lstStyle/>
-          <a:p>
-            <a:pPr algn="r" indent="0" marL="0">
-              <a:buNone/>
-            </a:pPr>
-            <a:r>
-              <a:rPr lang="en-US" sz="900" dirty="0">
-                <a:solidFill>
-                  <a:srgbClr val="64748B"/>
-                </a:solidFill>
-                <a:latin typeface="Calibri" pitchFamily="34" charset="0"/>
-                <a:ea typeface="Calibri" pitchFamily="34" charset="-122"/>
-                <a:cs typeface="Calibri" pitchFamily="34" charset="-120"/>
-              </a:rPr>
-              <a:t>VoiceGuard · 4 / 13</a:t>
-            </a:r>
-            <a:endParaRPr lang="en-US" sz="900" dirty="0"/>
-          </a:p>
-        </p:txBody>
-      </p:sp>
     </p:spTree>
   </p:cSld>
   <p:clrMapOvr>
@@ -8489,11 +8216,11 @@
                 <a:solidFill>
                   <a:srgbClr val="1E2761"/>
                 </a:solidFill>
-                <a:latin typeface="Cambria" pitchFamily="34" charset="0"/>
-                <a:ea typeface="Cambria" pitchFamily="34" charset="-122"/>
-                <a:cs typeface="Cambria" pitchFamily="34" charset="-120"/>
-              </a:rPr>
-              <a:t>Demo  —  Attack  →  Shield</a:t>
+                <a:latin typeface="Helvetica Neue" pitchFamily="34" charset="0"/>
+                <a:ea typeface="Helvetica Neue" pitchFamily="34" charset="-122"/>
+                <a:cs typeface="Helvetica Neue" pitchFamily="34" charset="-120"/>
+              </a:rPr>
+              <a:t>Live Demo  —  Attack  →  Shield</a:t>
             </a:r>
             <a:endParaRPr lang="en-US" sz="3000" dirty="0"/>
           </a:p>
@@ -8528,11 +8255,11 @@
                 <a:solidFill>
                   <a:srgbClr val="64748B"/>
                 </a:solidFill>
-                <a:latin typeface="Calibri" pitchFamily="34" charset="0"/>
-                <a:ea typeface="Calibri" pitchFamily="34" charset="-122"/>
-                <a:cs typeface="Calibri" pitchFamily="34" charset="-120"/>
-              </a:rPr>
-              <a:t>Rubric: 5 pts (Results)</a:t>
+                <a:latin typeface="Helvetica Neue" pitchFamily="34" charset="0"/>
+                <a:ea typeface="Helvetica Neue" pitchFamily="34" charset="-122"/>
+                <a:cs typeface="Helvetica Neue" pitchFamily="34" charset="-120"/>
+              </a:rPr>
+              <a:t>Live Demo</a:t>
             </a:r>
             <a:endParaRPr lang="en-US" sz="1100" dirty="0"/>
           </a:p>
@@ -8640,9 +8367,9 @@
                 <a:solidFill>
                   <a:srgbClr val="FFFFFF"/>
                 </a:solidFill>
-                <a:latin typeface="Cambria" pitchFamily="34" charset="0"/>
-                <a:ea typeface="Cambria" pitchFamily="34" charset="-122"/>
-                <a:cs typeface="Cambria" pitchFamily="34" charset="-120"/>
+                <a:latin typeface="Helvetica Neue" pitchFamily="34" charset="0"/>
+                <a:ea typeface="Helvetica Neue" pitchFamily="34" charset="-122"/>
+                <a:cs typeface="Helvetica Neue" pitchFamily="34" charset="-120"/>
               </a:rPr>
               <a:t>1.  Upload</a:t>
             </a:r>
@@ -8679,9 +8406,9 @@
                 <a:solidFill>
                   <a:srgbClr val="0F172A"/>
                 </a:solidFill>
-                <a:latin typeface="Calibri" pitchFamily="34" charset="0"/>
-                <a:ea typeface="Calibri" pitchFamily="34" charset="-122"/>
-                <a:cs typeface="Calibri" pitchFamily="34" charset="-120"/>
+                <a:latin typeface="Helvetica Neue" pitchFamily="34" charset="0"/>
+                <a:ea typeface="Helvetica Neue" pitchFamily="34" charset="-122"/>
+                <a:cs typeface="Helvetica Neue" pitchFamily="34" charset="-120"/>
               </a:rPr>
               <a:t>10-second</a:t>
             </a:r>
@@ -8696,9 +8423,9 @@
                 <a:solidFill>
                   <a:srgbClr val="0F172A"/>
                 </a:solidFill>
-                <a:latin typeface="Calibri" pitchFamily="34" charset="0"/>
-                <a:ea typeface="Calibri" pitchFamily="34" charset="-122"/>
-                <a:cs typeface="Calibri" pitchFamily="34" charset="-120"/>
+                <a:latin typeface="Helvetica Neue" pitchFamily="34" charset="0"/>
+                <a:ea typeface="Helvetica Neue" pitchFamily="34" charset="-122"/>
+                <a:cs typeface="Helvetica Neue" pitchFamily="34" charset="-120"/>
               </a:rPr>
               <a:t>reference clip</a:t>
             </a:r>
@@ -8785,9 +8512,9 @@
                 <a:solidFill>
                   <a:srgbClr val="FFFFFF"/>
                 </a:solidFill>
-                <a:latin typeface="Cambria" pitchFamily="34" charset="0"/>
-                <a:ea typeface="Cambria" pitchFamily="34" charset="-122"/>
-                <a:cs typeface="Cambria" pitchFamily="34" charset="-120"/>
+                <a:latin typeface="Helvetica Neue" pitchFamily="34" charset="0"/>
+                <a:ea typeface="Helvetica Neue" pitchFamily="34" charset="-122"/>
+                <a:cs typeface="Helvetica Neue" pitchFamily="34" charset="-120"/>
               </a:rPr>
               <a:t>2.  Clone</a:t>
             </a:r>
@@ -8824,9 +8551,9 @@
                 <a:solidFill>
                   <a:srgbClr val="0F172A"/>
                 </a:solidFill>
-                <a:latin typeface="Calibri" pitchFamily="34" charset="0"/>
-                <a:ea typeface="Calibri" pitchFamily="34" charset="-122"/>
-                <a:cs typeface="Calibri" pitchFamily="34" charset="-120"/>
+                <a:latin typeface="Helvetica Neue" pitchFamily="34" charset="0"/>
+                <a:ea typeface="Helvetica Neue" pitchFamily="34" charset="-122"/>
+                <a:cs typeface="Helvetica Neue" pitchFamily="34" charset="-120"/>
               </a:rPr>
               <a:t>OpenVoice v2</a:t>
             </a:r>
@@ -8841,9 +8568,9 @@
                 <a:solidFill>
                   <a:srgbClr val="0F172A"/>
                 </a:solidFill>
-                <a:latin typeface="Calibri" pitchFamily="34" charset="0"/>
-                <a:ea typeface="Calibri" pitchFamily="34" charset="-122"/>
-                <a:cs typeface="Calibri" pitchFamily="34" charset="-120"/>
+                <a:latin typeface="Helvetica Neue" pitchFamily="34" charset="0"/>
+                <a:ea typeface="Helvetica Neue" pitchFamily="34" charset="-122"/>
+                <a:cs typeface="Helvetica Neue" pitchFamily="34" charset="-120"/>
               </a:rPr>
               <a:t>generates cloned .wav</a:t>
             </a:r>
@@ -8930,9 +8657,9 @@
                 <a:solidFill>
                   <a:srgbClr val="FFFFFF"/>
                 </a:solidFill>
-                <a:latin typeface="Cambria" pitchFamily="34" charset="0"/>
-                <a:ea typeface="Cambria" pitchFamily="34" charset="-122"/>
-                <a:cs typeface="Cambria" pitchFamily="34" charset="-120"/>
+                <a:latin typeface="Helvetica Neue" pitchFamily="34" charset="0"/>
+                <a:ea typeface="Helvetica Neue" pitchFamily="34" charset="-122"/>
+                <a:cs typeface="Helvetica Neue" pitchFamily="34" charset="-120"/>
               </a:rPr>
               <a:t>3.  Send to Shield</a:t>
             </a:r>
@@ -8969,9 +8696,9 @@
                 <a:solidFill>
                   <a:srgbClr val="0F172A"/>
                 </a:solidFill>
-                <a:latin typeface="Calibri" pitchFamily="34" charset="0"/>
-                <a:ea typeface="Calibri" pitchFamily="34" charset="-122"/>
-                <a:cs typeface="Calibri" pitchFamily="34" charset="-120"/>
+                <a:latin typeface="Helvetica Neue" pitchFamily="34" charset="0"/>
+                <a:ea typeface="Helvetica Neue" pitchFamily="34" charset="-122"/>
+                <a:cs typeface="Helvetica Neue" pitchFamily="34" charset="-120"/>
               </a:rPr>
               <a:t>single-click</a:t>
             </a:r>
@@ -8986,9 +8713,9 @@
                 <a:solidFill>
                   <a:srgbClr val="0F172A"/>
                 </a:solidFill>
-                <a:latin typeface="Calibri" pitchFamily="34" charset="0"/>
-                <a:ea typeface="Calibri" pitchFamily="34" charset="-122"/>
-                <a:cs typeface="Calibri" pitchFamily="34" charset="-120"/>
+                <a:latin typeface="Helvetica Neue" pitchFamily="34" charset="0"/>
+                <a:ea typeface="Helvetica Neue" pitchFamily="34" charset="-122"/>
+                <a:cs typeface="Helvetica Neue" pitchFamily="34" charset="-120"/>
               </a:rPr>
               <a:t>hand-off</a:t>
             </a:r>
@@ -9075,9 +8802,9 @@
                 <a:solidFill>
                   <a:srgbClr val="FFFFFF"/>
                 </a:solidFill>
-                <a:latin typeface="Cambria" pitchFamily="34" charset="0"/>
-                <a:ea typeface="Cambria" pitchFamily="34" charset="-122"/>
-                <a:cs typeface="Cambria" pitchFamily="34" charset="-120"/>
+                <a:latin typeface="Helvetica Neue" pitchFamily="34" charset="0"/>
+                <a:ea typeface="Helvetica Neue" pitchFamily="34" charset="-122"/>
+                <a:cs typeface="Helvetica Neue" pitchFamily="34" charset="-120"/>
               </a:rPr>
               <a:t>4.  Verdict</a:t>
             </a:r>
@@ -9114,9 +8841,9 @@
                 <a:solidFill>
                   <a:srgbClr val="0F172A"/>
                 </a:solidFill>
-                <a:latin typeface="Calibri" pitchFamily="34" charset="0"/>
-                <a:ea typeface="Calibri" pitchFamily="34" charset="-122"/>
-                <a:cs typeface="Calibri" pitchFamily="34" charset="-120"/>
+                <a:latin typeface="Helvetica Neue" pitchFamily="34" charset="0"/>
+                <a:ea typeface="Helvetica Neue" pitchFamily="34" charset="-122"/>
+                <a:cs typeface="Helvetica Neue" pitchFamily="34" charset="-120"/>
               </a:rPr>
               <a:t>FAKE</a:t>
             </a:r>
@@ -9131,9 +8858,9 @@
                 <a:solidFill>
                   <a:srgbClr val="0F172A"/>
                 </a:solidFill>
-                <a:latin typeface="Calibri" pitchFamily="34" charset="0"/>
-                <a:ea typeface="Calibri" pitchFamily="34" charset="-122"/>
-                <a:cs typeface="Calibri" pitchFamily="34" charset="-120"/>
+                <a:latin typeface="Helvetica Neue" pitchFamily="34" charset="0"/>
+                <a:ea typeface="Helvetica Neue" pitchFamily="34" charset="-122"/>
+                <a:cs typeface="Helvetica Neue" pitchFamily="34" charset="-120"/>
               </a:rPr>
               <a:t>@  99.97 %</a:t>
             </a:r>
@@ -9195,9 +8922,9 @@
                 <a:solidFill>
                   <a:srgbClr val="CADCFC"/>
                 </a:solidFill>
-                <a:latin typeface="Calibri" pitchFamily="34" charset="0"/>
-                <a:ea typeface="Calibri" pitchFamily="34" charset="-122"/>
-                <a:cs typeface="Calibri" pitchFamily="34" charset="-120"/>
+                <a:latin typeface="Helvetica Neue" pitchFamily="34" charset="0"/>
+                <a:ea typeface="Helvetica Neue" pitchFamily="34" charset="-122"/>
+                <a:cs typeface="Helvetica Neue" pitchFamily="34" charset="-120"/>
               </a:rPr>
               <a:t>LIVE DEMO  ·  end-to-end  &lt;  30 s</a:t>
             </a:r>
@@ -9234,9 +8961,9 @@
                 <a:solidFill>
                   <a:srgbClr val="FFFFFF"/>
                 </a:solidFill>
-                <a:latin typeface="Calibri" pitchFamily="34" charset="0"/>
-                <a:ea typeface="Calibri" pitchFamily="34" charset="-122"/>
-                <a:cs typeface="Calibri" pitchFamily="34" charset="-120"/>
+                <a:latin typeface="Helvetica Neue" pitchFamily="34" charset="0"/>
+                <a:ea typeface="Helvetica Neue" pitchFamily="34" charset="-122"/>
+                <a:cs typeface="Helvetica Neue" pitchFamily="34" charset="-120"/>
               </a:rPr>
               <a:t>Attack:  </a:t>
             </a:r>
@@ -9251,9 +8978,9 @@
                 <a:solidFill>
                   <a:srgbClr val="CADCFC"/>
                 </a:solidFill>
-                <a:latin typeface="Calibri" pitchFamily="34" charset="0"/>
-                <a:ea typeface="Calibri" pitchFamily="34" charset="-122"/>
-                <a:cs typeface="Calibri" pitchFamily="34" charset="-120"/>
+                <a:latin typeface="Helvetica Neue" pitchFamily="34" charset="0"/>
+                <a:ea typeface="Helvetica Neue" pitchFamily="34" charset="-122"/>
+                <a:cs typeface="Helvetica Neue" pitchFamily="34" charset="-120"/>
               </a:rPr>
               <a:t>Upload → Clone &amp; Speak → cloned audio + similarity score</a:t>
             </a:r>
@@ -9268,9 +8995,9 @@
                 <a:solidFill>
                   <a:srgbClr val="FFFFFF"/>
                 </a:solidFill>
-                <a:latin typeface="Calibri" pitchFamily="34" charset="0"/>
-                <a:ea typeface="Calibri" pitchFamily="34" charset="-122"/>
-                <a:cs typeface="Calibri" pitchFamily="34" charset="-120"/>
+                <a:latin typeface="Helvetica Neue" pitchFamily="34" charset="0"/>
+                <a:ea typeface="Helvetica Neue" pitchFamily="34" charset="-122"/>
+                <a:cs typeface="Helvetica Neue" pitchFamily="34" charset="-120"/>
               </a:rPr>
               <a:t>Shield:  </a:t>
             </a:r>
@@ -9282,9 +9009,9 @@
                 <a:solidFill>
                   <a:srgbClr val="CADCFC"/>
                 </a:solidFill>
-                <a:latin typeface="Calibri" pitchFamily="34" charset="0"/>
-                <a:ea typeface="Calibri" pitchFamily="34" charset="-122"/>
-                <a:cs typeface="Calibri" pitchFamily="34" charset="-120"/>
+                <a:latin typeface="Helvetica Neue" pitchFamily="34" charset="0"/>
+                <a:ea typeface="Helvetica Neue" pitchFamily="34" charset="-122"/>
+                <a:cs typeface="Helvetica Neue" pitchFamily="34" charset="-120"/>
               </a:rPr>
               <a:t>Send to Shield → verdict  FAKE @ 99.97 %  + attention heatmap highlighting artifact bands</a:t>
             </a:r>
@@ -9321,52 +9048,13 @@
                 <a:solidFill>
                   <a:srgbClr val="64748B"/>
                 </a:solidFill>
-                <a:latin typeface="Calibri" pitchFamily="34" charset="0"/>
-                <a:ea typeface="Calibri" pitchFamily="34" charset="-122"/>
-                <a:cs typeface="Calibri" pitchFamily="34" charset="-120"/>
+                <a:latin typeface="Helvetica Neue" pitchFamily="34" charset="0"/>
+                <a:ea typeface="Helvetica Neue" pitchFamily="34" charset="-122"/>
+                <a:cs typeface="Helvetica Neue" pitchFamily="34" charset="-120"/>
               </a:rPr>
               <a:t>Demo recording available  ·  fallback if live demo fails</a:t>
             </a:r>
             <a:endParaRPr lang="en-US" sz="1100" dirty="0"/>
-          </a:p>
-        </p:txBody>
-      </p:sp>
-      <p:sp>
-        <p:nvSpPr>
-          <p:cNvPr id="26" name="Text 24"/>
-          <p:cNvSpPr/>
-          <p:nvPr/>
-        </p:nvSpPr>
-        <p:spPr>
-          <a:xfrm>
-            <a:off x="411480" y="6537960"/>
-            <a:ext cx="11338560" cy="228600"/>
-          </a:xfrm>
-          <a:prstGeom prst="rect">
-            <a:avLst/>
-          </a:prstGeom>
-          <a:noFill/>
-          <a:ln/>
-        </p:spPr>
-        <p:txBody>
-          <a:bodyPr wrap="square" lIns="0" tIns="0" rIns="0" bIns="0" rtlCol="0" anchor="ctr"/>
-          <a:lstStyle/>
-          <a:p>
-            <a:pPr algn="r" indent="0" marL="0">
-              <a:buNone/>
-            </a:pPr>
-            <a:r>
-              <a:rPr lang="en-US" sz="900" dirty="0">
-                <a:solidFill>
-                  <a:srgbClr val="64748B"/>
-                </a:solidFill>
-                <a:latin typeface="Calibri" pitchFamily="34" charset="0"/>
-                <a:ea typeface="Calibri" pitchFamily="34" charset="-122"/>
-                <a:cs typeface="Calibri" pitchFamily="34" charset="-120"/>
-              </a:rPr>
-              <a:t>VoiceGuard · 5 / 13</a:t>
-            </a:r>
-            <a:endParaRPr lang="en-US" sz="900" dirty="0"/>
           </a:p>
         </p:txBody>
       </p:sp>
@@ -9456,9 +9144,9 @@
                 <a:solidFill>
                   <a:srgbClr val="1E2761"/>
                 </a:solidFill>
-                <a:latin typeface="Cambria" pitchFamily="34" charset="0"/>
-                <a:ea typeface="Cambria" pitchFamily="34" charset="-122"/>
-                <a:cs typeface="Cambria" pitchFamily="34" charset="-120"/>
+                <a:latin typeface="Helvetica Neue" pitchFamily="34" charset="0"/>
+                <a:ea typeface="Helvetica Neue" pitchFamily="34" charset="-122"/>
+                <a:cs typeface="Helvetica Neue" pitchFamily="34" charset="-120"/>
               </a:rPr>
               <a:t>Results  —  ASVspoof 2019 LA  (full eval)</a:t>
             </a:r>
@@ -9495,11 +9183,11 @@
                 <a:solidFill>
                   <a:srgbClr val="64748B"/>
                 </a:solidFill>
-                <a:latin typeface="Calibri" pitchFamily="34" charset="0"/>
-                <a:ea typeface="Calibri" pitchFamily="34" charset="-122"/>
-                <a:cs typeface="Calibri" pitchFamily="34" charset="-120"/>
-              </a:rPr>
-              <a:t>Rubric: 5 pts (Results)</a:t>
+                <a:latin typeface="Helvetica Neue" pitchFamily="34" charset="0"/>
+                <a:ea typeface="Helvetica Neue" pitchFamily="34" charset="-122"/>
+                <a:cs typeface="Helvetica Neue" pitchFamily="34" charset="-120"/>
+              </a:rPr>
+              <a:t>Results</a:t>
             </a:r>
             <a:endParaRPr lang="en-US" sz="1100" dirty="0"/>
           </a:p>
@@ -9530,7 +9218,7 @@
       </p:sp>
       <p:pic>
         <p:nvPicPr>
-          <p:cNvPr id="6" name="Image 0" descr="/Users/jerryzeng/Documents/Voice Guard/.claude/worktrees/angry-wilson-c6077d/scripts/output/asvspoof_eval/full/confusion_matrix.png">    </p:cNvPr>
+          <p:cNvPr id="6" name="Image 0" descr="/Users/jerryzeng/Documents/Voice Guard/scripts/output/asvspoof_eval/full/confusion_matrix.png">    </p:cNvPr>
           <p:cNvPicPr>
             <a:picLocks noChangeAspect="1"/>
           </p:cNvPicPr>
@@ -9631,9 +9319,9 @@
                 <a:solidFill>
                   <a:srgbClr val="1E2761"/>
                 </a:solidFill>
-                <a:latin typeface="Cambria" pitchFamily="34" charset="0"/>
-                <a:ea typeface="Cambria" pitchFamily="34" charset="-122"/>
-                <a:cs typeface="Cambria" pitchFamily="34" charset="-120"/>
+                <a:latin typeface="Helvetica Neue" pitchFamily="34" charset="0"/>
+                <a:ea typeface="Helvetica Neue" pitchFamily="34" charset="-122"/>
+                <a:cs typeface="Helvetica Neue" pitchFamily="34" charset="-120"/>
               </a:rPr>
               <a:t>0.146 %</a:t>
             </a:r>
@@ -9670,9 +9358,9 @@
                 <a:solidFill>
                   <a:srgbClr val="64748B"/>
                 </a:solidFill>
-                <a:latin typeface="Calibri" pitchFamily="34" charset="0"/>
-                <a:ea typeface="Calibri" pitchFamily="34" charset="-122"/>
-                <a:cs typeface="Calibri" pitchFamily="34" charset="-120"/>
+                <a:latin typeface="Helvetica Neue" pitchFamily="34" charset="0"/>
+                <a:ea typeface="Helvetica Neue" pitchFamily="34" charset="-122"/>
+                <a:cs typeface="Helvetica Neue" pitchFamily="34" charset="-120"/>
               </a:rPr>
               <a:t>EER  (paper reports ~0.7 %)</a:t>
             </a:r>
@@ -9759,9 +9447,9 @@
                 <a:solidFill>
                   <a:srgbClr val="1E2761"/>
                 </a:solidFill>
-                <a:latin typeface="Cambria" pitchFamily="34" charset="0"/>
-                <a:ea typeface="Cambria" pitchFamily="34" charset="-122"/>
-                <a:cs typeface="Cambria" pitchFamily="34" charset="-120"/>
+                <a:latin typeface="Helvetica Neue" pitchFamily="34" charset="0"/>
+                <a:ea typeface="Helvetica Neue" pitchFamily="34" charset="-122"/>
+                <a:cs typeface="Helvetica Neue" pitchFamily="34" charset="-120"/>
               </a:rPr>
               <a:t>99.77 %</a:t>
             </a:r>
@@ -9798,9 +9486,9 @@
                 <a:solidFill>
                   <a:srgbClr val="64748B"/>
                 </a:solidFill>
-                <a:latin typeface="Calibri" pitchFamily="34" charset="0"/>
-                <a:ea typeface="Calibri" pitchFamily="34" charset="-122"/>
-                <a:cs typeface="Calibri" pitchFamily="34" charset="-120"/>
+                <a:latin typeface="Helvetica Neue" pitchFamily="34" charset="0"/>
+                <a:ea typeface="Helvetica Neue" pitchFamily="34" charset="-122"/>
+                <a:cs typeface="Helvetica Neue" pitchFamily="34" charset="-120"/>
               </a:rPr>
               <a:t>Overall Accuracy</a:t>
             </a:r>
@@ -9887,9 +9575,9 @@
                 <a:solidFill>
                   <a:srgbClr val="2E8B8B"/>
                 </a:solidFill>
-                <a:latin typeface="Cambria" pitchFamily="34" charset="0"/>
-                <a:ea typeface="Cambria" pitchFamily="34" charset="-122"/>
-                <a:cs typeface="Cambria" pitchFamily="34" charset="-120"/>
+                <a:latin typeface="Helvetica Neue" pitchFamily="34" charset="0"/>
+                <a:ea typeface="Helvetica Neue" pitchFamily="34" charset="-122"/>
+                <a:cs typeface="Helvetica Neue" pitchFamily="34" charset="-120"/>
               </a:rPr>
               <a:t>0.109 %</a:t>
             </a:r>
@@ -9926,9 +9614,9 @@
                 <a:solidFill>
                   <a:srgbClr val="64748B"/>
                 </a:solidFill>
-                <a:latin typeface="Calibri" pitchFamily="34" charset="0"/>
-                <a:ea typeface="Calibri" pitchFamily="34" charset="-122"/>
-                <a:cs typeface="Calibri" pitchFamily="34" charset="-120"/>
+                <a:latin typeface="Helvetica Neue" pitchFamily="34" charset="0"/>
+                <a:ea typeface="Helvetica Neue" pitchFamily="34" charset="-122"/>
+                <a:cs typeface="Helvetica Neue" pitchFamily="34" charset="-120"/>
               </a:rPr>
               <a:t>FPR   8 / 7,355 bonafide</a:t>
             </a:r>
@@ -10015,9 +9703,9 @@
                 <a:solidFill>
                   <a:srgbClr val="E53E3E"/>
                 </a:solidFill>
-                <a:latin typeface="Cambria" pitchFamily="34" charset="0"/>
-                <a:ea typeface="Cambria" pitchFamily="34" charset="-122"/>
-                <a:cs typeface="Cambria" pitchFamily="34" charset="-120"/>
+                <a:latin typeface="Helvetica Neue" pitchFamily="34" charset="0"/>
+                <a:ea typeface="Helvetica Neue" pitchFamily="34" charset="-122"/>
+                <a:cs typeface="Helvetica Neue" pitchFamily="34" charset="-120"/>
               </a:rPr>
               <a:t>0.244 %</a:t>
             </a:r>
@@ -10054,9 +9742,9 @@
                 <a:solidFill>
                   <a:srgbClr val="64748B"/>
                 </a:solidFill>
-                <a:latin typeface="Calibri" pitchFamily="34" charset="0"/>
-                <a:ea typeface="Calibri" pitchFamily="34" charset="-122"/>
-                <a:cs typeface="Calibri" pitchFamily="34" charset="-120"/>
+                <a:latin typeface="Helvetica Neue" pitchFamily="34" charset="0"/>
+                <a:ea typeface="Helvetica Neue" pitchFamily="34" charset="-122"/>
+                <a:cs typeface="Helvetica Neue" pitchFamily="34" charset="-120"/>
               </a:rPr>
               <a:t>FNR   156 / 63,882 spoof</a:t>
             </a:r>
@@ -10093,52 +9781,13 @@
                 <a:solidFill>
                   <a:srgbClr val="64748B"/>
                 </a:solidFill>
-                <a:latin typeface="Calibri" pitchFamily="34" charset="0"/>
-                <a:ea typeface="Calibri" pitchFamily="34" charset="-122"/>
-                <a:cs typeface="Calibri" pitchFamily="34" charset="-120"/>
+                <a:latin typeface="Helvetica Neue" pitchFamily="34" charset="0"/>
+                <a:ea typeface="Helvetica Neue" pitchFamily="34" charset="-122"/>
+                <a:cs typeface="Helvetica Neue" pitchFamily="34" charset="-120"/>
               </a:rPr>
               <a:t>N  =  71,237  ·  7,355 bonafide  +  63,882 spoof  ·  8 h 14 min on 4 CPU workers</a:t>
             </a:r>
             <a:endParaRPr lang="en-US" sz="1100" dirty="0"/>
-          </a:p>
-        </p:txBody>
-      </p:sp>
-      <p:sp>
-        <p:nvSpPr>
-          <p:cNvPr id="24" name="Text 21"/>
-          <p:cNvSpPr/>
-          <p:nvPr/>
-        </p:nvSpPr>
-        <p:spPr>
-          <a:xfrm>
-            <a:off x="411480" y="6537960"/>
-            <a:ext cx="11338560" cy="228600"/>
-          </a:xfrm>
-          <a:prstGeom prst="rect">
-            <a:avLst/>
-          </a:prstGeom>
-          <a:noFill/>
-          <a:ln/>
-        </p:spPr>
-        <p:txBody>
-          <a:bodyPr wrap="square" lIns="0" tIns="0" rIns="0" bIns="0" rtlCol="0" anchor="ctr"/>
-          <a:lstStyle/>
-          <a:p>
-            <a:pPr algn="r" indent="0" marL="0">
-              <a:buNone/>
-            </a:pPr>
-            <a:r>
-              <a:rPr lang="en-US" sz="900" dirty="0">
-                <a:solidFill>
-                  <a:srgbClr val="64748B"/>
-                </a:solidFill>
-                <a:latin typeface="Calibri" pitchFamily="34" charset="0"/>
-                <a:ea typeface="Calibri" pitchFamily="34" charset="-122"/>
-                <a:cs typeface="Calibri" pitchFamily="34" charset="-120"/>
-              </a:rPr>
-              <a:t>VoiceGuard · 6 / 13</a:t>
-            </a:r>
-            <a:endParaRPr lang="en-US" sz="900" dirty="0"/>
           </a:p>
         </p:txBody>
       </p:sp>
@@ -10228,9 +9877,9 @@
                 <a:solidFill>
                   <a:srgbClr val="1E2761"/>
                 </a:solidFill>
-                <a:latin typeface="Cambria" pitchFamily="34" charset="0"/>
-                <a:ea typeface="Cambria" pitchFamily="34" charset="-122"/>
-                <a:cs typeface="Cambria" pitchFamily="34" charset="-120"/>
+                <a:latin typeface="Helvetica Neue" pitchFamily="34" charset="0"/>
+                <a:ea typeface="Helvetica Neue" pitchFamily="34" charset="-122"/>
+                <a:cs typeface="Helvetica Neue" pitchFamily="34" charset="-120"/>
               </a:rPr>
               <a:t>Results  —  13 Deepfake Attack Types</a:t>
             </a:r>
@@ -10267,11 +9916,11 @@
                 <a:solidFill>
                   <a:srgbClr val="64748B"/>
                 </a:solidFill>
-                <a:latin typeface="Calibri" pitchFamily="34" charset="0"/>
-                <a:ea typeface="Calibri" pitchFamily="34" charset="-122"/>
-                <a:cs typeface="Calibri" pitchFamily="34" charset="-120"/>
-              </a:rPr>
-              <a:t>Rubric: 5 pts (Results)</a:t>
+                <a:latin typeface="Helvetica Neue" pitchFamily="34" charset="0"/>
+                <a:ea typeface="Helvetica Neue" pitchFamily="34" charset="-122"/>
+                <a:cs typeface="Helvetica Neue" pitchFamily="34" charset="-120"/>
+              </a:rPr>
+              <a:t>Results</a:t>
             </a:r>
             <a:endParaRPr lang="en-US" sz="1100" dirty="0"/>
           </a:p>
@@ -10302,7 +9951,7 @@
       </p:sp>
       <p:pic>
         <p:nvPicPr>
-          <p:cNvPr id="6" name="Image 0" descr="/Users/jerryzeng/Documents/Voice Guard/.claude/worktrees/angry-wilson-c6077d/scripts/output/asvspoof_eval/full/per_attack_accuracy.png">    </p:cNvPr>
+          <p:cNvPr id="6" name="Image 0" descr="/Users/jerryzeng/Documents/Voice Guard/scripts/output/asvspoof_eval/full/per_attack_accuracy.png">    </p:cNvPr>
           <p:cNvPicPr>
             <a:picLocks noChangeAspect="1"/>
           </p:cNvPicPr>
@@ -10403,9 +10052,9 @@
                 <a:solidFill>
                   <a:srgbClr val="1E2761"/>
                 </a:solidFill>
-                <a:latin typeface="Cambria" pitchFamily="34" charset="0"/>
-                <a:ea typeface="Cambria" pitchFamily="34" charset="-122"/>
-                <a:cs typeface="Cambria" pitchFamily="34" charset="-120"/>
+                <a:latin typeface="Helvetica Neue" pitchFamily="34" charset="0"/>
+                <a:ea typeface="Helvetica Neue" pitchFamily="34" charset="-122"/>
+                <a:cs typeface="Helvetica Neue" pitchFamily="34" charset="-120"/>
               </a:rPr>
               <a:t>Takeaways</a:t>
             </a:r>
@@ -10446,9 +10095,9 @@
                 <a:solidFill>
                   <a:srgbClr val="0F172A"/>
                 </a:solidFill>
-                <a:latin typeface="Calibri" pitchFamily="34" charset="0"/>
-                <a:ea typeface="Calibri" pitchFamily="34" charset="-122"/>
-                <a:cs typeface="Calibri" pitchFamily="34" charset="-120"/>
+                <a:latin typeface="Helvetica Neue" pitchFamily="34" charset="0"/>
+                <a:ea typeface="Helvetica Neue" pitchFamily="34" charset="-122"/>
+                <a:cs typeface="Helvetica Neue" pitchFamily="34" charset="-120"/>
               </a:rPr>
               <a:t>7 / 13  attacks detected at 100.0 %</a:t>
             </a:r>
@@ -10467,9 +10116,9 @@
                 <a:solidFill>
                   <a:srgbClr val="0F172A"/>
                 </a:solidFill>
-                <a:latin typeface="Calibri" pitchFamily="34" charset="0"/>
-                <a:ea typeface="Calibri" pitchFamily="34" charset="-122"/>
-                <a:cs typeface="Calibri" pitchFamily="34" charset="-120"/>
+                <a:latin typeface="Helvetica Neue" pitchFamily="34" charset="0"/>
+                <a:ea typeface="Helvetica Neue" pitchFamily="34" charset="-122"/>
+                <a:cs typeface="Helvetica Neue" pitchFamily="34" charset="-120"/>
               </a:rPr>
               <a:t>Hardest: A10 (98.5 %) — end-to-end TTS w/ WaveNet vocoder</a:t>
             </a:r>
@@ -10488,9 +10137,9 @@
                 <a:solidFill>
                   <a:srgbClr val="0F172A"/>
                 </a:solidFill>
-                <a:latin typeface="Calibri" pitchFamily="34" charset="0"/>
-                <a:ea typeface="Calibri" pitchFamily="34" charset="-122"/>
-                <a:cs typeface="Calibri" pitchFamily="34" charset="-120"/>
+                <a:latin typeface="Helvetica Neue" pitchFamily="34" charset="0"/>
+                <a:ea typeface="Helvetica Neue" pitchFamily="34" charset="-122"/>
+                <a:cs typeface="Helvetica Neue" pitchFamily="34" charset="-120"/>
               </a:rPr>
               <a:t>Runner-up: A11 (99.4 %) WaveRNN, A19 (99.6 %) transfer TTS+VC</a:t>
             </a:r>
@@ -10509,9 +10158,9 @@
                 <a:solidFill>
                   <a:srgbClr val="0F172A"/>
                 </a:solidFill>
-                <a:latin typeface="Calibri" pitchFamily="34" charset="0"/>
-                <a:ea typeface="Calibri" pitchFamily="34" charset="-122"/>
-                <a:cs typeface="Calibri" pitchFamily="34" charset="-120"/>
+                <a:latin typeface="Helvetica Neue" pitchFamily="34" charset="0"/>
+                <a:ea typeface="Helvetica Neue" pitchFamily="34" charset="-122"/>
+                <a:cs typeface="Helvetica Neue" pitchFamily="34" charset="-120"/>
               </a:rPr>
               <a:t>Mean detection: 99.8 % — no attack is a systemic blind spot</a:t>
             </a:r>
@@ -10527,9 +10176,9 @@
                 <a:solidFill>
                   <a:srgbClr val="64748B"/>
                 </a:solidFill>
-                <a:latin typeface="Calibri" pitchFamily="34" charset="0"/>
-                <a:ea typeface="Calibri" pitchFamily="34" charset="-122"/>
-                <a:cs typeface="Calibri" pitchFamily="34" charset="-120"/>
+                <a:latin typeface="Helvetica Neue" pitchFamily="34" charset="0"/>
+                <a:ea typeface="Helvetica Neue" pitchFamily="34" charset="-122"/>
+                <a:cs typeface="Helvetica Neue" pitchFamily="34" charset="-120"/>
               </a:rPr>
               <a:t>Each bar ≈ 4,914 utterances</a:t>
             </a:r>
@@ -10566,52 +10215,13 @@
                 <a:solidFill>
                   <a:srgbClr val="64748B"/>
                 </a:solidFill>
-                <a:latin typeface="Calibri" pitchFamily="34" charset="0"/>
-                <a:ea typeface="Calibri" pitchFamily="34" charset="-122"/>
-                <a:cs typeface="Calibri" pitchFamily="34" charset="-120"/>
+                <a:latin typeface="Helvetica Neue" pitchFamily="34" charset="0"/>
+                <a:ea typeface="Helvetica Neue" pitchFamily="34" charset="-122"/>
+                <a:cs typeface="Helvetica Neue" pitchFamily="34" charset="-120"/>
               </a:rPr>
               <a:t>Detection generalizes across TTS, VC, and neural-vocoder synthesis methods at scale.</a:t>
             </a:r>
             <a:endParaRPr lang="en-US" sz="1200" dirty="0"/>
-          </a:p>
-        </p:txBody>
-      </p:sp>
-      <p:sp>
-        <p:nvSpPr>
-          <p:cNvPr id="12" name="Text 9"/>
-          <p:cNvSpPr/>
-          <p:nvPr/>
-        </p:nvSpPr>
-        <p:spPr>
-          <a:xfrm>
-            <a:off x="411480" y="6537960"/>
-            <a:ext cx="11338560" cy="228600"/>
-          </a:xfrm>
-          <a:prstGeom prst="rect">
-            <a:avLst/>
-          </a:prstGeom>
-          <a:noFill/>
-          <a:ln/>
-        </p:spPr>
-        <p:txBody>
-          <a:bodyPr wrap="square" lIns="0" tIns="0" rIns="0" bIns="0" rtlCol="0" anchor="ctr"/>
-          <a:lstStyle/>
-          <a:p>
-            <a:pPr algn="r" indent="0" marL="0">
-              <a:buNone/>
-            </a:pPr>
-            <a:r>
-              <a:rPr lang="en-US" sz="900" dirty="0">
-                <a:solidFill>
-                  <a:srgbClr val="64748B"/>
-                </a:solidFill>
-                <a:latin typeface="Calibri" pitchFamily="34" charset="0"/>
-                <a:ea typeface="Calibri" pitchFamily="34" charset="-122"/>
-                <a:cs typeface="Calibri" pitchFamily="34" charset="-120"/>
-              </a:rPr>
-              <a:t>VoiceGuard · 7 / 13</a:t>
-            </a:r>
-            <a:endParaRPr lang="en-US" sz="900" dirty="0"/>
           </a:p>
         </p:txBody>
       </p:sp>
@@ -10701,9 +10311,9 @@
                 <a:solidFill>
                   <a:srgbClr val="1E2761"/>
                 </a:solidFill>
-                <a:latin typeface="Cambria" pitchFamily="34" charset="0"/>
-                <a:ea typeface="Cambria" pitchFamily="34" charset="-122"/>
-                <a:cs typeface="Cambria" pitchFamily="34" charset="-120"/>
+                <a:latin typeface="Helvetica Neue" pitchFamily="34" charset="0"/>
+                <a:ea typeface="Helvetica Neue" pitchFamily="34" charset="-122"/>
+                <a:cs typeface="Helvetica Neue" pitchFamily="34" charset="-120"/>
               </a:rPr>
               <a:t>Results  —  Feature Calibration at Scale</a:t>
             </a:r>
@@ -10740,11 +10350,11 @@
                 <a:solidFill>
                   <a:srgbClr val="64748B"/>
                 </a:solidFill>
-                <a:latin typeface="Calibri" pitchFamily="34" charset="0"/>
-                <a:ea typeface="Calibri" pitchFamily="34" charset="-122"/>
-                <a:cs typeface="Calibri" pitchFamily="34" charset="-120"/>
-              </a:rPr>
-              <a:t>Rubric: 5 pts (Results)</a:t>
+                <a:latin typeface="Helvetica Neue" pitchFamily="34" charset="0"/>
+                <a:ea typeface="Helvetica Neue" pitchFamily="34" charset="-122"/>
+                <a:cs typeface="Helvetica Neue" pitchFamily="34" charset="-120"/>
+              </a:rPr>
+              <a:t>Results</a:t>
             </a:r>
             <a:endParaRPr lang="en-US" sz="1100" dirty="0"/>
           </a:p>
@@ -10775,7 +10385,7 @@
       </p:sp>
       <p:pic>
         <p:nvPicPr>
-          <p:cNvPr id="6" name="Image 0" descr="/Users/jerryzeng/Documents/Voice Guard/.claude/worktrees/angry-wilson-c6077d/scripts/output/asvspoof_eval/full/feature_distributions.png">    </p:cNvPr>
+          <p:cNvPr id="6" name="Image 0" descr="/Users/jerryzeng/Documents/Voice Guard/scripts/output/asvspoof_eval/full/feature_distributions.png">    </p:cNvPr>
           <p:cNvPicPr>
             <a:picLocks noChangeAspect="1"/>
           </p:cNvPicPr>
@@ -10876,9 +10486,9 @@
                 <a:solidFill>
                   <a:srgbClr val="64748B"/>
                 </a:solidFill>
-                <a:latin typeface="Cambria" pitchFamily="34" charset="0"/>
-                <a:ea typeface="Cambria" pitchFamily="34" charset="-122"/>
-                <a:cs typeface="Cambria" pitchFamily="34" charset="-120"/>
+                <a:latin typeface="Helvetica Neue" pitchFamily="34" charset="0"/>
+                <a:ea typeface="Helvetica Neue" pitchFamily="34" charset="-122"/>
+                <a:cs typeface="Helvetica Neue" pitchFamily="34" charset="-120"/>
               </a:rPr>
               <a:t>14</a:t>
             </a:r>
@@ -10915,9 +10525,9 @@
                 <a:solidFill>
                   <a:srgbClr val="64748B"/>
                 </a:solidFill>
-                <a:latin typeface="Calibri" pitchFamily="34" charset="0"/>
-                <a:ea typeface="Calibri" pitchFamily="34" charset="-122"/>
-                <a:cs typeface="Calibri" pitchFamily="34" charset="-120"/>
+                <a:latin typeface="Helvetica Neue" pitchFamily="34" charset="0"/>
+                <a:ea typeface="Helvetica Neue" pitchFamily="34" charset="-122"/>
+                <a:cs typeface="Helvetica Neue" pitchFamily="34" charset="-120"/>
               </a:rPr>
               <a:t>samples before</a:t>
             </a:r>
@@ -10932,9 +10542,9 @@
                 <a:solidFill>
                   <a:srgbClr val="64748B"/>
                 </a:solidFill>
-                <a:latin typeface="Calibri" pitchFamily="34" charset="0"/>
-                <a:ea typeface="Calibri" pitchFamily="34" charset="-122"/>
-                <a:cs typeface="Calibri" pitchFamily="34" charset="-120"/>
+                <a:latin typeface="Helvetica Neue" pitchFamily="34" charset="0"/>
+                <a:ea typeface="Helvetica Neue" pitchFamily="34" charset="-122"/>
+                <a:cs typeface="Helvetica Neue" pitchFamily="34" charset="-120"/>
               </a:rPr>
               <a:t>(Challenge Analysis)</a:t>
             </a:r>
@@ -11021,9 +10631,9 @@
                 <a:solidFill>
                   <a:srgbClr val="DD6B20"/>
                 </a:solidFill>
-                <a:latin typeface="Cambria" pitchFamily="34" charset="0"/>
-                <a:ea typeface="Cambria" pitchFamily="34" charset="-122"/>
-                <a:cs typeface="Cambria" pitchFamily="34" charset="-120"/>
+                <a:latin typeface="Helvetica Neue" pitchFamily="34" charset="0"/>
+                <a:ea typeface="Helvetica Neue" pitchFamily="34" charset="-122"/>
+                <a:cs typeface="Helvetica Neue" pitchFamily="34" charset="-120"/>
               </a:rPr>
               <a:t>71,237</a:t>
             </a:r>
@@ -11060,9 +10670,9 @@
                 <a:solidFill>
                   <a:srgbClr val="64748B"/>
                 </a:solidFill>
-                <a:latin typeface="Calibri" pitchFamily="34" charset="0"/>
-                <a:ea typeface="Calibri" pitchFamily="34" charset="-122"/>
-                <a:cs typeface="Calibri" pitchFamily="34" charset="-120"/>
+                <a:latin typeface="Helvetica Neue" pitchFamily="34" charset="0"/>
+                <a:ea typeface="Helvetica Neue" pitchFamily="34" charset="-122"/>
+                <a:cs typeface="Helvetica Neue" pitchFamily="34" charset="-120"/>
               </a:rPr>
               <a:t>samples now</a:t>
             </a:r>
@@ -11077,9 +10687,9 @@
                 <a:solidFill>
                   <a:srgbClr val="64748B"/>
                 </a:solidFill>
-                <a:latin typeface="Calibri" pitchFamily="34" charset="0"/>
-                <a:ea typeface="Calibri" pitchFamily="34" charset="-122"/>
-                <a:cs typeface="Calibri" pitchFamily="34" charset="-120"/>
+                <a:latin typeface="Helvetica Neue" pitchFamily="34" charset="0"/>
+                <a:ea typeface="Helvetica Neue" pitchFamily="34" charset="-122"/>
+                <a:cs typeface="Helvetica Neue" pitchFamily="34" charset="-120"/>
               </a:rPr>
               <a:t>Nearly 5,000× more</a:t>
             </a:r>
@@ -11141,9 +10751,9 @@
                 <a:solidFill>
                   <a:srgbClr val="1E2761"/>
                 </a:solidFill>
-                <a:latin typeface="Cambria" pitchFamily="34" charset="0"/>
-                <a:ea typeface="Cambria" pitchFamily="34" charset="-122"/>
-                <a:cs typeface="Cambria" pitchFamily="34" charset="-120"/>
+                <a:latin typeface="Helvetica Neue" pitchFamily="34" charset="0"/>
+                <a:ea typeface="Helvetica Neue" pitchFamily="34" charset="-122"/>
+                <a:cs typeface="Helvetica Neue" pitchFamily="34" charset="-120"/>
               </a:rPr>
               <a:t>Answers Challenge-Analysis weakness #2</a:t>
             </a:r>
@@ -11180,9 +10790,9 @@
                 <a:solidFill>
                   <a:srgbClr val="0F172A"/>
                 </a:solidFill>
-                <a:latin typeface="Calibri" pitchFamily="34" charset="0"/>
-                <a:ea typeface="Calibri" pitchFamily="34" charset="-122"/>
-                <a:cs typeface="Calibri" pitchFamily="34" charset="-120"/>
+                <a:latin typeface="Helvetica Neue" pitchFamily="34" charset="0"/>
+                <a:ea typeface="Helvetica Neue" pitchFamily="34" charset="-122"/>
+                <a:cs typeface="Helvetica Neue" pitchFamily="34" charset="-120"/>
               </a:rPr>
               <a:t>Shimmer, F0 CV, Energy CV separate cleanly — ready for UI percentile context.</a:t>
             </a:r>
@@ -11219,52 +10829,13 @@
                 <a:solidFill>
                   <a:srgbClr val="64748B"/>
                 </a:solidFill>
-                <a:latin typeface="Calibri" pitchFamily="34" charset="0"/>
-                <a:ea typeface="Calibri" pitchFamily="34" charset="-122"/>
-                <a:cs typeface="Calibri" pitchFamily="34" charset="-120"/>
+                <a:latin typeface="Helvetica Neue" pitchFamily="34" charset="0"/>
+                <a:ea typeface="Helvetica Neue" pitchFamily="34" charset="-122"/>
+                <a:cs typeface="Helvetica Neue" pitchFamily="34" charset="-120"/>
               </a:rPr>
               <a:t>Violin plots: black line = median; colored region = kernel density.</a:t>
             </a:r>
             <a:endParaRPr lang="en-US" sz="1050" dirty="0"/>
-          </a:p>
-        </p:txBody>
-      </p:sp>
-      <p:sp>
-        <p:nvSpPr>
-          <p:cNvPr id="19" name="Text 16"/>
-          <p:cNvSpPr/>
-          <p:nvPr/>
-        </p:nvSpPr>
-        <p:spPr>
-          <a:xfrm>
-            <a:off x="411480" y="6537960"/>
-            <a:ext cx="11338560" cy="228600"/>
-          </a:xfrm>
-          <a:prstGeom prst="rect">
-            <a:avLst/>
-          </a:prstGeom>
-          <a:noFill/>
-          <a:ln/>
-        </p:spPr>
-        <p:txBody>
-          <a:bodyPr wrap="square" lIns="0" tIns="0" rIns="0" bIns="0" rtlCol="0" anchor="ctr"/>
-          <a:lstStyle/>
-          <a:p>
-            <a:pPr algn="r" indent="0" marL="0">
-              <a:buNone/>
-            </a:pPr>
-            <a:r>
-              <a:rPr lang="en-US" sz="900" dirty="0">
-                <a:solidFill>
-                  <a:srgbClr val="64748B"/>
-                </a:solidFill>
-                <a:latin typeface="Calibri" pitchFamily="34" charset="0"/>
-                <a:ea typeface="Calibri" pitchFamily="34" charset="-122"/>
-                <a:cs typeface="Calibri" pitchFamily="34" charset="-120"/>
-              </a:rPr>
-              <a:t>VoiceGuard · 8 / 13</a:t>
-            </a:r>
-            <a:endParaRPr lang="en-US" sz="900" dirty="0"/>
           </a:p>
         </p:txBody>
       </p:sp>
@@ -11354,9 +10925,9 @@
                 <a:solidFill>
                   <a:srgbClr val="1E2761"/>
                 </a:solidFill>
-                <a:latin typeface="Cambria" pitchFamily="34" charset="0"/>
-                <a:ea typeface="Cambria" pitchFamily="34" charset="-122"/>
-                <a:cs typeface="Cambria" pitchFamily="34" charset="-120"/>
+                <a:latin typeface="Helvetica Neue" pitchFamily="34" charset="0"/>
+                <a:ea typeface="Helvetica Neue" pitchFamily="34" charset="-122"/>
+                <a:cs typeface="Helvetica Neue" pitchFamily="34" charset="-120"/>
               </a:rPr>
               <a:t>The Gap We Found</a:t>
             </a:r>
@@ -11393,11 +10964,11 @@
                 <a:solidFill>
                   <a:srgbClr val="64748B"/>
                 </a:solidFill>
-                <a:latin typeface="Calibri" pitchFamily="34" charset="0"/>
-                <a:ea typeface="Calibri" pitchFamily="34" charset="-122"/>
-                <a:cs typeface="Calibri" pitchFamily="34" charset="-120"/>
-              </a:rPr>
-              <a:t>⭐ headline finding</a:t>
+                <a:latin typeface="Helvetica Neue" pitchFamily="34" charset="0"/>
+                <a:ea typeface="Helvetica Neue" pitchFamily="34" charset="-122"/>
+                <a:cs typeface="Helvetica Neue" pitchFamily="34" charset="-120"/>
+              </a:rPr>
+              <a:t>Results</a:t>
             </a:r>
             <a:endParaRPr lang="en-US" sz="1100" dirty="0"/>
           </a:p>
@@ -11505,9 +11076,9 @@
                 <a:solidFill>
                   <a:srgbClr val="2E8B8B"/>
                 </a:solidFill>
-                <a:latin typeface="Cambria" pitchFamily="34" charset="0"/>
-                <a:ea typeface="Cambria" pitchFamily="34" charset="-122"/>
-                <a:cs typeface="Cambria" pitchFamily="34" charset="-120"/>
+                <a:latin typeface="Helvetica Neue" pitchFamily="34" charset="0"/>
+                <a:ea typeface="Helvetica Neue" pitchFamily="34" charset="-122"/>
+                <a:cs typeface="Helvetica Neue" pitchFamily="34" charset="-120"/>
               </a:rPr>
               <a:t>0.109 %</a:t>
             </a:r>
@@ -11544,9 +11115,9 @@
                 <a:solidFill>
                   <a:srgbClr val="64748B"/>
                 </a:solidFill>
-                <a:latin typeface="Calibri" pitchFamily="34" charset="0"/>
-                <a:ea typeface="Calibri" pitchFamily="34" charset="-122"/>
-                <a:cs typeface="Calibri" pitchFamily="34" charset="-120"/>
+                <a:latin typeface="Helvetica Neue" pitchFamily="34" charset="0"/>
+                <a:ea typeface="Helvetica Neue" pitchFamily="34" charset="-122"/>
+                <a:cs typeface="Helvetica Neue" pitchFamily="34" charset="-120"/>
               </a:rPr>
               <a:t>FPR on ASVspoof 2019 LA</a:t>
             </a:r>
@@ -11561,9 +11132,9 @@
                 <a:solidFill>
                   <a:srgbClr val="64748B"/>
                 </a:solidFill>
-                <a:latin typeface="Calibri" pitchFamily="34" charset="0"/>
-                <a:ea typeface="Calibri" pitchFamily="34" charset="-122"/>
-                <a:cs typeface="Calibri" pitchFamily="34" charset="-120"/>
+                <a:latin typeface="Helvetica Neue" pitchFamily="34" charset="0"/>
+                <a:ea typeface="Helvetica Neue" pitchFamily="34" charset="-122"/>
+                <a:cs typeface="Helvetica Neue" pitchFamily="34" charset="-120"/>
               </a:rPr>
               <a:t>studio-quality, 7,355 real utterances</a:t>
             </a:r>
@@ -11650,9 +11221,9 @@
                 <a:solidFill>
                   <a:srgbClr val="E53E3E"/>
                 </a:solidFill>
-                <a:latin typeface="Cambria" pitchFamily="34" charset="0"/>
-                <a:ea typeface="Cambria" pitchFamily="34" charset="-122"/>
-                <a:cs typeface="Cambria" pitchFamily="34" charset="-120"/>
+                <a:latin typeface="Helvetica Neue" pitchFamily="34" charset="0"/>
+                <a:ea typeface="Helvetica Neue" pitchFamily="34" charset="-122"/>
+                <a:cs typeface="Helvetica Neue" pitchFamily="34" charset="-120"/>
               </a:rPr>
               <a:t>80.0 %</a:t>
             </a:r>
@@ -11689,9 +11260,9 @@
                 <a:solidFill>
                   <a:srgbClr val="64748B"/>
                 </a:solidFill>
-                <a:latin typeface="Calibri" pitchFamily="34" charset="0"/>
-                <a:ea typeface="Calibri" pitchFamily="34" charset="-122"/>
-                <a:cs typeface="Calibri" pitchFamily="34" charset="-120"/>
+                <a:latin typeface="Helvetica Neue" pitchFamily="34" charset="0"/>
+                <a:ea typeface="Helvetica Neue" pitchFamily="34" charset="-122"/>
+                <a:cs typeface="Helvetica Neue" pitchFamily="34" charset="-120"/>
               </a:rPr>
               <a:t>FPR on in-the-wild real humans</a:t>
             </a:r>
@@ -11706,9 +11277,9 @@
                 <a:solidFill>
                   <a:srgbClr val="64748B"/>
                 </a:solidFill>
-                <a:latin typeface="Calibri" pitchFamily="34" charset="0"/>
-                <a:ea typeface="Calibri" pitchFamily="34" charset="-122"/>
-                <a:cs typeface="Calibri" pitchFamily="34" charset="-120"/>
+                <a:latin typeface="Helvetica Neue" pitchFamily="34" charset="0"/>
+                <a:ea typeface="Helvetica Neue" pitchFamily="34" charset="-122"/>
+                <a:cs typeface="Helvetica Neue" pitchFamily="34" charset="-120"/>
               </a:rPr>
               <a:t>phone / laptop mic, n = 5</a:t>
             </a:r>
@@ -11770,9 +11341,9 @@
                 <a:solidFill>
                   <a:srgbClr val="DD6B20"/>
                 </a:solidFill>
-                <a:latin typeface="Cambria" pitchFamily="34" charset="0"/>
-                <a:ea typeface="Cambria" pitchFamily="34" charset="-122"/>
-                <a:cs typeface="Cambria" pitchFamily="34" charset="-120"/>
+                <a:latin typeface="Helvetica Neue" pitchFamily="34" charset="0"/>
+                <a:ea typeface="Helvetica Neue" pitchFamily="34" charset="-122"/>
+                <a:cs typeface="Helvetica Neue" pitchFamily="34" charset="-120"/>
               </a:rPr>
               <a:t>~ 730×</a:t>
             </a:r>
@@ -11809,9 +11380,9 @@
                 <a:solidFill>
                   <a:srgbClr val="FFFFFF"/>
                 </a:solidFill>
-                <a:latin typeface="Calibri" pitchFamily="34" charset="0"/>
-                <a:ea typeface="Calibri" pitchFamily="34" charset="-122"/>
-                <a:cs typeface="Calibri" pitchFamily="34" charset="-120"/>
+                <a:latin typeface="Helvetica Neue" pitchFamily="34" charset="0"/>
+                <a:ea typeface="Helvetica Neue" pitchFamily="34" charset="-122"/>
+                <a:cs typeface="Helvetica Neue" pitchFamily="34" charset="-120"/>
               </a:rPr>
               <a:t>FPR increase from benchmark → wild</a:t>
             </a:r>
@@ -11821,7 +11392,7 @@
       </p:sp>
       <p:pic>
         <p:nvPicPr>
-          <p:cNvPr id="17" name="Image 0" descr="/Users/jerryzeng/Documents/Voice Guard/.claude/worktrees/angry-wilson-c6077d/scripts/output/asvspoof_eval/domain_gap_fpr.png">    </p:cNvPr>
+          <p:cNvPr id="17" name="Image 0" descr="/Users/jerryzeng/Documents/Voice Guard/scripts/output/asvspoof_eval/domain_gap_fpr.png">    </p:cNvPr>
           <p:cNvPicPr>
             <a:picLocks noChangeAspect="1"/>
           </p:cNvPicPr>
@@ -11872,52 +11443,13 @@
                 <a:solidFill>
                   <a:srgbClr val="0F172A"/>
                 </a:solidFill>
-                <a:latin typeface="Calibri" pitchFamily="34" charset="0"/>
-                <a:ea typeface="Calibri" pitchFamily="34" charset="-122"/>
-                <a:cs typeface="Calibri" pitchFamily="34" charset="-120"/>
+                <a:latin typeface="Helvetica Neue" pitchFamily="34" charset="0"/>
+                <a:ea typeface="Helvetica Neue" pitchFamily="34" charset="-122"/>
+                <a:cs typeface="Helvetica Neue" pitchFamily="34" charset="-120"/>
               </a:rPr>
               <a:t>On its own benchmark, the model is near-perfect.  On everyday audio, 4 / 5 real humans are mis-flagged as AI.</a:t>
             </a:r>
             <a:endParaRPr lang="en-US" sz="1200" dirty="0"/>
-          </a:p>
-        </p:txBody>
-      </p:sp>
-      <p:sp>
-        <p:nvSpPr>
-          <p:cNvPr id="19" name="Text 16"/>
-          <p:cNvSpPr/>
-          <p:nvPr/>
-        </p:nvSpPr>
-        <p:spPr>
-          <a:xfrm>
-            <a:off x="411480" y="6537960"/>
-            <a:ext cx="11338560" cy="228600"/>
-          </a:xfrm>
-          <a:prstGeom prst="rect">
-            <a:avLst/>
-          </a:prstGeom>
-          <a:noFill/>
-          <a:ln/>
-        </p:spPr>
-        <p:txBody>
-          <a:bodyPr wrap="square" lIns="0" tIns="0" rIns="0" bIns="0" rtlCol="0" anchor="ctr"/>
-          <a:lstStyle/>
-          <a:p>
-            <a:pPr algn="r" indent="0" marL="0">
-              <a:buNone/>
-            </a:pPr>
-            <a:r>
-              <a:rPr lang="en-US" sz="900" dirty="0">
-                <a:solidFill>
-                  <a:srgbClr val="64748B"/>
-                </a:solidFill>
-                <a:latin typeface="Calibri" pitchFamily="34" charset="0"/>
-                <a:ea typeface="Calibri" pitchFamily="34" charset="-122"/>
-                <a:cs typeface="Calibri" pitchFamily="34" charset="-120"/>
-              </a:rPr>
-              <a:t>VoiceGuard · 9 / 13</a:t>
-            </a:r>
-            <a:endParaRPr lang="en-US" sz="900" dirty="0"/>
           </a:p>
         </p:txBody>
       </p:sp>

</xml_diff>

<commit_message>
Slides: Menlo for display numbers + speaker notes on every slide
- Big display numbers (stat callouts, '~ 730×' mega-stat) now use
  Menlo (Consolas fallback). Tabular, modern, and visually distinct
  from Helvetica Neue body text. Added charSpacing tightening.
- Removed "Demo recording available · fallback if live demo fails"
  from the Live Demo slide.
- Added speaker notes (slide.addNotes) to all 13 slides. Each note
  is phrased as what the presenter actually says on stage, timed to
  the slide's budget (30–60 s per slide). Q&A slide includes
  anticipated-question answers for the presenter's reference.

Co-Authored-By: Claude Opus 4.7 (1M context) <noreply@anthropic.com>
</commit_message>
<xml_diff>
--- a/slides/VoiceGuard - Final Presentation.pptx
+++ b/slides/VoiceGuard - Final Presentation.pptx
@@ -514,7 +514,7 @@
           <a:p>
             <a:r>
               <a:rPr lang="en-US" dirty="0"/>
-              <a:t/>
+              <a:t>Hi everyone, we're Jerry and Yuxin. Today we're presenting VoiceGuard — a single application that can both clone a voice and catch it. We built this for 14-795 this semester.</a:t>
             </a:r>
             <a:endParaRPr lang="en-US" dirty="0"/>
           </a:p>
@@ -602,7 +602,9 @@
           <a:p>
             <a:r>
               <a:rPr lang="en-US" dirty="0"/>
-              <a:t/>
+              <a:t>Our one recommended next step: domain-adaptive fine-tuning on diverse real-world speech.
+Concretely: collect at least 1,000 hours of real human audio, covering phone codecs like µ-law, Opus, GSM, consumer microphones — laptop, earbuds, headset — noisy conditions (cafés, cars, wind), and 50+ demographically diverse speakers. Pool that with ASVspoof and fine-tune W2V-AASIST end-to-end, then re-evaluate.
+Resources to think big: 1 A100-week of GPU compute, roughly 2 FTE-months for data collection and labelling, and $5–10k for microphone kits and speaker honoraria.</a:t>
             </a:r>
             <a:endParaRPr lang="en-US" dirty="0"/>
           </a:p>
@@ -690,7 +692,12 @@
           <a:p>
             <a:r>
               <a:rPr lang="en-US" dirty="0"/>
-              <a:t/>
+              <a:t>Four pieces of evidence from our own eval, all pointing to data — not model capacity — as the bottleneck.
+One: benchmark FPR is already near zero at 0.109 % on 7,355 real samples. Making the model bigger won't drive that lower.
+Two: in-the-wild FPR is 80 % — a ~730× degradation that scales with distribution mismatch, not model size.
+Three: the W2V-AASIST paper itself reports sub-1 % EER when training and test distributions match; our reproduction is 0.146 %. The architecture has plenty of capacity.
+Four: at full 71k scale, our acoustic features already separate real from fake cleanly. The signal exists in the audio — the training set just needs to look like deployment.
+Fine-tuning on diverse real speech is higher leverage than any architectural change.</a:t>
             </a:r>
             <a:endParaRPr lang="en-US" dirty="0"/>
           </a:p>
@@ -778,7 +785,12 @@
           <a:p>
             <a:r>
               <a:rPr lang="en-US" dirty="0"/>
-              <a:t/>
+              <a:t>To summarize.
+One: we built an integrated clone + detect tool with an end-to-end Attack → Shield hand-off in under 30 seconds.
+Two: we benchmarked at full 71k scale — 99.77 % accuracy, 0.109 % FPR, EER 0.146 %.
+Three: we found an 80 % FPR on in-the-wild real audio — a ~730× gap — that's the open problem.
+Four: we recommend collecting diverse real-world speech and domain-adapting the detector.
+Happy to take questions.</a:t>
             </a:r>
             <a:endParaRPr lang="en-US" dirty="0"/>
           </a:p>
@@ -866,7 +878,12 @@
           <a:p>
             <a:r>
               <a:rPr lang="en-US" dirty="0"/>
-              <a:t/>
+              <a:t>Thanks — happy to take questions.
+Things to be ready for:
+- Why ASVspoof 2019 LA rather than 2021 DF? Pretrained weights are   exactly for this benchmark; 13 attack types are clearly labelled;   paper-comparable.
+- Why only 5 in-the-wild samples? Proof of concept; a proper study   is the Future-Work dataset we just proposed.
+- Could you fine-tune in-house? The full 71k eval alone took ~8 hrs   on M4 Pro CPU; training needs GPU cluster.
+- What about the attention heatmap as explanation? Coarse — it shows   *where* the model looks but not *why*; see Challenge Analysis for   deeper discussion.</a:t>
             </a:r>
             <a:endParaRPr lang="en-US" dirty="0"/>
           </a:p>
@@ -954,7 +971,8 @@
           <a:p>
             <a:r>
               <a:rPr lang="en-US" dirty="0"/>
-              <a:t/>
+              <a:t>Our starting goal was to build one tool where anyone can clone a voice from as little as three seconds of reference audio, and detect whether an audio clip is AI-generated. Voice-cloning scams are projected at $40 billion by 2027, and there's no open-source tool today that pairs cloning and detection in one interface.
+After our Challenge Analysis, we refined this goal: not just 'does the detector work?', but 'is it calibrated and does it generalize beyond the benchmark?'. That question drives everything in the Results section.</a:t>
             </a:r>
             <a:endParaRPr lang="en-US" dirty="0"/>
           </a:p>
@@ -1042,7 +1060,8 @@
           <a:p>
             <a:r>
               <a:rPr lang="en-US" dirty="0"/>
-              <a:t/>
+              <a:t>VoiceGuard is a two-tab Gradio app. The Attack tab uses OpenVoice v2 from MyShell — it takes a short reference clip, extracts a speaker embedding, generates base speech with MeloTTS, and converts the tone color to match the target speaker.
+The Shield tab uses W2V-AASIST from Tak et al. — a wav2vec 2.0 XLSR encoder with 300 million parameters plus a graph-attention backend that classifies bonafide versus spoof. A single-click 'Send to Shield' button hands the cloned audio from Attack over to the detector. End-to-end in under 30 seconds — which we'll show live in two slides.</a:t>
             </a:r>
             <a:endParaRPr lang="en-US" dirty="0"/>
           </a:p>
@@ -1130,7 +1149,8 @@
           <a:p>
             <a:r>
               <a:rPr lang="en-US" dirty="0"/>
-              <a:t/>
+              <a:t>To be clear about what's ours and what's not: we used OpenVoice v2 and W2V-AASIST as-is with their pretrained weights — we didn't retrain either model.
+What we built from scratch is everything in bold here: the two-tab Gradio app, the Send-to-Shield workflow, the attention-heatmap overlay, the 8-feature acoustic dashboard, the dataset-wide evaluation pipeline for all 71,237 utterances, the feature-distribution calibration script, and the in-the-wild domain-gap test.</a:t>
             </a:r>
             <a:endParaRPr lang="en-US" dirty="0"/>
           </a:p>
@@ -1218,7 +1238,11 @@
           <a:p>
             <a:r>
               <a:rPr lang="en-US" dirty="0"/>
-              <a:t/>
+              <a:t>Let me show it live. [Click Clone &amp; Speak.]
+Right now OpenVoice v2 is extracting the speaker embedding from our reference clip and generating speech with MeloTTS. It takes about 15 seconds on CPU.
+[Wait for the cloned audio to appear; play it.]
+That sounds like the reference speaker saying our text. Now I click Send to Shield. [Click; switch to Shield tab.]
+And the verdict: FAKE @ 99.97 % confidence, with the attention heatmap showing which frequency bands the detector focused on.</a:t>
             </a:r>
             <a:endParaRPr lang="en-US" dirty="0"/>
           </a:p>
@@ -1306,7 +1330,9 @@
           <a:p>
             <a:r>
               <a:rPr lang="en-US" dirty="0"/>
-              <a:t/>
+              <a:t>At full scale on ASVspoof 2019 LA — that's 71,237 utterances, 7,355 bonafide plus 63,882 spoofed — here's what the detector does.
+EER is 0.146 %. Overall accuracy is 99.77 %. The false-positive rate is 0.109 % — just 8 out of 7,355 real speakers mis-flagged as fake. False-negative rate is 0.244 %.
+These numbers match what the original W2V-AASIST paper reports on this benchmark (around 0.7 % EER). So on studio-quality audio, the detector works exactly as advertised. That's the encouraging half of the story — the surprising half comes in a few slides.</a:t>
             </a:r>
             <a:endParaRPr lang="en-US" dirty="0"/>
           </a:p>
@@ -1394,7 +1420,9 @@
           <a:p>
             <a:r>
               <a:rPr lang="en-US" dirty="0"/>
-              <a:t/>
+              <a:t>Breaking the results down by attack type. We see all 13 deepfake methods in the eval set — A07 through A19, covering TTS and voice-conversion methods.
+7 of them are detected at exactly 100 %. The hardest is A10, an end-to-end TTS with a WaveNet vocoder, at 98.5 %. A11 with WaveRNN and A19 — a transfer-function TTS + VC — come in at 99.4 % and 99.6 %.
+Mean detection across all thirteen is 99.8 %. Key takeaway: no attack type is a systemic blind spot — the detector generalizes across synthesis methods.</a:t>
             </a:r>
             <a:endParaRPr lang="en-US" dirty="0"/>
           </a:p>
@@ -1482,7 +1510,9 @@
           <a:p>
             <a:r>
               <a:rPr lang="en-US" dirty="0"/>
-              <a:t/>
+              <a:t>This slide directly answers a weakness we raised in our Challenge Analysis: 'the acoustic feature values in the Shield tab have no baseline context.' Back then we had only 14 samples. Now we have 71,237.
+Looking at the violin plots for our 8 acoustic features — Shimmer, F0 CV, Energy CV, and Spectral Centroid all separate cleanly between real and fake at scale. That's enough data to support a percentile-based UI: when the user sees 'Jitter: 0.024', we can tell them that's the 87th percentile of bonafide samples.
+Weakness #2 from our Challenge Analysis is resolved.</a:t>
             </a:r>
             <a:endParaRPr lang="en-US" dirty="0"/>
           </a:p>
@@ -1570,7 +1600,9 @@
           <a:p>
             <a:r>
               <a:rPr lang="en-US" dirty="0"/>
-              <a:t/>
+              <a:t>Now here's the real finding — the headline of this project.
+On the benchmark, false-positive rate is 0.109 %. On just 5 recordings of real humans — phone and laptop microphones, people we know speaking naturally — the false-positive rate is 80 %. That's 4 out of 5 real humans mis-flagged as AI-generated.
+Roughly a 730× degradation, purely from distribution shift. The model is near-perfect on its training distribution, and catastrophic on everyday audio. This gap sets up everything that follows.</a:t>
             </a:r>
             <a:endParaRPr lang="en-US" dirty="0"/>
           </a:p>
@@ -9019,45 +9051,6 @@
           </a:p>
         </p:txBody>
       </p:sp>
-      <p:sp>
-        <p:nvSpPr>
-          <p:cNvPr id="25" name="Text 23"/>
-          <p:cNvSpPr/>
-          <p:nvPr/>
-        </p:nvSpPr>
-        <p:spPr>
-          <a:xfrm>
-            <a:off x="457200" y="5669280"/>
-            <a:ext cx="11247120" cy="365760"/>
-          </a:xfrm>
-          <a:prstGeom prst="rect">
-            <a:avLst/>
-          </a:prstGeom>
-          <a:noFill/>
-          <a:ln/>
-        </p:spPr>
-        <p:txBody>
-          <a:bodyPr wrap="square" lIns="0" tIns="0" rIns="0" bIns="0" rtlCol="0" anchor="t"/>
-          <a:lstStyle/>
-          <a:p>
-            <a:pPr algn="ctr" indent="0" marL="0">
-              <a:buNone/>
-            </a:pPr>
-            <a:r>
-              <a:rPr lang="en-US" sz="1100" i="1" dirty="0">
-                <a:solidFill>
-                  <a:srgbClr val="64748B"/>
-                </a:solidFill>
-                <a:latin typeface="Helvetica Neue" pitchFamily="34" charset="0"/>
-                <a:ea typeface="Helvetica Neue" pitchFamily="34" charset="-122"/>
-                <a:cs typeface="Helvetica Neue" pitchFamily="34" charset="-120"/>
-              </a:rPr>
-              <a:t>Demo recording available  ·  fallback if live demo fails</a:t>
-            </a:r>
-            <a:endParaRPr lang="en-US" sz="1100" dirty="0"/>
-          </a:p>
-        </p:txBody>
-      </p:sp>
     </p:spTree>
   </p:cSld>
   <p:clrMapOvr>
@@ -9315,17 +9308,17 @@
               <a:buNone/>
             </a:pPr>
             <a:r>
-              <a:rPr lang="en-US" sz="3200" b="1" dirty="0">
+              <a:rPr lang="en-US" sz="3000" b="1" spc="-100" kern="0" dirty="0">
                 <a:solidFill>
                   <a:srgbClr val="1E2761"/>
                 </a:solidFill>
-                <a:latin typeface="Helvetica Neue" pitchFamily="34" charset="0"/>
-                <a:ea typeface="Helvetica Neue" pitchFamily="34" charset="-122"/>
-                <a:cs typeface="Helvetica Neue" pitchFamily="34" charset="-120"/>
+                <a:latin typeface="Menlo" pitchFamily="34" charset="0"/>
+                <a:ea typeface="Menlo" pitchFamily="34" charset="-122"/>
+                <a:cs typeface="Menlo" pitchFamily="34" charset="-120"/>
               </a:rPr>
               <a:t>0.146 %</a:t>
             </a:r>
-            <a:endParaRPr lang="en-US" sz="3200" dirty="0"/>
+            <a:endParaRPr lang="en-US" sz="3000" dirty="0"/>
           </a:p>
         </p:txBody>
       </p:sp>
@@ -9443,17 +9436,17 @@
               <a:buNone/>
             </a:pPr>
             <a:r>
-              <a:rPr lang="en-US" sz="3200" b="1" dirty="0">
+              <a:rPr lang="en-US" sz="3000" b="1" spc="-100" kern="0" dirty="0">
                 <a:solidFill>
                   <a:srgbClr val="1E2761"/>
                 </a:solidFill>
-                <a:latin typeface="Helvetica Neue" pitchFamily="34" charset="0"/>
-                <a:ea typeface="Helvetica Neue" pitchFamily="34" charset="-122"/>
-                <a:cs typeface="Helvetica Neue" pitchFamily="34" charset="-120"/>
+                <a:latin typeface="Menlo" pitchFamily="34" charset="0"/>
+                <a:ea typeface="Menlo" pitchFamily="34" charset="-122"/>
+                <a:cs typeface="Menlo" pitchFamily="34" charset="-120"/>
               </a:rPr>
               <a:t>99.77 %</a:t>
             </a:r>
-            <a:endParaRPr lang="en-US" sz="3200" dirty="0"/>
+            <a:endParaRPr lang="en-US" sz="3000" dirty="0"/>
           </a:p>
         </p:txBody>
       </p:sp>
@@ -9571,17 +9564,17 @@
               <a:buNone/>
             </a:pPr>
             <a:r>
-              <a:rPr lang="en-US" sz="3200" b="1" dirty="0">
+              <a:rPr lang="en-US" sz="3000" b="1" spc="-100" kern="0" dirty="0">
                 <a:solidFill>
                   <a:srgbClr val="2E8B8B"/>
                 </a:solidFill>
-                <a:latin typeface="Helvetica Neue" pitchFamily="34" charset="0"/>
-                <a:ea typeface="Helvetica Neue" pitchFamily="34" charset="-122"/>
-                <a:cs typeface="Helvetica Neue" pitchFamily="34" charset="-120"/>
+                <a:latin typeface="Menlo" pitchFamily="34" charset="0"/>
+                <a:ea typeface="Menlo" pitchFamily="34" charset="-122"/>
+                <a:cs typeface="Menlo" pitchFamily="34" charset="-120"/>
               </a:rPr>
               <a:t>0.109 %</a:t>
             </a:r>
-            <a:endParaRPr lang="en-US" sz="3200" dirty="0"/>
+            <a:endParaRPr lang="en-US" sz="3000" dirty="0"/>
           </a:p>
         </p:txBody>
       </p:sp>
@@ -9699,17 +9692,17 @@
               <a:buNone/>
             </a:pPr>
             <a:r>
-              <a:rPr lang="en-US" sz="3200" b="1" dirty="0">
+              <a:rPr lang="en-US" sz="3000" b="1" spc="-100" kern="0" dirty="0">
                 <a:solidFill>
                   <a:srgbClr val="E53E3E"/>
                 </a:solidFill>
-                <a:latin typeface="Helvetica Neue" pitchFamily="34" charset="0"/>
-                <a:ea typeface="Helvetica Neue" pitchFamily="34" charset="-122"/>
-                <a:cs typeface="Helvetica Neue" pitchFamily="34" charset="-120"/>
+                <a:latin typeface="Menlo" pitchFamily="34" charset="0"/>
+                <a:ea typeface="Menlo" pitchFamily="34" charset="-122"/>
+                <a:cs typeface="Menlo" pitchFamily="34" charset="-120"/>
               </a:rPr>
               <a:t>0.244 %</a:t>
             </a:r>
-            <a:endParaRPr lang="en-US" sz="3200" dirty="0"/>
+            <a:endParaRPr lang="en-US" sz="3000" dirty="0"/>
           </a:p>
         </p:txBody>
       </p:sp>
@@ -10482,17 +10475,17 @@
               <a:buNone/>
             </a:pPr>
             <a:r>
-              <a:rPr lang="en-US" sz="3200" b="1" dirty="0">
+              <a:rPr lang="en-US" sz="3000" b="1" spc="-100" kern="0" dirty="0">
                 <a:solidFill>
                   <a:srgbClr val="64748B"/>
                 </a:solidFill>
-                <a:latin typeface="Helvetica Neue" pitchFamily="34" charset="0"/>
-                <a:ea typeface="Helvetica Neue" pitchFamily="34" charset="-122"/>
-                <a:cs typeface="Helvetica Neue" pitchFamily="34" charset="-120"/>
+                <a:latin typeface="Menlo" pitchFamily="34" charset="0"/>
+                <a:ea typeface="Menlo" pitchFamily="34" charset="-122"/>
+                <a:cs typeface="Menlo" pitchFamily="34" charset="-120"/>
               </a:rPr>
               <a:t>14</a:t>
             </a:r>
-            <a:endParaRPr lang="en-US" sz="3200" dirty="0"/>
+            <a:endParaRPr lang="en-US" sz="3000" dirty="0"/>
           </a:p>
         </p:txBody>
       </p:sp>
@@ -10627,17 +10620,17 @@
               <a:buNone/>
             </a:pPr>
             <a:r>
-              <a:rPr lang="en-US" sz="3200" b="1" dirty="0">
+              <a:rPr lang="en-US" sz="3000" b="1" spc="-100" kern="0" dirty="0">
                 <a:solidFill>
                   <a:srgbClr val="DD6B20"/>
                 </a:solidFill>
-                <a:latin typeface="Helvetica Neue" pitchFamily="34" charset="0"/>
-                <a:ea typeface="Helvetica Neue" pitchFamily="34" charset="-122"/>
-                <a:cs typeface="Helvetica Neue" pitchFamily="34" charset="-120"/>
+                <a:latin typeface="Menlo" pitchFamily="34" charset="0"/>
+                <a:ea typeface="Menlo" pitchFamily="34" charset="-122"/>
+                <a:cs typeface="Menlo" pitchFamily="34" charset="-120"/>
               </a:rPr>
               <a:t>71,237</a:t>
             </a:r>
-            <a:endParaRPr lang="en-US" sz="3200" dirty="0"/>
+            <a:endParaRPr lang="en-US" sz="3000" dirty="0"/>
           </a:p>
         </p:txBody>
       </p:sp>
@@ -11072,17 +11065,17 @@
               <a:buNone/>
             </a:pPr>
             <a:r>
-              <a:rPr lang="en-US" sz="3200" b="1" dirty="0">
+              <a:rPr lang="en-US" sz="3000" b="1" spc="-100" kern="0" dirty="0">
                 <a:solidFill>
                   <a:srgbClr val="2E8B8B"/>
                 </a:solidFill>
-                <a:latin typeface="Helvetica Neue" pitchFamily="34" charset="0"/>
-                <a:ea typeface="Helvetica Neue" pitchFamily="34" charset="-122"/>
-                <a:cs typeface="Helvetica Neue" pitchFamily="34" charset="-120"/>
+                <a:latin typeface="Menlo" pitchFamily="34" charset="0"/>
+                <a:ea typeface="Menlo" pitchFamily="34" charset="-122"/>
+                <a:cs typeface="Menlo" pitchFamily="34" charset="-120"/>
               </a:rPr>
               <a:t>0.109 %</a:t>
             </a:r>
-            <a:endParaRPr lang="en-US" sz="3200" dirty="0"/>
+            <a:endParaRPr lang="en-US" sz="3000" dirty="0"/>
           </a:p>
         </p:txBody>
       </p:sp>
@@ -11217,17 +11210,17 @@
               <a:buNone/>
             </a:pPr>
             <a:r>
-              <a:rPr lang="en-US" sz="3200" b="1" dirty="0">
+              <a:rPr lang="en-US" sz="3000" b="1" spc="-100" kern="0" dirty="0">
                 <a:solidFill>
                   <a:srgbClr val="E53E3E"/>
                 </a:solidFill>
-                <a:latin typeface="Helvetica Neue" pitchFamily="34" charset="0"/>
-                <a:ea typeface="Helvetica Neue" pitchFamily="34" charset="-122"/>
-                <a:cs typeface="Helvetica Neue" pitchFamily="34" charset="-120"/>
+                <a:latin typeface="Menlo" pitchFamily="34" charset="0"/>
+                <a:ea typeface="Menlo" pitchFamily="34" charset="-122"/>
+                <a:cs typeface="Menlo" pitchFamily="34" charset="-120"/>
               </a:rPr>
               <a:t>80.0 %</a:t>
             </a:r>
-            <a:endParaRPr lang="en-US" sz="3200" dirty="0"/>
+            <a:endParaRPr lang="en-US" sz="3000" dirty="0"/>
           </a:p>
         </p:txBody>
       </p:sp>
@@ -11337,13 +11330,13 @@
               <a:buNone/>
             </a:pPr>
             <a:r>
-              <a:rPr lang="en-US" sz="5600" b="1" dirty="0">
+              <a:rPr lang="en-US" sz="5600" b="1" spc="-200" kern="0" dirty="0">
                 <a:solidFill>
                   <a:srgbClr val="DD6B20"/>
                 </a:solidFill>
-                <a:latin typeface="Helvetica Neue" pitchFamily="34" charset="0"/>
-                <a:ea typeface="Helvetica Neue" pitchFamily="34" charset="-122"/>
-                <a:cs typeface="Helvetica Neue" pitchFamily="34" charset="-120"/>
+                <a:latin typeface="Menlo" pitchFamily="34" charset="0"/>
+                <a:ea typeface="Menlo" pitchFamily="34" charset="-122"/>
+                <a:cs typeface="Menlo" pitchFamily="34" charset="-120"/>
               </a:rPr>
               <a:t>~ 730×</a:t>
             </a:r>

</xml_diff>